<commit_message>
Fix animated deck per 8-agent slide audit
- Slide 40: mini-fiche overlay realigned to pixel-measured card bounds
- Slide 41: source chips wrapped to two rows (was overflowing slide edge),
  bold emphasis restored in Web column, section header sizing unified
- Slide 2: accent rule above title restored, lead x aligned
- Slide 4: n8n card copy reverted to artifact wording
- Slides 48-50: left-aligned like the artifact; card descriptions removed,
  number labels rescaled; logo moved bottom-left
- VB heading to 34pt matching sibling case sections
- Straight apostrophes normalized deck-wide (artifact convention)
- Media deduplicated (5.2 MB -> 3.8 MB), theme fonts set to Arial

Co-Authored-By: Claude Fable 5 <noreply@anthropic.com>
Claude-Session: https://claude.ai/code/session_01LhBsEGCwVttHSPT2zP54Mu
</commit_message>
<xml_diff>
--- a/LIA-concretement-CC-anime.pptx
+++ b/LIA-concretement-CC-anime.pptx
@@ -5759,7 +5759,7 @@
                 <a:ea typeface="Arial" pitchFamily="34" charset="-122"/>
                 <a:cs typeface="Arial" pitchFamily="34" charset="-120"/>
               </a:rPr>
-              <a:t>« On n’a pas tous le réflexe Salesforce... ni toujours le temps. »</a:t>
+              <a:t>« On n'a pas tous le réflexe Salesforce... ni toujours le temps. »</a:t>
             </a:r>
             <a:endParaRPr lang="en-US" sz="1250" dirty="0"/>
           </a:p>
@@ -6017,7 +6017,7 @@
                 <a:ea typeface="Arial" pitchFamily="34" charset="-122"/>
                 <a:cs typeface="Arial" pitchFamily="34" charset="-120"/>
               </a:rPr>
-              <a:t>« Aucun moyen d’interroger nos participations d’un coup. »</a:t>
+              <a:t>« Aucun moyen d'interroger nos participations d'un coup. »</a:t>
             </a:r>
             <a:endParaRPr lang="en-US" sz="1250" dirty="0"/>
           </a:p>
@@ -6397,7 +6397,7 @@
                 <a:ea typeface="Arial" pitchFamily="34" charset="-122"/>
                 <a:cs typeface="Arial" pitchFamily="34" charset="-120"/>
               </a:rPr>
-              <a:t>« On n’a pas tous le réflexe Salesforce... ni toujours le temps. »</a:t>
+              <a:t>« On n'a pas tous le réflexe Salesforce... ni toujours le temps. »</a:t>
             </a:r>
             <a:endParaRPr lang="en-US" sz="1250" dirty="0"/>
           </a:p>
@@ -6655,7 +6655,7 @@
                 <a:ea typeface="Arial" pitchFamily="34" charset="-122"/>
                 <a:cs typeface="Arial" pitchFamily="34" charset="-120"/>
               </a:rPr>
-              <a:t>« Aucun moyen d’interroger nos participations d’un coup. »</a:t>
+              <a:t>« Aucun moyen d'interroger nos participations d'un coup. »</a:t>
             </a:r>
             <a:endParaRPr lang="en-US" sz="1250" dirty="0"/>
           </a:p>
@@ -7150,7 +7150,7 @@
                 <a:ea typeface="Arial" pitchFamily="34" charset="-122"/>
                 <a:cs typeface="Arial" pitchFamily="34" charset="-120"/>
               </a:rPr>
-              <a:t>« On n’a pas tous le réflexe Salesforce... ni toujours le temps. »</a:t>
+              <a:t>« On n'a pas tous le réflexe Salesforce... ni toujours le temps. »</a:t>
             </a:r>
             <a:endParaRPr lang="en-US" sz="1250" dirty="0"/>
           </a:p>
@@ -7408,7 +7408,7 @@
                 <a:ea typeface="Arial" pitchFamily="34" charset="-122"/>
                 <a:cs typeface="Arial" pitchFamily="34" charset="-120"/>
               </a:rPr>
-              <a:t>« Aucun moyen d’interroger nos participations d’un coup. »</a:t>
+              <a:t>« Aucun moyen d'interroger nos participations d'un coup. »</a:t>
             </a:r>
             <a:endParaRPr lang="en-US" sz="1250" dirty="0"/>
           </a:p>
@@ -8053,7 +8053,7 @@
                 <a:ea typeface="Arial" pitchFamily="34" charset="-122"/>
                 <a:cs typeface="Arial" pitchFamily="34" charset="-120"/>
               </a:rPr>
-              <a:t>Il est 11h02, vous sortez d’un rendez-vous. Une minute de dictée dans Teams, le compte-rendu s’écrit : vous donnez votre feu vert. Demander un résumé à une IA, tout le monde sait déjà le faire. La différence est ailleurs : ici, il est rédigé directement dans </a:t>
+              <a:t>Il est 11h02, vous sortez d'un rendez-vous. Une minute de dictée dans Teams, le compte-rendu s'écrit : vous donnez votre feu vert. Demander un résumé à une IA, tout le monde sait déjà le faire. La différence est ailleurs : ici, il est rédigé directement dans </a:t>
             </a:r>
             <a:pPr indent="0" marL="0">
               <a:lnSpc>
@@ -8285,7 +8285,7 @@
                 <a:ea typeface="Arial" pitchFamily="34" charset="-122"/>
                 <a:cs typeface="Arial" pitchFamily="34" charset="-120"/>
               </a:rPr>
-              <a:t>Il est 11h02, vous sortez d’un rendez-vous. Une minute de dictée dans Teams, le compte-rendu s’écrit : vous donnez votre feu vert. Demander un résumé à une IA, tout le monde sait déjà le faire. La différence est ailleurs : ici, il est rédigé directement dans </a:t>
+              <a:t>Il est 11h02, vous sortez d'un rendez-vous. Une minute de dictée dans Teams, le compte-rendu s'écrit : vous donnez votre feu vert. Demander un résumé à une IA, tout le monde sait déjà le faire. La différence est ailleurs : ici, il est rédigé directement dans </a:t>
             </a:r>
             <a:pPr indent="0" marL="0">
               <a:lnSpc>
@@ -8811,7 +8811,7 @@
                 <a:ea typeface="Arial" pitchFamily="34" charset="-122"/>
                 <a:cs typeface="Arial" pitchFamily="34" charset="-120"/>
               </a:rPr>
-              <a:t>Il est 11h02, vous sortez d’un rendez-vous. Une minute de dictée dans Teams, le compte-rendu s’écrit : vous donnez votre feu vert. Demander un résumé à une IA, tout le monde sait déjà le faire. La différence est ailleurs : ici, il est rédigé directement dans </a:t>
+              <a:t>Il est 11h02, vous sortez d'un rendez-vous. Une minute de dictée dans Teams, le compte-rendu s'écrit : vous donnez votre feu vert. Demander un résumé à une IA, tout le monde sait déjà le faire. La différence est ailleurs : ici, il est rédigé directement dans </a:t>
             </a:r>
             <a:pPr indent="0" marL="0">
               <a:lnSpc>
@@ -9312,7 +9312,29 @@
       </p:sp>
       <p:sp>
         <p:nvSpPr>
-          <p:cNvPr id="4" name="Text 1"/>
+          <p:cNvPr id="4" name="Shape 1"/>
+          <p:cNvSpPr/>
+          <p:nvPr/>
+        </p:nvSpPr>
+        <p:spPr>
+          <a:xfrm>
+            <a:off x="548640" y="2066544"/>
+            <a:ext cx="612648" cy="41148"/>
+          </a:xfrm>
+          <a:prstGeom prst="roundRect">
+            <a:avLst>
+              <a:gd name="adj" fmla="val 44444"/>
+            </a:avLst>
+          </a:prstGeom>
+          <a:solidFill>
+            <a:srgbClr val="0488C1"/>
+          </a:solidFill>
+          <a:ln/>
+        </p:spPr>
+      </p:sp>
+      <p:sp>
+        <p:nvSpPr>
+          <p:cNvPr id="5" name="Text 2"/>
           <p:cNvSpPr/>
           <p:nvPr/>
         </p:nvSpPr>
@@ -9374,13 +9396,13 @@
       </p:sp>
       <p:sp>
         <p:nvSpPr>
-          <p:cNvPr id="5" name="Text 2"/>
-          <p:cNvSpPr/>
-          <p:nvPr/>
-        </p:nvSpPr>
-        <p:spPr>
-          <a:xfrm>
-            <a:off x="566928" y="4800600"/>
+          <p:cNvPr id="6" name="Text 3"/>
+          <p:cNvSpPr/>
+          <p:nvPr/>
+        </p:nvSpPr>
+        <p:spPr>
+          <a:xfrm>
+            <a:off x="548640" y="4800600"/>
             <a:ext cx="6035040" cy="822960"/>
           </a:xfrm>
           <a:prstGeom prst="rect">
@@ -9408,7 +9430,7 @@
                 <a:ea typeface="Arial" pitchFamily="34" charset="-122"/>
                 <a:cs typeface="Arial" pitchFamily="34" charset="-120"/>
               </a:rPr>
-              <a:t>Ce que nous avons construit en deux mois, et ce que vous pouvez installer en sortant d’ici.</a:t>
+              <a:t>Ce que nous avons construit en deux mois, et ce que vous pouvez installer en sortant d'ici.</a:t>
             </a:r>
             <a:endParaRPr lang="en-US" sz="1600" dirty="0"/>
           </a:p>
@@ -9572,7 +9594,7 @@
                 <a:ea typeface="Arial" pitchFamily="34" charset="-122"/>
                 <a:cs typeface="Arial" pitchFamily="34" charset="-120"/>
               </a:rPr>
-              <a:t>Il est 11h02, vous sortez d’un rendez-vous. Une minute de dictée dans Teams, le compte-rendu s’écrit : vous donnez votre feu vert. Demander un résumé à une IA, tout le monde sait déjà le faire. La différence est ailleurs : ici, il est rédigé directement dans </a:t>
+              <a:t>Il est 11h02, vous sortez d'un rendez-vous. Une minute de dictée dans Teams, le compte-rendu s'écrit : vous donnez votre feu vert. Demander un résumé à une IA, tout le monde sait déjà le faire. La différence est ailleurs : ici, il est rédigé directement dans </a:t>
             </a:r>
             <a:pPr indent="0" marL="0">
               <a:lnSpc>
@@ -10122,7 +10144,7 @@
                 <a:ea typeface="Arial" pitchFamily="34" charset="-122"/>
                 <a:cs typeface="Arial" pitchFamily="34" charset="-120"/>
               </a:rPr>
-              <a:t>Il est 11h02, vous sortez d’un rendez-vous. Une minute de dictée dans Teams, le compte-rendu s’écrit : vous donnez votre feu vert. Demander un résumé à une IA, tout le monde sait déjà le faire. La différence est ailleurs : ici, il est rédigé directement dans </a:t>
+              <a:t>Il est 11h02, vous sortez d'un rendez-vous. Une minute de dictée dans Teams, le compte-rendu s'écrit : vous donnez votre feu vert. Demander un résumé à une IA, tout le monde sait déjà le faire. La différence est ailleurs : ici, il est rédigé directement dans </a:t>
             </a:r>
             <a:pPr indent="0" marL="0">
               <a:lnSpc>
@@ -10672,7 +10694,7 @@
                 <a:ea typeface="Arial" pitchFamily="34" charset="-122"/>
                 <a:cs typeface="Arial" pitchFamily="34" charset="-120"/>
               </a:rPr>
-              <a:t>Il est 11h02, vous sortez d’un rendez-vous. Une minute de dictée dans Teams, le compte-rendu s’écrit : vous donnez votre feu vert. Demander un résumé à une IA, tout le monde sait déjà le faire. La différence est ailleurs : ici, il est rédigé directement dans </a:t>
+              <a:t>Il est 11h02, vous sortez d'un rendez-vous. Une minute de dictée dans Teams, le compte-rendu s'écrit : vous donnez votre feu vert. Demander un résumé à une IA, tout le monde sait déjà le faire. La différence est ailleurs : ici, il est rédigé directement dans </a:t>
             </a:r>
             <a:pPr indent="0" marL="0">
               <a:lnSpc>
@@ -11222,7 +11244,7 @@
                 <a:ea typeface="Arial" pitchFamily="34" charset="-122"/>
                 <a:cs typeface="Arial" pitchFamily="34" charset="-120"/>
               </a:rPr>
-              <a:t>Il est 11h02, vous sortez d’un rendez-vous. Une minute de dictée dans Teams, le compte-rendu s’écrit : vous donnez votre feu vert. Demander un résumé à une IA, tout le monde sait déjà le faire. La différence est ailleurs : ici, il est rédigé directement dans </a:t>
+              <a:t>Il est 11h02, vous sortez d'un rendez-vous. Une minute de dictée dans Teams, le compte-rendu s'écrit : vous donnez votre feu vert. Demander un résumé à une IA, tout le monde sait déjà le faire. La différence est ailleurs : ici, il est rédigé directement dans </a:t>
             </a:r>
             <a:pPr indent="0" marL="0">
               <a:lnSpc>
@@ -11772,7 +11794,7 @@
                 <a:ea typeface="Arial" pitchFamily="34" charset="-122"/>
                 <a:cs typeface="Arial" pitchFamily="34" charset="-120"/>
               </a:rPr>
-              <a:t>Il est 11h02, vous sortez d’un rendez-vous. Une minute de dictée dans Teams, le compte-rendu s’écrit : vous donnez votre feu vert. Demander un résumé à une IA, tout le monde sait déjà le faire. La différence est ailleurs : ici, il est rédigé directement dans </a:t>
+              <a:t>Il est 11h02, vous sortez d'un rendez-vous. Une minute de dictée dans Teams, le compte-rendu s'écrit : vous donnez votre feu vert. Demander un résumé à une IA, tout le monde sait déjà le faire. La différence est ailleurs : ici, il est rédigé directement dans </a:t>
             </a:r>
             <a:pPr indent="0" marL="0">
               <a:lnSpc>
@@ -12322,7 +12344,7 @@
                 <a:ea typeface="Arial" pitchFamily="34" charset="-122"/>
                 <a:cs typeface="Arial" pitchFamily="34" charset="-120"/>
               </a:rPr>
-              <a:t>Il est 11h02, vous sortez d’un rendez-vous. Une minute de dictée dans Teams, le compte-rendu s’écrit : vous donnez votre feu vert. Demander un résumé à une IA, tout le monde sait déjà le faire. La différence est ailleurs : ici, il est rédigé directement dans </a:t>
+              <a:t>Il est 11h02, vous sortez d'un rendez-vous. Une minute de dictée dans Teams, le compte-rendu s'écrit : vous donnez votre feu vert. Demander un résumé à une IA, tout le monde sait déjà le faire. La différence est ailleurs : ici, il est rédigé directement dans </a:t>
             </a:r>
             <a:pPr indent="0" marL="0">
               <a:lnSpc>
@@ -12872,7 +12894,7 @@
                 <a:ea typeface="Arial" pitchFamily="34" charset="-122"/>
                 <a:cs typeface="Arial" pitchFamily="34" charset="-120"/>
               </a:rPr>
-              <a:t>Il est 11h02, vous sortez d’un rendez-vous. Une minute de dictée dans Teams, le compte-rendu s’écrit : vous donnez votre feu vert. Demander un résumé à une IA, tout le monde sait déjà le faire. La différence est ailleurs : ici, il est rédigé directement dans </a:t>
+              <a:t>Il est 11h02, vous sortez d'un rendez-vous. Une minute de dictée dans Teams, le compte-rendu s'écrit : vous donnez votre feu vert. Demander un résumé à une IA, tout le monde sait déjà le faire. La différence est ailleurs : ici, il est rédigé directement dans </a:t>
             </a:r>
             <a:pPr indent="0" marL="0">
               <a:lnSpc>
@@ -13422,7 +13444,7 @@
                 <a:ea typeface="Arial" pitchFamily="34" charset="-122"/>
                 <a:cs typeface="Arial" pitchFamily="34" charset="-120"/>
               </a:rPr>
-              <a:t>Il est 11h02, vous sortez d’un rendez-vous. Une minute de dictée dans Teams, le compte-rendu s’écrit : vous donnez votre feu vert. Demander un résumé à une IA, tout le monde sait déjà le faire. La différence est ailleurs : ici, il est rédigé directement dans </a:t>
+              <a:t>Il est 11h02, vous sortez d'un rendez-vous. Une minute de dictée dans Teams, le compte-rendu s'écrit : vous donnez votre feu vert. Demander un résumé à une IA, tout le monde sait déjà le faire. La différence est ailleurs : ici, il est rédigé directement dans </a:t>
             </a:r>
             <a:pPr indent="0" marL="0">
               <a:lnSpc>
@@ -13972,7 +13994,7 @@
                 <a:ea typeface="Arial" pitchFamily="34" charset="-122"/>
                 <a:cs typeface="Arial" pitchFamily="34" charset="-120"/>
               </a:rPr>
-              <a:t>Il est 11h02, vous sortez d’un rendez-vous. Une minute de dictée dans Teams, le compte-rendu s’écrit : vous donnez votre feu vert. Demander un résumé à une IA, tout le monde sait déjà le faire. La différence est ailleurs : ici, il est rédigé directement dans </a:t>
+              <a:t>Il est 11h02, vous sortez d'un rendez-vous. Une minute de dictée dans Teams, le compte-rendu s'écrit : vous donnez votre feu vert. Demander un résumé à une IA, tout le monde sait déjà le faire. La différence est ailleurs : ici, il est rédigé directement dans </a:t>
             </a:r>
             <a:pPr indent="0" marL="0">
               <a:lnSpc>
@@ -14522,7 +14544,7 @@
                 <a:ea typeface="Arial" pitchFamily="34" charset="-122"/>
                 <a:cs typeface="Arial" pitchFamily="34" charset="-120"/>
               </a:rPr>
-              <a:t>Il est 11h02, vous sortez d’un rendez-vous. Une minute de dictée dans Teams, le compte-rendu s’écrit : vous donnez votre feu vert. Demander un résumé à une IA, tout le monde sait déjà le faire. La différence est ailleurs : ici, il est rédigé directement dans </a:t>
+              <a:t>Il est 11h02, vous sortez d'un rendez-vous. Une minute de dictée dans Teams, le compte-rendu s'écrit : vous donnez votre feu vert. Demander un résumé à une IA, tout le monde sait déjà le faire. La différence est ailleurs : ici, il est rédigé directement dans </a:t>
             </a:r>
             <a:pPr indent="0" marL="0">
               <a:lnSpc>
@@ -15194,7 +15216,7 @@
                 <a:ea typeface="Arial" pitchFamily="34" charset="-122"/>
                 <a:cs typeface="Arial" pitchFamily="34" charset="-120"/>
               </a:rPr>
-              <a:t>Il est 11h02, vous sortez d’un rendez-vous. Une minute de dictée dans Teams, le compte-rendu s’écrit : vous donnez votre feu vert. Demander un résumé à une IA, tout le monde sait déjà le faire. La différence est ailleurs : ici, il est rédigé directement dans </a:t>
+              <a:t>Il est 11h02, vous sortez d'un rendez-vous. Une minute de dictée dans Teams, le compte-rendu s'écrit : vous donnez votre feu vert. Demander un résumé à une IA, tout le monde sait déjà le faire. La différence est ailleurs : ici, il est rédigé directement dans </a:t>
             </a:r>
             <a:pPr indent="0" marL="0">
               <a:lnSpc>
@@ -15744,7 +15766,7 @@
                 <a:ea typeface="Arial" pitchFamily="34" charset="-122"/>
                 <a:cs typeface="Arial" pitchFamily="34" charset="-120"/>
               </a:rPr>
-              <a:t>Il est 11h02, vous sortez d’un rendez-vous. Une minute de dictée dans Teams, le compte-rendu s’écrit : vous donnez votre feu vert. Demander un résumé à une IA, tout le monde sait déjà le faire. La différence est ailleurs : ici, il est rédigé directement dans </a:t>
+              <a:t>Il est 11h02, vous sortez d'un rendez-vous. Une minute de dictée dans Teams, le compte-rendu s'écrit : vous donnez votre feu vert. Demander un résumé à une IA, tout le monde sait déjà le faire. La différence est ailleurs : ici, il est rédigé directement dans </a:t>
             </a:r>
             <a:pPr indent="0" marL="0">
               <a:lnSpc>
@@ -16294,7 +16316,7 @@
                 <a:ea typeface="Arial" pitchFamily="34" charset="-122"/>
                 <a:cs typeface="Arial" pitchFamily="34" charset="-120"/>
               </a:rPr>
-              <a:t>Il est 11h02, vous sortez d’un rendez-vous. Une minute de dictée dans Teams, le compte-rendu s’écrit : vous donnez votre feu vert. Demander un résumé à une IA, tout le monde sait déjà le faire. La différence est ailleurs : ici, il est rédigé directement dans </a:t>
+              <a:t>Il est 11h02, vous sortez d'un rendez-vous. Une minute de dictée dans Teams, le compte-rendu s'écrit : vous donnez votre feu vert. Demander un résumé à une IA, tout le monde sait déjà le faire. La différence est ailleurs : ici, il est rédigé directement dans </a:t>
             </a:r>
             <a:pPr indent="0" marL="0">
               <a:lnSpc>
@@ -16715,7 +16737,7 @@
                 <a:ea typeface="Arial" pitchFamily="34" charset="-122"/>
                 <a:cs typeface="Arial" pitchFamily="34" charset="-120"/>
               </a:rPr>
-              <a:t>Vous parlez, vous validez, c’est rangé.</a:t>
+              <a:t>Vous parlez, vous validez, c'est rangé.</a:t>
             </a:r>
             <a:endParaRPr lang="en-US" sz="1600" dirty="0"/>
           </a:p>
@@ -17045,7 +17067,7 @@
                 <a:ea typeface="Arial" pitchFamily="34" charset="-122"/>
                 <a:cs typeface="Arial" pitchFamily="34" charset="-120"/>
               </a:rPr>
-              <a:t>Il est 9h21, vous voyez un LP dans 20 minutes. Une phrase dans Teams : il relit d’abord tout ce que notre Salesforce sait déjà de lui, puis enrichit avec ce qui se dit dehors : </a:t>
+              <a:t>Il est 9h21, vous voyez un LP dans 20 minutes. Une phrase dans Teams : il relit d'abord tout ce que notre Salesforce sait déjà de lui, puis enrichit avec ce qui se dit dehors : </a:t>
             </a:r>
             <a:pPr indent="0" marL="0">
               <a:lnSpc>
@@ -17311,7 +17333,7 @@
                 <a:ea typeface="Arial" pitchFamily="34" charset="-122"/>
                 <a:cs typeface="Arial" pitchFamily="34" charset="-120"/>
               </a:rPr>
-              <a:t>Il est 9h21, vous voyez un LP dans 20 minutes. Une phrase dans Teams : il relit d’abord tout ce que notre Salesforce sait déjà de lui, puis enrichit avec ce qui se dit dehors : </a:t>
+              <a:t>Il est 9h21, vous voyez un LP dans 20 minutes. Une phrase dans Teams : il relit d'abord tout ce que notre Salesforce sait déjà de lui, puis enrichit avec ce qui se dit dehors : </a:t>
             </a:r>
             <a:pPr indent="0" marL="0">
               <a:lnSpc>
@@ -17930,7 +17952,7 @@
                 <a:ea typeface="Arial" pitchFamily="34" charset="-122"/>
                 <a:cs typeface="Arial" pitchFamily="34" charset="-120"/>
               </a:rPr>
-              <a:t>Il est 9h21, vous voyez un LP dans 20 minutes. Une phrase dans Teams : il relit d’abord tout ce que notre Salesforce sait déjà de lui, puis enrichit avec ce qui se dit dehors : </a:t>
+              <a:t>Il est 9h21, vous voyez un LP dans 20 minutes. Une phrase dans Teams : il relit d'abord tout ce que notre Salesforce sait déjà de lui, puis enrichit avec ce qui se dit dehors : </a:t>
             </a:r>
             <a:pPr indent="0" marL="0">
               <a:lnSpc>
@@ -18573,7 +18595,7 @@
                 <a:ea typeface="Arial" pitchFamily="34" charset="-122"/>
                 <a:cs typeface="Arial" pitchFamily="34" charset="-120"/>
               </a:rPr>
-              <a:t>Il est 9h21, vous voyez un LP dans 20 minutes. Une phrase dans Teams : il relit d’abord tout ce que notre Salesforce sait déjà de lui, puis enrichit avec ce qui se dit dehors : </a:t>
+              <a:t>Il est 9h21, vous voyez un LP dans 20 minutes. Une phrase dans Teams : il relit d'abord tout ce que notre Salesforce sait déjà de lui, puis enrichit avec ce qui se dit dehors : </a:t>
             </a:r>
             <a:pPr indent="0" marL="0">
               <a:lnSpc>
@@ -19216,7 +19238,7 @@
                 <a:ea typeface="Arial" pitchFamily="34" charset="-122"/>
                 <a:cs typeface="Arial" pitchFamily="34" charset="-120"/>
               </a:rPr>
-              <a:t>Il est 9h21, vous voyez un LP dans 20 minutes. Une phrase dans Teams : il relit d’abord tout ce que notre Salesforce sait déjà de lui, puis enrichit avec ce qui se dit dehors : </a:t>
+              <a:t>Il est 9h21, vous voyez un LP dans 20 minutes. Une phrase dans Teams : il relit d'abord tout ce que notre Salesforce sait déjà de lui, puis enrichit avec ce qui se dit dehors : </a:t>
             </a:r>
             <a:pPr indent="0" marL="0">
               <a:lnSpc>
@@ -19859,7 +19881,7 @@
                 <a:ea typeface="Arial" pitchFamily="34" charset="-122"/>
                 <a:cs typeface="Arial" pitchFamily="34" charset="-120"/>
               </a:rPr>
-              <a:t>Il est 9h21, vous voyez un LP dans 20 minutes. Une phrase dans Teams : il relit d’abord tout ce que notre Salesforce sait déjà de lui, puis enrichit avec ce qui se dit dehors : </a:t>
+              <a:t>Il est 9h21, vous voyez un LP dans 20 minutes. Une phrase dans Teams : il relit d'abord tout ce que notre Salesforce sait déjà de lui, puis enrichit avec ce qui se dit dehors : </a:t>
             </a:r>
             <a:pPr indent="0" marL="0">
               <a:lnSpc>
@@ -20860,7 +20882,7 @@
                 <a:ea typeface="Arial" pitchFamily="34" charset="-122"/>
                 <a:cs typeface="Arial" pitchFamily="34" charset="-120"/>
               </a:rPr>
-              <a:t>C'est elle qui fait dialoguer le cerveau et la bibliothèque.</a:t>
+              <a:t>C'est elle qui les fait dialoguer.</a:t>
             </a:r>
             <a:endParaRPr lang="en-US" sz="1200" dirty="0"/>
           </a:p>
@@ -21274,7 +21296,7 @@
                 <a:ea typeface="Arial" pitchFamily="34" charset="-122"/>
                 <a:cs typeface="Arial" pitchFamily="34" charset="-120"/>
               </a:rPr>
-              <a:t>Il est 9h21, vous voyez un LP dans 20 minutes. Une phrase dans Teams : il relit d’abord tout ce que notre Salesforce sait déjà de lui, puis enrichit avec ce qui se dit dehors : </a:t>
+              <a:t>Il est 9h21, vous voyez un LP dans 20 minutes. Une phrase dans Teams : il relit d'abord tout ce que notre Salesforce sait déjà de lui, puis enrichit avec ce qui se dit dehors : </a:t>
             </a:r>
             <a:pPr indent="0" marL="0">
               <a:lnSpc>
@@ -21767,12 +21789,12 @@
         </p:nvSpPr>
         <p:spPr>
           <a:xfrm>
-            <a:off x="7563518" y="1094728"/>
-            <a:ext cx="2674469" cy="5242064"/>
+            <a:off x="7346290" y="1238098"/>
+            <a:ext cx="2648102" cy="4736592"/>
           </a:xfrm>
           <a:prstGeom prst="roundRect">
             <a:avLst>
-              <a:gd name="adj" fmla="val 3077"/>
+              <a:gd name="adj" fmla="val 3108"/>
             </a:avLst>
           </a:prstGeom>
           <a:solidFill>
@@ -21801,8 +21823,8 @@
         </p:nvSpPr>
         <p:spPr>
           <a:xfrm>
-            <a:off x="7673246" y="1149592"/>
-            <a:ext cx="2455013" cy="219456"/>
+            <a:off x="7456018" y="1292962"/>
+            <a:ext cx="2428646" cy="219456"/>
           </a:xfrm>
           <a:prstGeom prst="rect">
             <a:avLst/>
@@ -21854,17 +21876,17 @@
         </p:nvSpPr>
         <p:spPr>
           <a:xfrm>
-            <a:off x="7673246" y="1405624"/>
-            <a:ext cx="2455013" cy="731520"/>
-          </a:xfrm>
-          <a:prstGeom prst="rect">
-            <a:avLst/>
-          </a:prstGeom>
-          <a:noFill/>
-          <a:ln/>
-        </p:spPr>
-        <p:txBody>
-          <a:bodyPr wrap="square" lIns="0" tIns="0" rIns="0" bIns="0" rtlCol="0" anchor="ctr"/>
+            <a:off x="7456018" y="1548994"/>
+            <a:ext cx="2428646" cy="731520"/>
+          </a:xfrm>
+          <a:prstGeom prst="rect">
+            <a:avLst/>
+          </a:prstGeom>
+          <a:noFill/>
+          <a:ln/>
+        </p:spPr>
+        <p:txBody>
+          <a:bodyPr wrap="square" lIns="0" tIns="0" rIns="0" bIns="0" rtlCol="0" anchor="t"/>
           <a:lstStyle/>
           <a:p>
             <a:pPr indent="0" marL="0">
@@ -21896,17 +21918,17 @@
         </p:nvSpPr>
         <p:spPr>
           <a:xfrm>
-            <a:off x="7673246" y="2192008"/>
-            <a:ext cx="2455013" cy="4007624"/>
-          </a:xfrm>
-          <a:prstGeom prst="rect">
-            <a:avLst/>
-          </a:prstGeom>
-          <a:noFill/>
-          <a:ln/>
-        </p:spPr>
-        <p:txBody>
-          <a:bodyPr wrap="square" lIns="0" tIns="0" rIns="0" bIns="0" rtlCol="0" anchor="ctr"/>
+            <a:off x="7456018" y="2335378"/>
+            <a:ext cx="2428646" cy="3502152"/>
+          </a:xfrm>
+          <a:prstGeom prst="rect">
+            <a:avLst/>
+          </a:prstGeom>
+          <a:noFill/>
+          <a:ln/>
+        </p:spPr>
+        <p:txBody>
+          <a:bodyPr wrap="square" lIns="0" tIns="0" rIns="0" bIns="0" rtlCol="0" anchor="t"/>
           <a:lstStyle/>
           <a:p>
             <a:pPr indent="0" marL="0">
@@ -22036,7 +22058,7 @@
             <a:r>
               <a:rPr lang="en-US" sz="550" dirty="0">
                 <a:solidFill>
-                  <a:srgbClr val="6B6D72"/>
+                  <a:srgbClr val="25262A"/>
                 </a:solidFill>
                 <a:latin typeface="Arial" pitchFamily="34" charset="0"/>
                 <a:ea typeface="Arial" pitchFamily="34" charset="-122"/>
@@ -22510,7 +22532,7 @@
               <a:buNone/>
             </a:pPr>
             <a:r>
-              <a:rPr lang="en-US" sz="950" dirty="0">
+              <a:rPr lang="en-US" sz="950" b="1" dirty="0">
                 <a:solidFill>
                   <a:srgbClr val="25262A"/>
                 </a:solidFill>
@@ -23293,7 +23315,7 @@
               <a:buNone/>
             </a:pPr>
             <a:r>
-              <a:rPr lang="en-US" sz="950" b="1" dirty="0">
+              <a:rPr lang="en-US" sz="1000" b="1" spc="100" kern="0" dirty="0">
                 <a:solidFill>
                   <a:srgbClr val="414142"/>
                 </a:solidFill>
@@ -23403,7 +23425,47 @@
                 <a:ea typeface="Arial" pitchFamily="34" charset="-122"/>
                 <a:cs typeface="Arial" pitchFamily="34" charset="-120"/>
               </a:rPr>
-              <a:t>Associé fondateur de Breizh Rebond (Rennes), premier fonds breton de retournement, créé en 2021, spécialisé dans le financement de PME en difficulté.</a:t>
+              <a:t>Associé fondateur de </a:t>
+            </a:r>
+            <a:pPr indent="0" marL="0">
+              <a:lnSpc>
+                <a:spcPts val="1250"/>
+              </a:lnSpc>
+              <a:spcAft>
+                <a:spcPts val="400"/>
+              </a:spcAft>
+              <a:buNone/>
+            </a:pPr>
+            <a:r>
+              <a:rPr lang="en-US" sz="950" b="1" dirty="0">
+                <a:solidFill>
+                  <a:srgbClr val="25262A"/>
+                </a:solidFill>
+                <a:latin typeface="Arial" pitchFamily="34" charset="0"/>
+                <a:ea typeface="Arial" pitchFamily="34" charset="-122"/>
+                <a:cs typeface="Arial" pitchFamily="34" charset="-120"/>
+              </a:rPr>
+              <a:t>Breizh Rebond</a:t>
+            </a:r>
+            <a:pPr indent="0" marL="0">
+              <a:lnSpc>
+                <a:spcPts val="1250"/>
+              </a:lnSpc>
+              <a:spcAft>
+                <a:spcPts val="400"/>
+              </a:spcAft>
+              <a:buNone/>
+            </a:pPr>
+            <a:r>
+              <a:rPr lang="en-US" sz="950" dirty="0">
+                <a:solidFill>
+                  <a:srgbClr val="25262A"/>
+                </a:solidFill>
+                <a:latin typeface="Arial" pitchFamily="34" charset="0"/>
+                <a:ea typeface="Arial" pitchFamily="34" charset="-122"/>
+                <a:cs typeface="Arial" pitchFamily="34" charset="-120"/>
+              </a:rPr>
+              <a:t> (Rennes), premier fonds breton de retournement, créé en 2021, spécialisé dans le financement de PME en difficulté.</a:t>
             </a:r>
             <a:endParaRPr lang="en-US" sz="950" dirty="0"/>
           </a:p>
@@ -23419,6 +23481,26 @@
               <a:buChar char="•"/>
             </a:pPr>
             <a:r>
+              <a:rPr lang="en-US" sz="950" b="1" dirty="0">
+                <a:solidFill>
+                  <a:srgbClr val="25262A"/>
+                </a:solidFill>
+                <a:latin typeface="Arial" pitchFamily="34" charset="0"/>
+                <a:ea typeface="Arial" pitchFamily="34" charset="-122"/>
+                <a:cs typeface="Arial" pitchFamily="34" charset="-120"/>
+              </a:rPr>
+              <a:t>46 M€ investis dans 10 PME</a:t>
+            </a:r>
+            <a:pPr indent="0" marL="0">
+              <a:lnSpc>
+                <a:spcPts val="1250"/>
+              </a:lnSpc>
+              <a:spcAft>
+                <a:spcPts val="400"/>
+              </a:spcAft>
+              <a:buNone/>
+            </a:pPr>
+            <a:r>
               <a:rPr lang="en-US" sz="950" dirty="0">
                 <a:solidFill>
                   <a:srgbClr val="25262A"/>
@@ -23427,7 +23509,7 @@
                 <a:ea typeface="Arial" pitchFamily="34" charset="-122"/>
                 <a:cs typeface="Arial" pitchFamily="34" charset="-120"/>
               </a:rPr>
-              <a:t>46 M€ investis dans 10 PME, tickets de 1 à 6 M€.</a:t>
+              <a:t>, tickets de 1 à 6 M€.</a:t>
             </a:r>
             <a:endParaRPr lang="en-US" sz="950" dirty="0"/>
           </a:p>
@@ -23451,7 +23533,47 @@
                 <a:ea typeface="Arial" pitchFamily="34" charset="-122"/>
                 <a:cs typeface="Arial" pitchFamily="34" charset="-120"/>
               </a:rPr>
-              <a:t>Prix « Best French Turnaround Investor », Private Equity Exchange 2025.</a:t>
+              <a:t>Prix </a:t>
+            </a:r>
+            <a:pPr indent="0" marL="0">
+              <a:lnSpc>
+                <a:spcPts val="1250"/>
+              </a:lnSpc>
+              <a:spcAft>
+                <a:spcPts val="400"/>
+              </a:spcAft>
+              <a:buNone/>
+            </a:pPr>
+            <a:r>
+              <a:rPr lang="en-US" sz="950" b="1" dirty="0">
+                <a:solidFill>
+                  <a:srgbClr val="25262A"/>
+                </a:solidFill>
+                <a:latin typeface="Arial" pitchFamily="34" charset="0"/>
+                <a:ea typeface="Arial" pitchFamily="34" charset="-122"/>
+                <a:cs typeface="Arial" pitchFamily="34" charset="-120"/>
+              </a:rPr>
+              <a:t>« Best French Turnaround Investor »</a:t>
+            </a:r>
+            <a:pPr indent="0" marL="0">
+              <a:lnSpc>
+                <a:spcPts val="1250"/>
+              </a:lnSpc>
+              <a:spcAft>
+                <a:spcPts val="400"/>
+              </a:spcAft>
+              <a:buNone/>
+            </a:pPr>
+            <a:r>
+              <a:rPr lang="en-US" sz="950" dirty="0">
+                <a:solidFill>
+                  <a:srgbClr val="25262A"/>
+                </a:solidFill>
+                <a:latin typeface="Arial" pitchFamily="34" charset="0"/>
+                <a:ea typeface="Arial" pitchFamily="34" charset="-122"/>
+                <a:cs typeface="Arial" pitchFamily="34" charset="-120"/>
+              </a:rPr>
+              <a:t>, Private Equity Exchange 2025.</a:t>
             </a:r>
             <a:endParaRPr lang="en-US" sz="950" dirty="0"/>
           </a:p>
@@ -23537,7 +23659,7 @@
                 <a:ea typeface="Arial" pitchFamily="34" charset="-122"/>
                 <a:cs typeface="Arial" pitchFamily="34" charset="-120"/>
               </a:rPr>
-              <a:t>Il voit les PME de l’Ouest par le bas du cycle, nous par le haut : un prescripteur autant qu’un LP.</a:t>
+              <a:t>Il voit les PME de l'Ouest par le bas du cycle, nous par le haut : un prescripteur autant qu'un LP.</a:t>
             </a:r>
             <a:endParaRPr lang="en-US" sz="950" dirty="0"/>
           </a:p>
@@ -23623,7 +23745,7 @@
                 <a:ea typeface="Arial" pitchFamily="34" charset="-122"/>
                 <a:cs typeface="Arial" pitchFamily="34" charset="-120"/>
               </a:rPr>
-              <a:t>une reprise récente s’est accompagnée de suppressions de postes. À ne pas aborder en ouverture.</a:t>
+              <a:t>une reprise récente s'est accompagnée de suppressions de postes. À ne pas aborder en ouverture.</a:t>
             </a:r>
             <a:endParaRPr lang="en-US" sz="950" dirty="0"/>
           </a:p>
@@ -23637,7 +23759,7 @@
         </p:nvSpPr>
         <p:spPr>
           <a:xfrm>
-            <a:off x="6355080" y="5596128"/>
+            <a:off x="6355080" y="5559552"/>
             <a:ext cx="859536" cy="274320"/>
           </a:xfrm>
           <a:prstGeom prst="roundRect">
@@ -23664,7 +23786,7 @@
         </p:nvSpPr>
         <p:spPr>
           <a:xfrm>
-            <a:off x="6355080" y="5596128"/>
+            <a:off x="6355080" y="5559552"/>
             <a:ext cx="859536" cy="274320"/>
           </a:xfrm>
           <a:prstGeom prst="rect">
@@ -23703,7 +23825,7 @@
         </p:nvSpPr>
         <p:spPr>
           <a:xfrm>
-            <a:off x="7306056" y="5596128"/>
+            <a:off x="7306056" y="5559552"/>
             <a:ext cx="610819" cy="274320"/>
           </a:xfrm>
           <a:prstGeom prst="roundRect">
@@ -23730,7 +23852,7 @@
         </p:nvSpPr>
         <p:spPr>
           <a:xfrm>
-            <a:off x="7306056" y="5596128"/>
+            <a:off x="7306056" y="5559552"/>
             <a:ext cx="610819" cy="274320"/>
           </a:xfrm>
           <a:prstGeom prst="rect">
@@ -23769,7 +23891,7 @@
         </p:nvSpPr>
         <p:spPr>
           <a:xfrm>
-            <a:off x="8008315" y="5596128"/>
+            <a:off x="8008315" y="5559552"/>
             <a:ext cx="1481328" cy="274320"/>
           </a:xfrm>
           <a:prstGeom prst="roundRect">
@@ -23796,7 +23918,7 @@
         </p:nvSpPr>
         <p:spPr>
           <a:xfrm>
-            <a:off x="8008315" y="5596128"/>
+            <a:off x="8008315" y="5559552"/>
             <a:ext cx="1481328" cy="274320"/>
           </a:xfrm>
           <a:prstGeom prst="rect">
@@ -23835,7 +23957,7 @@
         </p:nvSpPr>
         <p:spPr>
           <a:xfrm>
-            <a:off x="9581083" y="5596128"/>
+            <a:off x="6355080" y="5907024"/>
             <a:ext cx="735178" cy="274320"/>
           </a:xfrm>
           <a:prstGeom prst="roundRect">
@@ -23862,7 +23984,7 @@
         </p:nvSpPr>
         <p:spPr>
           <a:xfrm>
-            <a:off x="9581083" y="5596128"/>
+            <a:off x="6355080" y="5907024"/>
             <a:ext cx="735178" cy="274320"/>
           </a:xfrm>
           <a:prstGeom prst="rect">
@@ -23901,7 +24023,7 @@
         </p:nvSpPr>
         <p:spPr>
           <a:xfrm>
-            <a:off x="10407701" y="5596128"/>
+            <a:off x="7181698" y="5907024"/>
             <a:ext cx="983894" cy="274320"/>
           </a:xfrm>
           <a:prstGeom prst="roundRect">
@@ -23928,7 +24050,7 @@
         </p:nvSpPr>
         <p:spPr>
           <a:xfrm>
-            <a:off x="10407701" y="5596128"/>
+            <a:off x="7181698" y="5907024"/>
             <a:ext cx="983894" cy="274320"/>
           </a:xfrm>
           <a:prstGeom prst="rect">
@@ -23967,7 +24089,7 @@
         </p:nvSpPr>
         <p:spPr>
           <a:xfrm>
-            <a:off x="11483035" y="5596128"/>
+            <a:off x="8257032" y="5907024"/>
             <a:ext cx="1356970" cy="274320"/>
           </a:xfrm>
           <a:prstGeom prst="roundRect">
@@ -23994,7 +24116,7 @@
         </p:nvSpPr>
         <p:spPr>
           <a:xfrm>
-            <a:off x="11483035" y="5596128"/>
+            <a:off x="8257032" y="5907024"/>
             <a:ext cx="1356970" cy="274320"/>
           </a:xfrm>
           <a:prstGeom prst="rect">
@@ -24259,7 +24381,7 @@
         <p:spPr>
           <a:xfrm>
             <a:off x="548640" y="987552"/>
-            <a:ext cx="5577840" cy="1005840"/>
+            <a:ext cx="5577840" cy="1051560"/>
           </a:xfrm>
           <a:prstGeom prst="rect">
             <a:avLst/>
@@ -24275,7 +24397,7 @@
               <a:buNone/>
             </a:pPr>
             <a:r>
-              <a:rPr lang="en-US" sz="2600" b="1" dirty="0">
+              <a:rPr lang="en-US" sz="3400" b="1" dirty="0">
                 <a:solidFill>
                   <a:srgbClr val="414142"/>
                 </a:solidFill>
@@ -24285,7 +24407,7 @@
               </a:rPr>
               <a:t>Une question sur nos participations ?</a:t>
             </a:r>
-            <a:endParaRPr lang="en-US" sz="2600" dirty="0"/>
+            <a:endParaRPr lang="en-US" sz="3400" dirty="0"/>
           </a:p>
         </p:txBody>
       </p:sp>
@@ -24297,7 +24419,7 @@
         </p:nvSpPr>
         <p:spPr>
           <a:xfrm>
-            <a:off x="548640" y="2057400"/>
+            <a:off x="548640" y="2121408"/>
             <a:ext cx="5394960" cy="1234440"/>
           </a:xfrm>
           <a:prstGeom prst="rect">
@@ -24325,7 +24447,7 @@
                 <a:ea typeface="Arial" pitchFamily="34" charset="-122"/>
                 <a:cs typeface="Arial" pitchFamily="34" charset="-120"/>
               </a:rPr>
-              <a:t>Un cas venu de l’équipe IR : des agents qui vont chercher, systématiquement, la même information dans chacune de nos participations, données sensibles comprises. Ici, la cartographie bancaire : deux régions, une banque, l’analyse tombe.</a:t>
+              <a:t>Un cas venu de l'équipe IR : des agents qui vont chercher, systématiquement, la même information dans chacune de nos participations, données sensibles comprises. Ici, la cartographie bancaire : deux régions, une banque, l'analyse tombe.</a:t>
             </a:r>
             <a:endParaRPr lang="en-US" sz="1250" dirty="0"/>
           </a:p>
@@ -24423,7 +24545,7 @@
         <p:spPr>
           <a:xfrm>
             <a:off x="548640" y="987552"/>
-            <a:ext cx="5577840" cy="1005840"/>
+            <a:ext cx="5577840" cy="1051560"/>
           </a:xfrm>
           <a:prstGeom prst="rect">
             <a:avLst/>
@@ -24439,7 +24561,7 @@
               <a:buNone/>
             </a:pPr>
             <a:r>
-              <a:rPr lang="en-US" sz="2600" b="1" dirty="0">
+              <a:rPr lang="en-US" sz="3400" b="1" dirty="0">
                 <a:solidFill>
                   <a:srgbClr val="414142"/>
                 </a:solidFill>
@@ -24449,7 +24571,7 @@
               </a:rPr>
               <a:t>Une question sur nos participations ?</a:t>
             </a:r>
-            <a:endParaRPr lang="en-US" sz="2600" dirty="0"/>
+            <a:endParaRPr lang="en-US" sz="3400" dirty="0"/>
           </a:p>
         </p:txBody>
       </p:sp>
@@ -24461,7 +24583,7 @@
         </p:nvSpPr>
         <p:spPr>
           <a:xfrm>
-            <a:off x="548640" y="2057400"/>
+            <a:off x="548640" y="2121408"/>
             <a:ext cx="5394960" cy="1234440"/>
           </a:xfrm>
           <a:prstGeom prst="rect">
@@ -24489,7 +24611,7 @@
                 <a:ea typeface="Arial" pitchFamily="34" charset="-122"/>
                 <a:cs typeface="Arial" pitchFamily="34" charset="-120"/>
               </a:rPr>
-              <a:t>Un cas venu de l’équipe IR : des agents qui vont chercher, systématiquement, la même information dans chacune de nos participations, données sensibles comprises. Ici, la cartographie bancaire : deux régions, une banque, l’analyse tombe.</a:t>
+              <a:t>Un cas venu de l'équipe IR : des agents qui vont chercher, systématiquement, la même information dans chacune de nos participations, données sensibles comprises. Ici, la cartographie bancaire : deux régions, une banque, l'analyse tombe.</a:t>
             </a:r>
             <a:endParaRPr lang="en-US" sz="1250" dirty="0"/>
           </a:p>
@@ -24576,7 +24698,7 @@
                 <a:ea typeface="Arial" pitchFamily="34" charset="-122"/>
                 <a:cs typeface="Arial" pitchFamily="34" charset="-120"/>
               </a:rPr>
-              <a:t>Virtual Brain · L’app régions</a:t>
+              <a:t>Virtual Brain · L'app régions</a:t>
             </a:r>
             <a:endParaRPr lang="en-US" sz="1150" dirty="0"/>
           </a:p>
@@ -25112,7 +25234,7 @@
         <p:spPr>
           <a:xfrm>
             <a:off x="548640" y="987552"/>
-            <a:ext cx="5577840" cy="1005840"/>
+            <a:ext cx="5577840" cy="1051560"/>
           </a:xfrm>
           <a:prstGeom prst="rect">
             <a:avLst/>
@@ -25128,7 +25250,7 @@
               <a:buNone/>
             </a:pPr>
             <a:r>
-              <a:rPr lang="en-US" sz="2600" b="1" dirty="0">
+              <a:rPr lang="en-US" sz="3400" b="1" dirty="0">
                 <a:solidFill>
                   <a:srgbClr val="414142"/>
                 </a:solidFill>
@@ -25138,7 +25260,7 @@
               </a:rPr>
               <a:t>Une question sur nos participations ?</a:t>
             </a:r>
-            <a:endParaRPr lang="en-US" sz="2600" dirty="0"/>
+            <a:endParaRPr lang="en-US" sz="3400" dirty="0"/>
           </a:p>
         </p:txBody>
       </p:sp>
@@ -25150,7 +25272,7 @@
         </p:nvSpPr>
         <p:spPr>
           <a:xfrm>
-            <a:off x="548640" y="2057400"/>
+            <a:off x="548640" y="2121408"/>
             <a:ext cx="5394960" cy="1234440"/>
           </a:xfrm>
           <a:prstGeom prst="rect">
@@ -25178,7 +25300,7 @@
                 <a:ea typeface="Arial" pitchFamily="34" charset="-122"/>
                 <a:cs typeface="Arial" pitchFamily="34" charset="-120"/>
               </a:rPr>
-              <a:t>Un cas venu de l’équipe IR : des agents qui vont chercher, systématiquement, la même information dans chacune de nos participations, données sensibles comprises. Ici, la cartographie bancaire : deux régions, une banque, l’analyse tombe.</a:t>
+              <a:t>Un cas venu de l'équipe IR : des agents qui vont chercher, systématiquement, la même information dans chacune de nos participations, données sensibles comprises. Ici, la cartographie bancaire : deux régions, une banque, l'analyse tombe.</a:t>
             </a:r>
             <a:endParaRPr lang="en-US" sz="1250" dirty="0"/>
           </a:p>
@@ -25265,7 +25387,7 @@
                 <a:ea typeface="Arial" pitchFamily="34" charset="-122"/>
                 <a:cs typeface="Arial" pitchFamily="34" charset="-120"/>
               </a:rPr>
-              <a:t>Virtual Brain · L’app régions</a:t>
+              <a:t>Virtual Brain · L'app régions</a:t>
             </a:r>
             <a:endParaRPr lang="en-US" sz="1150" dirty="0"/>
           </a:p>
@@ -25603,7 +25725,7 @@
                 <a:ea typeface="Arial" pitchFamily="34" charset="-122"/>
                 <a:cs typeface="Arial" pitchFamily="34" charset="-120"/>
               </a:rPr>
-              <a:t>Caisse d’Épargne</a:t>
+              <a:t>Caisse d'Épargne</a:t>
             </a:r>
             <a:endParaRPr lang="en-US" sz="1100" dirty="0"/>
           </a:p>
@@ -25801,7 +25923,7 @@
         <p:spPr>
           <a:xfrm>
             <a:off x="548640" y="987552"/>
-            <a:ext cx="5577840" cy="1005840"/>
+            <a:ext cx="5577840" cy="1051560"/>
           </a:xfrm>
           <a:prstGeom prst="rect">
             <a:avLst/>
@@ -25817,7 +25939,7 @@
               <a:buNone/>
             </a:pPr>
             <a:r>
-              <a:rPr lang="en-US" sz="2600" b="1" dirty="0">
+              <a:rPr lang="en-US" sz="3400" b="1" dirty="0">
                 <a:solidFill>
                   <a:srgbClr val="414142"/>
                 </a:solidFill>
@@ -25827,7 +25949,7 @@
               </a:rPr>
               <a:t>Une question sur nos participations ?</a:t>
             </a:r>
-            <a:endParaRPr lang="en-US" sz="2600" dirty="0"/>
+            <a:endParaRPr lang="en-US" sz="3400" dirty="0"/>
           </a:p>
         </p:txBody>
       </p:sp>
@@ -25839,7 +25961,7 @@
         </p:nvSpPr>
         <p:spPr>
           <a:xfrm>
-            <a:off x="548640" y="2057400"/>
+            <a:off x="548640" y="2121408"/>
             <a:ext cx="5394960" cy="1234440"/>
           </a:xfrm>
           <a:prstGeom prst="rect">
@@ -25867,7 +25989,7 @@
                 <a:ea typeface="Arial" pitchFamily="34" charset="-122"/>
                 <a:cs typeface="Arial" pitchFamily="34" charset="-120"/>
               </a:rPr>
-              <a:t>Un cas venu de l’équipe IR : des agents qui vont chercher, systématiquement, la même information dans chacune de nos participations, données sensibles comprises. Ici, la cartographie bancaire : deux régions, une banque, l’analyse tombe.</a:t>
+              <a:t>Un cas venu de l'équipe IR : des agents qui vont chercher, systématiquement, la même information dans chacune de nos participations, données sensibles comprises. Ici, la cartographie bancaire : deux régions, une banque, l'analyse tombe.</a:t>
             </a:r>
             <a:endParaRPr lang="en-US" sz="1250" dirty="0"/>
           </a:p>
@@ -25954,7 +26076,7 @@
                 <a:ea typeface="Arial" pitchFamily="34" charset="-122"/>
                 <a:cs typeface="Arial" pitchFamily="34" charset="-120"/>
               </a:rPr>
-              <a:t>Virtual Brain · L’app régions</a:t>
+              <a:t>Virtual Brain · L'app régions</a:t>
             </a:r>
             <a:endParaRPr lang="en-US" sz="1150" dirty="0"/>
           </a:p>
@@ -26292,7 +26414,7 @@
                 <a:ea typeface="Arial" pitchFamily="34" charset="-122"/>
                 <a:cs typeface="Arial" pitchFamily="34" charset="-120"/>
               </a:rPr>
-              <a:t>Caisse d’Épargne</a:t>
+              <a:t>Caisse d'Épargne</a:t>
             </a:r>
             <a:endParaRPr lang="en-US" sz="1100" dirty="0"/>
           </a:p>
@@ -26622,7 +26744,7 @@
                 <a:ea typeface="Arial" pitchFamily="34" charset="-122"/>
                 <a:cs typeface="Arial" pitchFamily="34" charset="-120"/>
               </a:rPr>
-              <a:t>de prêt effectif, Tier 1 Caisse d’Épargne</a:t>
+              <a:t>de prêt effectif, Tier 1 Caisse d'Épargne</a:t>
             </a:r>
             <a:endParaRPr lang="en-US" sz="850" dirty="0"/>
           </a:p>
@@ -26872,7 +26994,7 @@
                 <a:ea typeface="Arial" pitchFamily="34" charset="-122"/>
                 <a:cs typeface="Arial" pitchFamily="34" charset="-120"/>
               </a:rPr>
-              <a:t>Caisse d’Épargne BPL</a:t>
+              <a:t>Caisse d'Épargne BPL</a:t>
             </a:r>
             <a:endParaRPr lang="en-US" sz="1050" dirty="0"/>
           </a:p>
@@ -27360,7 +27482,7 @@
                 <a:ea typeface="Arial" pitchFamily="34" charset="-122"/>
                 <a:cs typeface="Arial" pitchFamily="34" charset="-120"/>
               </a:rPr>
-              <a:t>Deux régions, une banque : l’analyse tombe, données sensibles comprises.</a:t>
+              <a:t>Deux régions, une banque : l'analyse tombe, données sensibles comprises.</a:t>
             </a:r>
             <a:endParaRPr lang="en-US" sz="900" dirty="0"/>
           </a:p>
@@ -27458,7 +27580,7 @@
         <p:spPr>
           <a:xfrm>
             <a:off x="548640" y="987552"/>
-            <a:ext cx="5577840" cy="1005840"/>
+            <a:ext cx="5577840" cy="1051560"/>
           </a:xfrm>
           <a:prstGeom prst="rect">
             <a:avLst/>
@@ -27474,7 +27596,7 @@
               <a:buNone/>
             </a:pPr>
             <a:r>
-              <a:rPr lang="en-US" sz="2600" b="1" dirty="0">
+              <a:rPr lang="en-US" sz="3400" b="1" dirty="0">
                 <a:solidFill>
                   <a:srgbClr val="414142"/>
                 </a:solidFill>
@@ -27484,7 +27606,7 @@
               </a:rPr>
               <a:t>Une question sur nos participations ?</a:t>
             </a:r>
-            <a:endParaRPr lang="en-US" sz="2600" dirty="0"/>
+            <a:endParaRPr lang="en-US" sz="3400" dirty="0"/>
           </a:p>
         </p:txBody>
       </p:sp>
@@ -27496,7 +27618,7 @@
         </p:nvSpPr>
         <p:spPr>
           <a:xfrm>
-            <a:off x="548640" y="2057400"/>
+            <a:off x="548640" y="2121408"/>
             <a:ext cx="5394960" cy="1234440"/>
           </a:xfrm>
           <a:prstGeom prst="rect">
@@ -27524,7 +27646,7 @@
                 <a:ea typeface="Arial" pitchFamily="34" charset="-122"/>
                 <a:cs typeface="Arial" pitchFamily="34" charset="-120"/>
               </a:rPr>
-              <a:t>Un cas venu de l’équipe IR : des agents qui vont chercher, systématiquement, la même information dans chacune de nos participations, données sensibles comprises. Ici, la cartographie bancaire : deux régions, une banque, l’analyse tombe.</a:t>
+              <a:t>Un cas venu de l'équipe IR : des agents qui vont chercher, systématiquement, la même information dans chacune de nos participations, données sensibles comprises. Ici, la cartographie bancaire : deux régions, une banque, l'analyse tombe.</a:t>
             </a:r>
             <a:endParaRPr lang="en-US" sz="1250" dirty="0"/>
           </a:p>
@@ -27611,7 +27733,7 @@
                 <a:ea typeface="Arial" pitchFamily="34" charset="-122"/>
                 <a:cs typeface="Arial" pitchFamily="34" charset="-120"/>
               </a:rPr>
-              <a:t>Virtual Brain · L’app régions</a:t>
+              <a:t>Virtual Brain · L'app régions</a:t>
             </a:r>
             <a:endParaRPr lang="en-US" sz="1150" dirty="0"/>
           </a:p>
@@ -27949,7 +28071,7 @@
                 <a:ea typeface="Arial" pitchFamily="34" charset="-122"/>
                 <a:cs typeface="Arial" pitchFamily="34" charset="-120"/>
               </a:rPr>
-              <a:t>Caisse d’Épargne</a:t>
+              <a:t>Caisse d'Épargne</a:t>
             </a:r>
             <a:endParaRPr lang="en-US" sz="1100" dirty="0"/>
           </a:p>
@@ -28279,7 +28401,7 @@
                 <a:ea typeface="Arial" pitchFamily="34" charset="-122"/>
                 <a:cs typeface="Arial" pitchFamily="34" charset="-120"/>
               </a:rPr>
-              <a:t>de prêt effectif, Tier 1 Caisse d’Épargne</a:t>
+              <a:t>de prêt effectif, Tier 1 Caisse d'Épargne</a:t>
             </a:r>
             <a:endParaRPr lang="en-US" sz="850" dirty="0"/>
           </a:p>
@@ -28529,7 +28651,7 @@
                 <a:ea typeface="Arial" pitchFamily="34" charset="-122"/>
                 <a:cs typeface="Arial" pitchFamily="34" charset="-120"/>
               </a:rPr>
-              <a:t>Caisse d’Épargne BPL</a:t>
+              <a:t>Caisse d'Épargne BPL</a:t>
             </a:r>
             <a:endParaRPr lang="en-US" sz="1050" dirty="0"/>
           </a:p>
@@ -29017,7 +29139,7 @@
                 <a:ea typeface="Arial" pitchFamily="34" charset="-122"/>
                 <a:cs typeface="Arial" pitchFamily="34" charset="-120"/>
               </a:rPr>
-              <a:t>Deux régions, une banque : l’analyse tombe, données sensibles comprises.</a:t>
+              <a:t>Deux régions, une banque : l'analyse tombe, données sensibles comprises.</a:t>
             </a:r>
             <a:endParaRPr lang="en-US" sz="900" dirty="0"/>
           </a:p>
@@ -29088,7 +29210,7 @@
           <a:bodyPr wrap="square" lIns="0" tIns="0" rIns="0" bIns="0" rtlCol="0" anchor="ctr"/>
           <a:lstStyle/>
           <a:p>
-            <a:pPr algn="ctr" indent="0" marL="0">
+            <a:pPr algn="l" indent="0" marL="0">
               <a:buNone/>
             </a:pPr>
             <a:r>
@@ -29127,7 +29249,7 @@
           <a:bodyPr wrap="square" lIns="0" tIns="0" rIns="0" bIns="0" rtlCol="0" anchor="ctr"/>
           <a:lstStyle/>
           <a:p>
-            <a:pPr algn="ctr" indent="0" marL="0">
+            <a:pPr algn="l" indent="0" marL="0">
               <a:buNone/>
             </a:pPr>
             <a:r>
@@ -29210,7 +29332,7 @@
           <a:bodyPr wrap="square" lIns="0" tIns="0" rIns="0" bIns="0" rtlCol="0" anchor="ctr"/>
           <a:lstStyle/>
           <a:p>
-            <a:pPr algn="ctr" indent="0" marL="0">
+            <a:pPr algn="l" indent="0" marL="0">
               <a:buNone/>
             </a:pPr>
             <a:r>
@@ -29249,7 +29371,7 @@
           <a:bodyPr wrap="square" lIns="0" tIns="0" rIns="0" bIns="0" rtlCol="0" anchor="ctr"/>
           <a:lstStyle/>
           <a:p>
-            <a:pPr algn="ctr" indent="0" marL="0">
+            <a:pPr algn="l" indent="0" marL="0">
               <a:buNone/>
             </a:pPr>
             <a:r>
@@ -29275,12 +29397,12 @@
         </p:nvSpPr>
         <p:spPr>
           <a:xfrm>
-            <a:off x="563728" y="2377440"/>
-            <a:ext cx="3383280" cy="2286000"/>
+            <a:off x="548640" y="2514600"/>
+            <a:ext cx="3383280" cy="1600200"/>
           </a:xfrm>
           <a:prstGeom prst="roundRect">
             <a:avLst>
-              <a:gd name="adj" fmla="val 3600"/>
+              <a:gd name="adj" fmla="val 5143"/>
             </a:avLst>
           </a:prstGeom>
           <a:solidFill>
@@ -29309,26 +29431,26 @@
         </p:nvSpPr>
         <p:spPr>
           <a:xfrm>
-            <a:off x="856336" y="2606040"/>
-            <a:ext cx="2798064" cy="548640"/>
-          </a:xfrm>
-          <a:prstGeom prst="rect">
-            <a:avLst/>
-          </a:prstGeom>
-          <a:noFill/>
-          <a:ln/>
-        </p:spPr>
-        <p:txBody>
-          <a:bodyPr wrap="square" lIns="0" tIns="0" rIns="0" bIns="0" rtlCol="0" anchor="ctr"/>
-          <a:lstStyle/>
-          <a:p>
-            <a:pPr indent="0" marL="0">
-              <a:buNone/>
-            </a:pPr>
-            <a:r>
-              <a:rPr lang="en-US" sz="3000" b="1" dirty="0">
-                <a:solidFill>
-                  <a:srgbClr val="0488C1"/>
+            <a:off x="841248" y="2788920"/>
+            <a:ext cx="2798064" cy="256032"/>
+          </a:xfrm>
+          <a:prstGeom prst="rect">
+            <a:avLst/>
+          </a:prstGeom>
+          <a:noFill/>
+          <a:ln/>
+        </p:spPr>
+        <p:txBody>
+          <a:bodyPr wrap="square" lIns="0" tIns="0" rIns="0" bIns="0" rtlCol="0" anchor="ctr"/>
+          <a:lstStyle/>
+          <a:p>
+            <a:pPr indent="0" marL="0">
+              <a:buNone/>
+            </a:pPr>
+            <a:r>
+              <a:rPr lang="en-US" sz="1100" b="1" spc="200" kern="0" dirty="0">
+                <a:solidFill>
+                  <a:srgbClr val="9B9DA3"/>
                 </a:solidFill>
                 <a:latin typeface="Arial" pitchFamily="34" charset="0"/>
                 <a:ea typeface="Arial" pitchFamily="34" charset="-122"/>
@@ -29336,7 +29458,7 @@
               </a:rPr>
               <a:t>01</a:t>
             </a:r>
-            <a:endParaRPr lang="en-US" sz="3000" dirty="0"/>
+            <a:endParaRPr lang="en-US" sz="1100" dirty="0"/>
           </a:p>
         </p:txBody>
       </p:sp>
@@ -29348,8 +29470,8 @@
         </p:nvSpPr>
         <p:spPr>
           <a:xfrm>
-            <a:off x="856336" y="3246120"/>
-            <a:ext cx="2798064" cy="594360"/>
+            <a:off x="841248" y="3136392"/>
+            <a:ext cx="2798064" cy="685800"/>
           </a:xfrm>
           <a:prstGeom prst="rect">
             <a:avLst/>
@@ -29363,12 +29485,12 @@
           <a:p>
             <a:pPr indent="0" marL="0">
               <a:lnSpc>
-                <a:spcPts val="2000"/>
+                <a:spcPts val="2200"/>
               </a:lnSpc>
               <a:buNone/>
             </a:pPr>
             <a:r>
-              <a:rPr lang="en-US" sz="1650" b="1" dirty="0">
+              <a:rPr lang="en-US" sz="1800" b="1" dirty="0">
                 <a:solidFill>
                   <a:srgbClr val="414142"/>
                 </a:solidFill>
@@ -29378,66 +29500,24 @@
               </a:rPr>
               <a:t>Installez CR Express</a:t>
             </a:r>
-            <a:endParaRPr lang="en-US" sz="1650" dirty="0"/>
-          </a:p>
-        </p:txBody>
-      </p:sp>
-      <p:sp>
-        <p:nvSpPr>
-          <p:cNvPr id="7" name="Text 5"/>
-          <p:cNvSpPr/>
-          <p:nvPr/>
-        </p:nvSpPr>
-        <p:spPr>
-          <a:xfrm>
-            <a:off x="856336" y="3858768"/>
-            <a:ext cx="2798064" cy="731520"/>
-          </a:xfrm>
-          <a:prstGeom prst="rect">
-            <a:avLst/>
-          </a:prstGeom>
-          <a:noFill/>
-          <a:ln/>
-        </p:spPr>
-        <p:txBody>
-          <a:bodyPr wrap="square" lIns="0" tIns="0" rIns="0" bIns="0" rtlCol="0" anchor="ctr"/>
-          <a:lstStyle/>
-          <a:p>
-            <a:pPr indent="0" marL="0">
-              <a:lnSpc>
-                <a:spcPts val="1450"/>
-              </a:lnSpc>
-              <a:buNone/>
-            </a:pPr>
-            <a:r>
-              <a:rPr lang="en-US" sz="1100" dirty="0">
-                <a:solidFill>
-                  <a:srgbClr val="6B6D72"/>
-                </a:solidFill>
-                <a:latin typeface="Arial" pitchFamily="34" charset="0"/>
-                <a:ea typeface="Arial" pitchFamily="34" charset="-122"/>
-                <a:cs typeface="Arial" pitchFamily="34" charset="-120"/>
-              </a:rPr>
-              <a:t>Dictez votre compte-rendu, validez quatre cartes : tout est rangé dans Salesforce.</a:t>
-            </a:r>
-            <a:endParaRPr lang="en-US" sz="1100" dirty="0"/>
-          </a:p>
-        </p:txBody>
-      </p:sp>
-      <p:sp>
-        <p:nvSpPr>
-          <p:cNvPr id="8" name="Shape 6"/>
-          <p:cNvSpPr/>
-          <p:nvPr/>
-        </p:nvSpPr>
-        <p:spPr>
-          <a:xfrm>
-            <a:off x="4404208" y="2377440"/>
-            <a:ext cx="3383280" cy="2286000"/>
+            <a:endParaRPr lang="en-US" sz="1800" dirty="0"/>
+          </a:p>
+        </p:txBody>
+      </p:sp>
+      <p:sp>
+        <p:nvSpPr>
+          <p:cNvPr id="7" name="Shape 5"/>
+          <p:cNvSpPr/>
+          <p:nvPr/>
+        </p:nvSpPr>
+        <p:spPr>
+          <a:xfrm>
+            <a:off x="4389120" y="2514600"/>
+            <a:ext cx="3383280" cy="1600200"/>
           </a:xfrm>
           <a:prstGeom prst="roundRect">
             <a:avLst>
-              <a:gd name="adj" fmla="val 3600"/>
+              <a:gd name="adj" fmla="val 5143"/>
             </a:avLst>
           </a:prstGeom>
           <a:solidFill>
@@ -29460,53 +29540,53 @@
       </p:sp>
       <p:sp>
         <p:nvSpPr>
+          <p:cNvPr id="8" name="Text 6"/>
+          <p:cNvSpPr/>
+          <p:nvPr/>
+        </p:nvSpPr>
+        <p:spPr>
+          <a:xfrm>
+            <a:off x="4681728" y="2788920"/>
+            <a:ext cx="2798064" cy="256032"/>
+          </a:xfrm>
+          <a:prstGeom prst="rect">
+            <a:avLst/>
+          </a:prstGeom>
+          <a:noFill/>
+          <a:ln/>
+        </p:spPr>
+        <p:txBody>
+          <a:bodyPr wrap="square" lIns="0" tIns="0" rIns="0" bIns="0" rtlCol="0" anchor="ctr"/>
+          <a:lstStyle/>
+          <a:p>
+            <a:pPr indent="0" marL="0">
+              <a:buNone/>
+            </a:pPr>
+            <a:r>
+              <a:rPr lang="en-US" sz="1100" b="1" spc="200" kern="0" dirty="0">
+                <a:solidFill>
+                  <a:srgbClr val="9B9DA3"/>
+                </a:solidFill>
+                <a:latin typeface="Arial" pitchFamily="34" charset="0"/>
+                <a:ea typeface="Arial" pitchFamily="34" charset="-122"/>
+                <a:cs typeface="Arial" pitchFamily="34" charset="-120"/>
+              </a:rPr>
+              <a:t>02</a:t>
+            </a:r>
+            <a:endParaRPr lang="en-US" sz="1100" dirty="0"/>
+          </a:p>
+        </p:txBody>
+      </p:sp>
+      <p:sp>
+        <p:nvSpPr>
           <p:cNvPr id="9" name="Text 7"/>
           <p:cNvSpPr/>
           <p:nvPr/>
         </p:nvSpPr>
         <p:spPr>
           <a:xfrm>
-            <a:off x="4696816" y="2606040"/>
-            <a:ext cx="2798064" cy="548640"/>
-          </a:xfrm>
-          <a:prstGeom prst="rect">
-            <a:avLst/>
-          </a:prstGeom>
-          <a:noFill/>
-          <a:ln/>
-        </p:spPr>
-        <p:txBody>
-          <a:bodyPr wrap="square" lIns="0" tIns="0" rIns="0" bIns="0" rtlCol="0" anchor="ctr"/>
-          <a:lstStyle/>
-          <a:p>
-            <a:pPr indent="0" marL="0">
-              <a:buNone/>
-            </a:pPr>
-            <a:r>
-              <a:rPr lang="en-US" sz="3000" b="1" dirty="0">
-                <a:solidFill>
-                  <a:srgbClr val="0488C1"/>
-                </a:solidFill>
-                <a:latin typeface="Arial" pitchFamily="34" charset="0"/>
-                <a:ea typeface="Arial" pitchFamily="34" charset="-122"/>
-                <a:cs typeface="Arial" pitchFamily="34" charset="-120"/>
-              </a:rPr>
-              <a:t>02</a:t>
-            </a:r>
-            <a:endParaRPr lang="en-US" sz="3000" dirty="0"/>
-          </a:p>
-        </p:txBody>
-      </p:sp>
-      <p:sp>
-        <p:nvSpPr>
-          <p:cNvPr id="10" name="Text 8"/>
-          <p:cNvSpPr/>
-          <p:nvPr/>
-        </p:nvSpPr>
-        <p:spPr>
-          <a:xfrm>
-            <a:off x="4696816" y="3246120"/>
-            <a:ext cx="2798064" cy="594360"/>
+            <a:off x="4681728" y="3136392"/>
+            <a:ext cx="2798064" cy="685800"/>
           </a:xfrm>
           <a:prstGeom prst="rect">
             <a:avLst/>
@@ -29520,12 +29600,12 @@
           <a:p>
             <a:pPr indent="0" marL="0">
               <a:lnSpc>
-                <a:spcPts val="2000"/>
+                <a:spcPts val="2200"/>
               </a:lnSpc>
               <a:buNone/>
             </a:pPr>
             <a:r>
-              <a:rPr lang="en-US" sz="1650" b="1" dirty="0">
+              <a:rPr lang="en-US" sz="1800" b="1" dirty="0">
                 <a:solidFill>
                   <a:srgbClr val="414142"/>
                 </a:solidFill>
@@ -29535,66 +29615,24 @@
               </a:rPr>
               <a:t>Demandez un Brief Express</a:t>
             </a:r>
-            <a:endParaRPr lang="en-US" sz="1650" dirty="0"/>
-          </a:p>
-        </p:txBody>
-      </p:sp>
-      <p:sp>
-        <p:nvSpPr>
-          <p:cNvPr id="11" name="Text 9"/>
-          <p:cNvSpPr/>
-          <p:nvPr/>
-        </p:nvSpPr>
-        <p:spPr>
-          <a:xfrm>
-            <a:off x="4696816" y="3858768"/>
-            <a:ext cx="2798064" cy="731520"/>
-          </a:xfrm>
-          <a:prstGeom prst="rect">
-            <a:avLst/>
-          </a:prstGeom>
-          <a:noFill/>
-          <a:ln/>
-        </p:spPr>
-        <p:txBody>
-          <a:bodyPr wrap="square" lIns="0" tIns="0" rIns="0" bIns="0" rtlCol="0" anchor="ctr"/>
-          <a:lstStyle/>
-          <a:p>
-            <a:pPr indent="0" marL="0">
-              <a:lnSpc>
-                <a:spcPts val="1450"/>
-              </a:lnSpc>
-              <a:buNone/>
-            </a:pPr>
-            <a:r>
-              <a:rPr lang="en-US" sz="1100" dirty="0">
-                <a:solidFill>
-                  <a:srgbClr val="6B6D72"/>
-                </a:solidFill>
-                <a:latin typeface="Arial" pitchFamily="34" charset="0"/>
-                <a:ea typeface="Arial" pitchFamily="34" charset="-122"/>
-                <a:cs typeface="Arial" pitchFamily="34" charset="-120"/>
-              </a:rPr>
-              <a:t>Une phrase dans Teams, trente secondes : la fiche complète avant votre rendez-vous.</a:t>
-            </a:r>
-            <a:endParaRPr lang="en-US" sz="1100" dirty="0"/>
-          </a:p>
-        </p:txBody>
-      </p:sp>
-      <p:sp>
-        <p:nvSpPr>
-          <p:cNvPr id="12" name="Shape 10"/>
-          <p:cNvSpPr/>
-          <p:nvPr/>
-        </p:nvSpPr>
-        <p:spPr>
-          <a:xfrm>
-            <a:off x="8244688" y="2377440"/>
-            <a:ext cx="3383280" cy="2286000"/>
+            <a:endParaRPr lang="en-US" sz="1800" dirty="0"/>
+          </a:p>
+        </p:txBody>
+      </p:sp>
+      <p:sp>
+        <p:nvSpPr>
+          <p:cNvPr id="10" name="Shape 8"/>
+          <p:cNvSpPr/>
+          <p:nvPr/>
+        </p:nvSpPr>
+        <p:spPr>
+          <a:xfrm>
+            <a:off x="8229600" y="2514600"/>
+            <a:ext cx="3383280" cy="1600200"/>
           </a:xfrm>
           <a:prstGeom prst="roundRect">
             <a:avLst>
-              <a:gd name="adj" fmla="val 3600"/>
+              <a:gd name="adj" fmla="val 5143"/>
             </a:avLst>
           </a:prstGeom>
           <a:solidFill>
@@ -29617,72 +29655,111 @@
       </p:sp>
       <p:sp>
         <p:nvSpPr>
+          <p:cNvPr id="11" name="Text 9"/>
+          <p:cNvSpPr/>
+          <p:nvPr/>
+        </p:nvSpPr>
+        <p:spPr>
+          <a:xfrm>
+            <a:off x="8522208" y="2788920"/>
+            <a:ext cx="2798064" cy="256032"/>
+          </a:xfrm>
+          <a:prstGeom prst="rect">
+            <a:avLst/>
+          </a:prstGeom>
+          <a:noFill/>
+          <a:ln/>
+        </p:spPr>
+        <p:txBody>
+          <a:bodyPr wrap="square" lIns="0" tIns="0" rIns="0" bIns="0" rtlCol="0" anchor="ctr"/>
+          <a:lstStyle/>
+          <a:p>
+            <a:pPr indent="0" marL="0">
+              <a:buNone/>
+            </a:pPr>
+            <a:r>
+              <a:rPr lang="en-US" sz="1100" b="1" spc="200" kern="0" dirty="0">
+                <a:solidFill>
+                  <a:srgbClr val="9B9DA3"/>
+                </a:solidFill>
+                <a:latin typeface="Arial" pitchFamily="34" charset="0"/>
+                <a:ea typeface="Arial" pitchFamily="34" charset="-122"/>
+                <a:cs typeface="Arial" pitchFamily="34" charset="-120"/>
+              </a:rPr>
+              <a:t>03</a:t>
+            </a:r>
+            <a:endParaRPr lang="en-US" sz="1100" dirty="0"/>
+          </a:p>
+        </p:txBody>
+      </p:sp>
+      <p:sp>
+        <p:nvSpPr>
+          <p:cNvPr id="12" name="Text 10"/>
+          <p:cNvSpPr/>
+          <p:nvPr/>
+        </p:nvSpPr>
+        <p:spPr>
+          <a:xfrm>
+            <a:off x="8522208" y="3136392"/>
+            <a:ext cx="2798064" cy="685800"/>
+          </a:xfrm>
+          <a:prstGeom prst="rect">
+            <a:avLst/>
+          </a:prstGeom>
+          <a:noFill/>
+          <a:ln/>
+        </p:spPr>
+        <p:txBody>
+          <a:bodyPr wrap="square" lIns="0" tIns="0" rIns="0" bIns="0" rtlCol="0" anchor="ctr"/>
+          <a:lstStyle/>
+          <a:p>
+            <a:pPr indent="0" marL="0">
+              <a:lnSpc>
+                <a:spcPts val="2200"/>
+              </a:lnSpc>
+              <a:buNone/>
+            </a:pPr>
+            <a:r>
+              <a:rPr lang="en-US" sz="1800" b="1" dirty="0">
+                <a:solidFill>
+                  <a:srgbClr val="414142"/>
+                </a:solidFill>
+                <a:latin typeface="Arial" pitchFamily="34" charset="0"/>
+                <a:ea typeface="Arial" pitchFamily="34" charset="-122"/>
+                <a:cs typeface="Arial" pitchFamily="34" charset="-120"/>
+              </a:rPr>
+              <a:t>Parlez à Virtual Brain</a:t>
+            </a:r>
+            <a:endParaRPr lang="en-US" sz="1800" dirty="0"/>
+          </a:p>
+        </p:txBody>
+      </p:sp>
+      <p:sp>
+        <p:nvSpPr>
           <p:cNvPr id="13" name="Text 11"/>
           <p:cNvSpPr/>
           <p:nvPr/>
         </p:nvSpPr>
         <p:spPr>
           <a:xfrm>
-            <a:off x="8537296" y="2606040"/>
-            <a:ext cx="2798064" cy="548640"/>
-          </a:xfrm>
-          <a:prstGeom prst="rect">
-            <a:avLst/>
-          </a:prstGeom>
-          <a:noFill/>
-          <a:ln/>
-        </p:spPr>
-        <p:txBody>
-          <a:bodyPr wrap="square" lIns="0" tIns="0" rIns="0" bIns="0" rtlCol="0" anchor="ctr"/>
-          <a:lstStyle/>
-          <a:p>
-            <a:pPr indent="0" marL="0">
-              <a:buNone/>
-            </a:pPr>
-            <a:r>
-              <a:rPr lang="en-US" sz="3000" b="1" dirty="0">
-                <a:solidFill>
-                  <a:srgbClr val="0488C1"/>
-                </a:solidFill>
-                <a:latin typeface="Arial" pitchFamily="34" charset="0"/>
-                <a:ea typeface="Arial" pitchFamily="34" charset="-122"/>
-                <a:cs typeface="Arial" pitchFamily="34" charset="-120"/>
-              </a:rPr>
-              <a:t>03</a:t>
-            </a:r>
-            <a:endParaRPr lang="en-US" sz="3000" dirty="0"/>
-          </a:p>
-        </p:txBody>
-      </p:sp>
-      <p:sp>
-        <p:nvSpPr>
-          <p:cNvPr id="14" name="Text 12"/>
-          <p:cNvSpPr/>
-          <p:nvPr/>
-        </p:nvSpPr>
-        <p:spPr>
-          <a:xfrm>
-            <a:off x="8537296" y="3246120"/>
-            <a:ext cx="2798064" cy="594360"/>
-          </a:xfrm>
-          <a:prstGeom prst="rect">
-            <a:avLst/>
-          </a:prstGeom>
-          <a:noFill/>
-          <a:ln/>
-        </p:spPr>
-        <p:txBody>
-          <a:bodyPr wrap="square" lIns="0" tIns="0" rIns="0" bIns="0" rtlCol="0" anchor="ctr"/>
-          <a:lstStyle/>
-          <a:p>
-            <a:pPr indent="0" marL="0">
-              <a:lnSpc>
-                <a:spcPts val="2000"/>
-              </a:lnSpc>
-              <a:buNone/>
-            </a:pPr>
-            <a:r>
-              <a:rPr lang="en-US" sz="1650" b="1" dirty="0">
+            <a:off x="548640" y="4892040"/>
+            <a:ext cx="11064240" cy="548640"/>
+          </a:xfrm>
+          <a:prstGeom prst="rect">
+            <a:avLst/>
+          </a:prstGeom>
+          <a:noFill/>
+          <a:ln/>
+        </p:spPr>
+        <p:txBody>
+          <a:bodyPr wrap="square" lIns="0" tIns="0" rIns="0" bIns="0" rtlCol="0" anchor="ctr"/>
+          <a:lstStyle/>
+          <a:p>
+            <a:pPr indent="0" marL="0">
+              <a:buNone/>
+            </a:pPr>
+            <a:r>
+              <a:rPr lang="en-US" sz="2100" b="1" dirty="0">
                 <a:solidFill>
                   <a:srgbClr val="414142"/>
                 </a:solidFill>
@@ -29690,90 +29767,9 @@
                 <a:ea typeface="Arial" pitchFamily="34" charset="-122"/>
                 <a:cs typeface="Arial" pitchFamily="34" charset="-120"/>
               </a:rPr>
-              <a:t>Parlez à Virtual Brain</a:t>
-            </a:r>
-            <a:endParaRPr lang="en-US" sz="1650" dirty="0"/>
-          </a:p>
-        </p:txBody>
-      </p:sp>
-      <p:sp>
-        <p:nvSpPr>
-          <p:cNvPr id="15" name="Text 13"/>
-          <p:cNvSpPr/>
-          <p:nvPr/>
-        </p:nvSpPr>
-        <p:spPr>
-          <a:xfrm>
-            <a:off x="8537296" y="3858768"/>
-            <a:ext cx="2798064" cy="731520"/>
-          </a:xfrm>
-          <a:prstGeom prst="rect">
-            <a:avLst/>
-          </a:prstGeom>
-          <a:noFill/>
-          <a:ln/>
-        </p:spPr>
-        <p:txBody>
-          <a:bodyPr wrap="square" lIns="0" tIns="0" rIns="0" bIns="0" rtlCol="0" anchor="ctr"/>
-          <a:lstStyle/>
-          <a:p>
-            <a:pPr indent="0" marL="0">
-              <a:lnSpc>
-                <a:spcPts val="1450"/>
-              </a:lnSpc>
-              <a:buNone/>
-            </a:pPr>
-            <a:r>
-              <a:rPr lang="en-US" sz="1100" dirty="0">
-                <a:solidFill>
-                  <a:srgbClr val="6B6D72"/>
-                </a:solidFill>
-                <a:latin typeface="Arial" pitchFamily="34" charset="0"/>
-                <a:ea typeface="Arial" pitchFamily="34" charset="-122"/>
-                <a:cs typeface="Arial" pitchFamily="34" charset="-120"/>
-              </a:rPr>
-              <a:t>Une question, toutes nos participations interrogées d’un coup.</a:t>
-            </a:r>
-            <a:endParaRPr lang="en-US" sz="1100" dirty="0"/>
-          </a:p>
-        </p:txBody>
-      </p:sp>
-      <p:sp>
-        <p:nvSpPr>
-          <p:cNvPr id="16" name="Text 14"/>
-          <p:cNvSpPr/>
-          <p:nvPr/>
-        </p:nvSpPr>
-        <p:spPr>
-          <a:xfrm>
-            <a:off x="548640" y="5166360"/>
-            <a:ext cx="11064240" cy="548640"/>
-          </a:xfrm>
-          <a:prstGeom prst="rect">
-            <a:avLst/>
-          </a:prstGeom>
-          <a:noFill/>
-          <a:ln/>
-        </p:spPr>
-        <p:txBody>
-          <a:bodyPr wrap="square" lIns="0" tIns="0" rIns="0" bIns="0" rtlCol="0" anchor="ctr"/>
-          <a:lstStyle/>
-          <a:p>
-            <a:pPr algn="ctr" indent="0" marL="0">
-              <a:buNone/>
-            </a:pPr>
-            <a:r>
-              <a:rPr lang="en-US" sz="2100" b="1" dirty="0">
-                <a:solidFill>
-                  <a:srgbClr val="414142"/>
-                </a:solidFill>
-                <a:latin typeface="Arial" pitchFamily="34" charset="0"/>
-                <a:ea typeface="Arial" pitchFamily="34" charset="-122"/>
-                <a:cs typeface="Arial" pitchFamily="34" charset="-120"/>
-              </a:rPr>
               <a:t>Plus on les utilise, </a:t>
             </a:r>
-            <a:pPr algn="ctr" indent="0" marL="0">
+            <a:pPr indent="0" marL="0">
               <a:buNone/>
             </a:pPr>
             <a:r>
@@ -29949,7 +29945,7 @@
           <a:bodyPr wrap="square" lIns="0" tIns="0" rIns="0" bIns="0" rtlCol="0" anchor="ctr"/>
           <a:lstStyle/>
           <a:p>
-            <a:pPr algn="ctr" indent="0" marL="0">
+            <a:pPr algn="l" indent="0" marL="0">
               <a:buNone/>
             </a:pPr>
             <a:r>
@@ -29988,7 +29984,7 @@
           <a:bodyPr wrap="square" lIns="0" tIns="0" rIns="0" bIns="0" rtlCol="0" anchor="ctr"/>
           <a:lstStyle/>
           <a:p>
-            <a:pPr algn="ctr" indent="0" marL="0">
+            <a:pPr indent="0" marL="0">
               <a:buNone/>
             </a:pPr>
             <a:r>
@@ -30027,7 +30023,7 @@
           <a:bodyPr wrap="square" lIns="0" tIns="0" rIns="0" bIns="0" rtlCol="0" anchor="ctr"/>
           <a:lstStyle/>
           <a:p>
-            <a:pPr algn="ctr" indent="0" marL="0">
+            <a:pPr indent="0" marL="0">
               <a:buNone/>
             </a:pPr>
             <a:r>
@@ -30039,7 +30035,7 @@
                 <a:ea typeface="Arial" pitchFamily="34" charset="-122"/>
                 <a:cs typeface="Arial" pitchFamily="34" charset="-120"/>
               </a:rPr>
-              <a:t>Une idée, un cas d’usage ? Venez nous voir.</a:t>
+              <a:t>Une idée, un cas d'usage ? Venez nous voir.</a:t>
             </a:r>
             <a:endParaRPr lang="en-US" sz="1400" dirty="0"/>
           </a:p>
@@ -30061,8 +30057,8 @@
         </p:blipFill>
         <p:spPr>
           <a:xfrm>
-            <a:off x="5227168" y="5577840"/>
-            <a:ext cx="1737360" cy="684355"/>
+            <a:off x="548640" y="5897880"/>
+            <a:ext cx="1463040" cy="576299"/>
           </a:xfrm>
           <a:prstGeom prst="rect">
             <a:avLst/>
@@ -30504,7 +30500,7 @@
     </a:clrScheme>
     <a:fontScheme name="Office">
       <a:majorFont>
-        <a:latin typeface="Calibri Light" panose="020F0302020204030204"/>
+        <a:latin typeface="Arial" panose="020F0302020204030204"/>
         <a:ea typeface=""/>
         <a:cs typeface=""/>
         <a:font script="Jpan" typeface="游ゴシック Light"/>
@@ -30556,7 +30552,7 @@
         <a:font script="Tfng" typeface="Ebrima"/>
       </a:majorFont>
       <a:minorFont>
-        <a:latin typeface="Calibri" panose="020F0502020204030204"/>
+        <a:latin typeface="Arial" panose="020F0502020204030204"/>
         <a:ea typeface=""/>
         <a:cs typeface=""/>
         <a:font script="Jpan" typeface="游ゴシック"/>

</xml_diff>

<commit_message>
Add staggered entrance-animation layer to animated deck
Native PowerPoint entrance effects (p:timing) injected with the
artifact's own build-in delays: toolbox cards then n8n bridge then
wires (0/180/550/800ms), diagnostic bubbles one by one (0/1.2/2.4/3.6s),
fiche content cascading after the morph lands (35ms steps), Virtual
Brain chart + stats in rhythm, closing cards in cadence. Shapes in
these sequences stay hidden through the Morph and fade in on their
own beat; slide 46 auto-advance widened to 1s to let its stagger play.

Co-Authored-By: Claude Fable 5 <noreply@anthropic.com>
Claude-Session: https://claude.ai/code/session_01LhBsEGCwVttHSPT2zP54Mu
</commit_message>
<xml_diff>
--- a/LIA-concretement-CC-anime.pptx
+++ b/LIA-concretement-CC-anime.pptx
@@ -6210,6 +6210,474 @@
       </p:transition>
     </mc:Fallback>
   </mc:AlternateContent>
+  <p:timing>
+    <p:tnLst>
+      <p:par>
+        <p:cTn id="1" dur="indefinite" restart="never" nodeType="tmRoot">
+          <p:childTnLst>
+            <p:seq concurrent="1" nextAc="seek">
+              <p:cTn id="2" dur="indefinite" nodeType="mainSeq">
+                <p:childTnLst>
+                  <p:par>
+                    <p:cTn id="3" fill="hold">
+                      <p:stCondLst>
+                        <p:cond delay="0"/>
+                      </p:stCondLst>
+                      <p:childTnLst>
+                        <p:par>
+                          <p:cTn id="4" fill="hold">
+                            <p:stCondLst>
+                              <p:cond delay="0"/>
+                            </p:stCondLst>
+                            <p:childTnLst>
+                              <p:par>
+                                <p:cTn id="5" presetID="10" presetClass="entr" presetSubtype="0" fill="hold" grpId="0" nodeType="withEffect">
+                                  <p:stCondLst>
+                                    <p:cond delay="0"/>
+                                  </p:stCondLst>
+                                  <p:childTnLst>
+                                    <p:set>
+                                      <p:cBhvr>
+                                        <p:cTn id="6" dur="1" fill="hold">
+                                          <p:stCondLst>
+                                            <p:cond delay="0"/>
+                                          </p:stCondLst>
+                                        </p:cTn>
+                                        <p:tgtEl>
+                                          <p:spTgt spid="4"/>
+                                        </p:tgtEl>
+                                        <p:attrNameLst>
+                                          <p:attrName>style.visibility</p:attrName>
+                                        </p:attrNameLst>
+                                      </p:cBhvr>
+                                      <p:to>
+                                        <p:strVal val="visible"/>
+                                      </p:to>
+                                    </p:set>
+                                    <p:animEffect transition="in" filter="fade">
+                                      <p:cBhvr>
+                                        <p:cTn id="7" dur="600"/>
+                                        <p:tgtEl>
+                                          <p:spTgt spid="4"/>
+                                        </p:tgtEl>
+                                      </p:cBhvr>
+                                    </p:animEffect>
+                                  </p:childTnLst>
+                                </p:cTn>
+                              </p:par>
+                              <p:par>
+                                <p:cTn id="8" presetID="10" presetClass="entr" presetSubtype="0" fill="hold" grpId="0" nodeType="withEffect">
+                                  <p:stCondLst>
+                                    <p:cond delay="0"/>
+                                  </p:stCondLst>
+                                  <p:childTnLst>
+                                    <p:set>
+                                      <p:cBhvr>
+                                        <p:cTn id="9" dur="1" fill="hold">
+                                          <p:stCondLst>
+                                            <p:cond delay="0"/>
+                                          </p:stCondLst>
+                                        </p:cTn>
+                                        <p:tgtEl>
+                                          <p:spTgt spid="5"/>
+                                        </p:tgtEl>
+                                        <p:attrNameLst>
+                                          <p:attrName>style.visibility</p:attrName>
+                                        </p:attrNameLst>
+                                      </p:cBhvr>
+                                      <p:to>
+                                        <p:strVal val="visible"/>
+                                      </p:to>
+                                    </p:set>
+                                    <p:animEffect transition="in" filter="fade">
+                                      <p:cBhvr>
+                                        <p:cTn id="10" dur="600"/>
+                                        <p:tgtEl>
+                                          <p:spTgt spid="5"/>
+                                        </p:tgtEl>
+                                      </p:cBhvr>
+                                    </p:animEffect>
+                                  </p:childTnLst>
+                                </p:cTn>
+                              </p:par>
+                              <p:par>
+                                <p:cTn id="11" presetID="10" presetClass="entr" presetSubtype="0" fill="hold" grpId="0" nodeType="withEffect">
+                                  <p:stCondLst>
+                                    <p:cond delay="0"/>
+                                  </p:stCondLst>
+                                  <p:childTnLst>
+                                    <p:set>
+                                      <p:cBhvr>
+                                        <p:cTn id="12" dur="1" fill="hold">
+                                          <p:stCondLst>
+                                            <p:cond delay="0"/>
+                                          </p:stCondLst>
+                                        </p:cTn>
+                                        <p:tgtEl>
+                                          <p:spTgt spid="6"/>
+                                        </p:tgtEl>
+                                        <p:attrNameLst>
+                                          <p:attrName>style.visibility</p:attrName>
+                                        </p:attrNameLst>
+                                      </p:cBhvr>
+                                      <p:to>
+                                        <p:strVal val="visible"/>
+                                      </p:to>
+                                    </p:set>
+                                    <p:animEffect transition="in" filter="fade">
+                                      <p:cBhvr>
+                                        <p:cTn id="13" dur="600"/>
+                                        <p:tgtEl>
+                                          <p:spTgt spid="6"/>
+                                        </p:tgtEl>
+                                      </p:cBhvr>
+                                    </p:animEffect>
+                                  </p:childTnLst>
+                                </p:cTn>
+                              </p:par>
+                              <p:par>
+                                <p:cTn id="14" presetID="10" presetClass="entr" presetSubtype="0" fill="hold" grpId="0" nodeType="withEffect">
+                                  <p:stCondLst>
+                                    <p:cond delay="1200"/>
+                                  </p:stCondLst>
+                                  <p:childTnLst>
+                                    <p:set>
+                                      <p:cBhvr>
+                                        <p:cTn id="15" dur="1" fill="hold">
+                                          <p:stCondLst>
+                                            <p:cond delay="0"/>
+                                          </p:stCondLst>
+                                        </p:cTn>
+                                        <p:tgtEl>
+                                          <p:spTgt spid="7"/>
+                                        </p:tgtEl>
+                                        <p:attrNameLst>
+                                          <p:attrName>style.visibility</p:attrName>
+                                        </p:attrNameLst>
+                                      </p:cBhvr>
+                                      <p:to>
+                                        <p:strVal val="visible"/>
+                                      </p:to>
+                                    </p:set>
+                                    <p:animEffect transition="in" filter="fade">
+                                      <p:cBhvr>
+                                        <p:cTn id="16" dur="600"/>
+                                        <p:tgtEl>
+                                          <p:spTgt spid="7"/>
+                                        </p:tgtEl>
+                                      </p:cBhvr>
+                                    </p:animEffect>
+                                  </p:childTnLst>
+                                </p:cTn>
+                              </p:par>
+                              <p:par>
+                                <p:cTn id="17" presetID="10" presetClass="entr" presetSubtype="0" fill="hold" grpId="0" nodeType="withEffect">
+                                  <p:stCondLst>
+                                    <p:cond delay="1200"/>
+                                  </p:stCondLst>
+                                  <p:childTnLst>
+                                    <p:set>
+                                      <p:cBhvr>
+                                        <p:cTn id="18" dur="1" fill="hold">
+                                          <p:stCondLst>
+                                            <p:cond delay="0"/>
+                                          </p:stCondLst>
+                                        </p:cTn>
+                                        <p:tgtEl>
+                                          <p:spTgt spid="8"/>
+                                        </p:tgtEl>
+                                        <p:attrNameLst>
+                                          <p:attrName>style.visibility</p:attrName>
+                                        </p:attrNameLst>
+                                      </p:cBhvr>
+                                      <p:to>
+                                        <p:strVal val="visible"/>
+                                      </p:to>
+                                    </p:set>
+                                    <p:animEffect transition="in" filter="fade">
+                                      <p:cBhvr>
+                                        <p:cTn id="19" dur="600"/>
+                                        <p:tgtEl>
+                                          <p:spTgt spid="8"/>
+                                        </p:tgtEl>
+                                      </p:cBhvr>
+                                    </p:animEffect>
+                                  </p:childTnLst>
+                                </p:cTn>
+                              </p:par>
+                              <p:par>
+                                <p:cTn id="20" presetID="10" presetClass="entr" presetSubtype="0" fill="hold" grpId="0" nodeType="withEffect">
+                                  <p:stCondLst>
+                                    <p:cond delay="1200"/>
+                                  </p:stCondLst>
+                                  <p:childTnLst>
+                                    <p:set>
+                                      <p:cBhvr>
+                                        <p:cTn id="21" dur="1" fill="hold">
+                                          <p:stCondLst>
+                                            <p:cond delay="0"/>
+                                          </p:stCondLst>
+                                        </p:cTn>
+                                        <p:tgtEl>
+                                          <p:spTgt spid="9"/>
+                                        </p:tgtEl>
+                                        <p:attrNameLst>
+                                          <p:attrName>style.visibility</p:attrName>
+                                        </p:attrNameLst>
+                                      </p:cBhvr>
+                                      <p:to>
+                                        <p:strVal val="visible"/>
+                                      </p:to>
+                                    </p:set>
+                                    <p:animEffect transition="in" filter="fade">
+                                      <p:cBhvr>
+                                        <p:cTn id="22" dur="600"/>
+                                        <p:tgtEl>
+                                          <p:spTgt spid="9"/>
+                                        </p:tgtEl>
+                                      </p:cBhvr>
+                                    </p:animEffect>
+                                  </p:childTnLst>
+                                </p:cTn>
+                              </p:par>
+                              <p:par>
+                                <p:cTn id="23" presetID="10" presetClass="entr" presetSubtype="0" fill="hold" grpId="0" nodeType="withEffect">
+                                  <p:stCondLst>
+                                    <p:cond delay="2400"/>
+                                  </p:stCondLst>
+                                  <p:childTnLst>
+                                    <p:set>
+                                      <p:cBhvr>
+                                        <p:cTn id="24" dur="1" fill="hold">
+                                          <p:stCondLst>
+                                            <p:cond delay="0"/>
+                                          </p:stCondLst>
+                                        </p:cTn>
+                                        <p:tgtEl>
+                                          <p:spTgt spid="10"/>
+                                        </p:tgtEl>
+                                        <p:attrNameLst>
+                                          <p:attrName>style.visibility</p:attrName>
+                                        </p:attrNameLst>
+                                      </p:cBhvr>
+                                      <p:to>
+                                        <p:strVal val="visible"/>
+                                      </p:to>
+                                    </p:set>
+                                    <p:animEffect transition="in" filter="fade">
+                                      <p:cBhvr>
+                                        <p:cTn id="25" dur="600"/>
+                                        <p:tgtEl>
+                                          <p:spTgt spid="10"/>
+                                        </p:tgtEl>
+                                      </p:cBhvr>
+                                    </p:animEffect>
+                                  </p:childTnLst>
+                                </p:cTn>
+                              </p:par>
+                              <p:par>
+                                <p:cTn id="26" presetID="10" presetClass="entr" presetSubtype="0" fill="hold" grpId="0" nodeType="withEffect">
+                                  <p:stCondLst>
+                                    <p:cond delay="2400"/>
+                                  </p:stCondLst>
+                                  <p:childTnLst>
+                                    <p:set>
+                                      <p:cBhvr>
+                                        <p:cTn id="27" dur="1" fill="hold">
+                                          <p:stCondLst>
+                                            <p:cond delay="0"/>
+                                          </p:stCondLst>
+                                        </p:cTn>
+                                        <p:tgtEl>
+                                          <p:spTgt spid="11"/>
+                                        </p:tgtEl>
+                                        <p:attrNameLst>
+                                          <p:attrName>style.visibility</p:attrName>
+                                        </p:attrNameLst>
+                                      </p:cBhvr>
+                                      <p:to>
+                                        <p:strVal val="visible"/>
+                                      </p:to>
+                                    </p:set>
+                                    <p:animEffect transition="in" filter="fade">
+                                      <p:cBhvr>
+                                        <p:cTn id="28" dur="600"/>
+                                        <p:tgtEl>
+                                          <p:spTgt spid="11"/>
+                                        </p:tgtEl>
+                                      </p:cBhvr>
+                                    </p:animEffect>
+                                  </p:childTnLst>
+                                </p:cTn>
+                              </p:par>
+                              <p:par>
+                                <p:cTn id="29" presetID="10" presetClass="entr" presetSubtype="0" fill="hold" grpId="0" nodeType="withEffect">
+                                  <p:stCondLst>
+                                    <p:cond delay="2400"/>
+                                  </p:stCondLst>
+                                  <p:childTnLst>
+                                    <p:set>
+                                      <p:cBhvr>
+                                        <p:cTn id="30" dur="1" fill="hold">
+                                          <p:stCondLst>
+                                            <p:cond delay="0"/>
+                                          </p:stCondLst>
+                                        </p:cTn>
+                                        <p:tgtEl>
+                                          <p:spTgt spid="12"/>
+                                        </p:tgtEl>
+                                        <p:attrNameLst>
+                                          <p:attrName>style.visibility</p:attrName>
+                                        </p:attrNameLst>
+                                      </p:cBhvr>
+                                      <p:to>
+                                        <p:strVal val="visible"/>
+                                      </p:to>
+                                    </p:set>
+                                    <p:animEffect transition="in" filter="fade">
+                                      <p:cBhvr>
+                                        <p:cTn id="31" dur="600"/>
+                                        <p:tgtEl>
+                                          <p:spTgt spid="12"/>
+                                        </p:tgtEl>
+                                      </p:cBhvr>
+                                    </p:animEffect>
+                                  </p:childTnLst>
+                                </p:cTn>
+                              </p:par>
+                              <p:par>
+                                <p:cTn id="32" presetID="10" presetClass="entr" presetSubtype="0" fill="hold" grpId="0" nodeType="withEffect">
+                                  <p:stCondLst>
+                                    <p:cond delay="3600"/>
+                                  </p:stCondLst>
+                                  <p:childTnLst>
+                                    <p:set>
+                                      <p:cBhvr>
+                                        <p:cTn id="33" dur="1" fill="hold">
+                                          <p:stCondLst>
+                                            <p:cond delay="0"/>
+                                          </p:stCondLst>
+                                        </p:cTn>
+                                        <p:tgtEl>
+                                          <p:spTgt spid="13"/>
+                                        </p:tgtEl>
+                                        <p:attrNameLst>
+                                          <p:attrName>style.visibility</p:attrName>
+                                        </p:attrNameLst>
+                                      </p:cBhvr>
+                                      <p:to>
+                                        <p:strVal val="visible"/>
+                                      </p:to>
+                                    </p:set>
+                                    <p:animEffect transition="in" filter="fade">
+                                      <p:cBhvr>
+                                        <p:cTn id="34" dur="600"/>
+                                        <p:tgtEl>
+                                          <p:spTgt spid="13"/>
+                                        </p:tgtEl>
+                                      </p:cBhvr>
+                                    </p:animEffect>
+                                  </p:childTnLst>
+                                </p:cTn>
+                              </p:par>
+                              <p:par>
+                                <p:cTn id="35" presetID="10" presetClass="entr" presetSubtype="0" fill="hold" grpId="0" nodeType="withEffect">
+                                  <p:stCondLst>
+                                    <p:cond delay="3600"/>
+                                  </p:stCondLst>
+                                  <p:childTnLst>
+                                    <p:set>
+                                      <p:cBhvr>
+                                        <p:cTn id="36" dur="1" fill="hold">
+                                          <p:stCondLst>
+                                            <p:cond delay="0"/>
+                                          </p:stCondLst>
+                                        </p:cTn>
+                                        <p:tgtEl>
+                                          <p:spTgt spid="14"/>
+                                        </p:tgtEl>
+                                        <p:attrNameLst>
+                                          <p:attrName>style.visibility</p:attrName>
+                                        </p:attrNameLst>
+                                      </p:cBhvr>
+                                      <p:to>
+                                        <p:strVal val="visible"/>
+                                      </p:to>
+                                    </p:set>
+                                    <p:animEffect transition="in" filter="fade">
+                                      <p:cBhvr>
+                                        <p:cTn id="37" dur="600"/>
+                                        <p:tgtEl>
+                                          <p:spTgt spid="14"/>
+                                        </p:tgtEl>
+                                      </p:cBhvr>
+                                    </p:animEffect>
+                                  </p:childTnLst>
+                                </p:cTn>
+                              </p:par>
+                              <p:par>
+                                <p:cTn id="38" presetID="10" presetClass="entr" presetSubtype="0" fill="hold" grpId="0" nodeType="withEffect">
+                                  <p:stCondLst>
+                                    <p:cond delay="3600"/>
+                                  </p:stCondLst>
+                                  <p:childTnLst>
+                                    <p:set>
+                                      <p:cBhvr>
+                                        <p:cTn id="39" dur="1" fill="hold">
+                                          <p:stCondLst>
+                                            <p:cond delay="0"/>
+                                          </p:stCondLst>
+                                        </p:cTn>
+                                        <p:tgtEl>
+                                          <p:spTgt spid="15"/>
+                                        </p:tgtEl>
+                                        <p:attrNameLst>
+                                          <p:attrName>style.visibility</p:attrName>
+                                        </p:attrNameLst>
+                                      </p:cBhvr>
+                                      <p:to>
+                                        <p:strVal val="visible"/>
+                                      </p:to>
+                                    </p:set>
+                                    <p:animEffect transition="in" filter="fade">
+                                      <p:cBhvr>
+                                        <p:cTn id="40" dur="600"/>
+                                        <p:tgtEl>
+                                          <p:spTgt spid="15"/>
+                                        </p:tgtEl>
+                                      </p:cBhvr>
+                                    </p:animEffect>
+                                  </p:childTnLst>
+                                </p:cTn>
+                              </p:par>
+                            </p:childTnLst>
+                          </p:cTn>
+                        </p:par>
+                      </p:childTnLst>
+                    </p:cTn>
+                  </p:par>
+                </p:childTnLst>
+              </p:cTn>
+              <p:prevCondLst>
+                <p:cond evt="onPrev" delay="0">
+                  <p:tgtEl>
+                    <p:sldTgt/>
+                  </p:tgtEl>
+                </p:cond>
+              </p:prevCondLst>
+              <p:nextCondLst>
+                <p:cond evt="onNext" delay="0">
+                  <p:tgtEl>
+                    <p:sldTgt/>
+                  </p:tgtEl>
+                </p:cond>
+              </p:nextCondLst>
+            </p:seq>
+          </p:childTnLst>
+        </p:cTn>
+      </p:par>
+    </p:tnLst>
+  </p:timing>
 </p:sld>
 </file>
 
@@ -19875,6 +20343,754 @@
       </p:transition>
     </mc:Fallback>
   </mc:AlternateContent>
+  <p:timing>
+    <p:tnLst>
+      <p:par>
+        <p:cTn id="1" dur="indefinite" restart="never" nodeType="tmRoot">
+          <p:childTnLst>
+            <p:seq concurrent="1" nextAc="seek">
+              <p:cTn id="2" dur="indefinite" nodeType="mainSeq">
+                <p:childTnLst>
+                  <p:par>
+                    <p:cTn id="3" fill="hold">
+                      <p:stCondLst>
+                        <p:cond delay="0"/>
+                      </p:stCondLst>
+                      <p:childTnLst>
+                        <p:par>
+                          <p:cTn id="4" fill="hold">
+                            <p:stCondLst>
+                              <p:cond delay="0"/>
+                            </p:stCondLst>
+                            <p:childTnLst>
+                              <p:par>
+                                <p:cTn id="5" presetID="10" presetClass="entr" presetSubtype="0" fill="hold" grpId="0" nodeType="withEffect">
+                                  <p:stCondLst>
+                                    <p:cond delay="0"/>
+                                  </p:stCondLst>
+                                  <p:childTnLst>
+                                    <p:set>
+                                      <p:cBhvr>
+                                        <p:cTn id="6" dur="1" fill="hold">
+                                          <p:stCondLst>
+                                            <p:cond delay="0"/>
+                                          </p:stCondLst>
+                                        </p:cTn>
+                                        <p:tgtEl>
+                                          <p:spTgt spid="6"/>
+                                        </p:tgtEl>
+                                        <p:attrNameLst>
+                                          <p:attrName>style.visibility</p:attrName>
+                                        </p:attrNameLst>
+                                      </p:cBhvr>
+                                      <p:to>
+                                        <p:strVal val="visible"/>
+                                      </p:to>
+                                    </p:set>
+                                    <p:animEffect transition="in" filter="fade">
+                                      <p:cBhvr>
+                                        <p:cTn id="7" dur="450"/>
+                                        <p:tgtEl>
+                                          <p:spTgt spid="6"/>
+                                        </p:tgtEl>
+                                      </p:cBhvr>
+                                    </p:animEffect>
+                                  </p:childTnLst>
+                                </p:cTn>
+                              </p:par>
+                              <p:par>
+                                <p:cTn id="8" presetID="10" presetClass="entr" presetSubtype="0" fill="hold" grpId="0" nodeType="withEffect">
+                                  <p:stCondLst>
+                                    <p:cond delay="0"/>
+                                  </p:stCondLst>
+                                  <p:childTnLst>
+                                    <p:set>
+                                      <p:cBhvr>
+                                        <p:cTn id="9" dur="1" fill="hold">
+                                          <p:stCondLst>
+                                            <p:cond delay="0"/>
+                                          </p:stCondLst>
+                                        </p:cTn>
+                                        <p:tgtEl>
+                                          <p:spTgt spid="7"/>
+                                        </p:tgtEl>
+                                        <p:attrNameLst>
+                                          <p:attrName>style.visibility</p:attrName>
+                                        </p:attrNameLst>
+                                      </p:cBhvr>
+                                      <p:to>
+                                        <p:strVal val="visible"/>
+                                      </p:to>
+                                    </p:set>
+                                    <p:animEffect transition="in" filter="fade">
+                                      <p:cBhvr>
+                                        <p:cTn id="10" dur="450"/>
+                                        <p:tgtEl>
+                                          <p:spTgt spid="7"/>
+                                        </p:tgtEl>
+                                      </p:cBhvr>
+                                    </p:animEffect>
+                                  </p:childTnLst>
+                                </p:cTn>
+                              </p:par>
+                              <p:par>
+                                <p:cTn id="11" presetID="10" presetClass="entr" presetSubtype="0" fill="hold" grpId="0" nodeType="withEffect">
+                                  <p:stCondLst>
+                                    <p:cond delay="0"/>
+                                  </p:stCondLst>
+                                  <p:childTnLst>
+                                    <p:set>
+                                      <p:cBhvr>
+                                        <p:cTn id="12" dur="1" fill="hold">
+                                          <p:stCondLst>
+                                            <p:cond delay="0"/>
+                                          </p:stCondLst>
+                                        </p:cTn>
+                                        <p:tgtEl>
+                                          <p:spTgt spid="8"/>
+                                        </p:tgtEl>
+                                        <p:attrNameLst>
+                                          <p:attrName>style.visibility</p:attrName>
+                                        </p:attrNameLst>
+                                      </p:cBhvr>
+                                      <p:to>
+                                        <p:strVal val="visible"/>
+                                      </p:to>
+                                    </p:set>
+                                    <p:animEffect transition="in" filter="fade">
+                                      <p:cBhvr>
+                                        <p:cTn id="13" dur="450"/>
+                                        <p:tgtEl>
+                                          <p:spTgt spid="8"/>
+                                        </p:tgtEl>
+                                      </p:cBhvr>
+                                    </p:animEffect>
+                                  </p:childTnLst>
+                                </p:cTn>
+                              </p:par>
+                              <p:par>
+                                <p:cTn id="14" presetID="10" presetClass="entr" presetSubtype="0" fill="hold" grpId="0" nodeType="withEffect">
+                                  <p:stCondLst>
+                                    <p:cond delay="0"/>
+                                  </p:stCondLst>
+                                  <p:childTnLst>
+                                    <p:set>
+                                      <p:cBhvr>
+                                        <p:cTn id="15" dur="1" fill="hold">
+                                          <p:stCondLst>
+                                            <p:cond delay="0"/>
+                                          </p:stCondLst>
+                                        </p:cTn>
+                                        <p:tgtEl>
+                                          <p:spTgt spid="9"/>
+                                        </p:tgtEl>
+                                        <p:attrNameLst>
+                                          <p:attrName>style.visibility</p:attrName>
+                                        </p:attrNameLst>
+                                      </p:cBhvr>
+                                      <p:to>
+                                        <p:strVal val="visible"/>
+                                      </p:to>
+                                    </p:set>
+                                    <p:animEffect transition="in" filter="fade">
+                                      <p:cBhvr>
+                                        <p:cTn id="16" dur="450"/>
+                                        <p:tgtEl>
+                                          <p:spTgt spid="9"/>
+                                        </p:tgtEl>
+                                      </p:cBhvr>
+                                    </p:animEffect>
+                                  </p:childTnLst>
+                                </p:cTn>
+                              </p:par>
+                              <p:par>
+                                <p:cTn id="17" presetID="10" presetClass="entr" presetSubtype="0" fill="hold" grpId="0" nodeType="withEffect">
+                                  <p:stCondLst>
+                                    <p:cond delay="0"/>
+                                  </p:stCondLst>
+                                  <p:childTnLst>
+                                    <p:set>
+                                      <p:cBhvr>
+                                        <p:cTn id="18" dur="1" fill="hold">
+                                          <p:stCondLst>
+                                            <p:cond delay="0"/>
+                                          </p:stCondLst>
+                                        </p:cTn>
+                                        <p:tgtEl>
+                                          <p:spTgt spid="10"/>
+                                        </p:tgtEl>
+                                        <p:attrNameLst>
+                                          <p:attrName>style.visibility</p:attrName>
+                                        </p:attrNameLst>
+                                      </p:cBhvr>
+                                      <p:to>
+                                        <p:strVal val="visible"/>
+                                      </p:to>
+                                    </p:set>
+                                    <p:animEffect transition="in" filter="fade">
+                                      <p:cBhvr>
+                                        <p:cTn id="19" dur="450"/>
+                                        <p:tgtEl>
+                                          <p:spTgt spid="10"/>
+                                        </p:tgtEl>
+                                      </p:cBhvr>
+                                    </p:animEffect>
+                                  </p:childTnLst>
+                                </p:cTn>
+                              </p:par>
+                              <p:par>
+                                <p:cTn id="20" presetID="10" presetClass="entr" presetSubtype="0" fill="hold" grpId="0" nodeType="withEffect">
+                                  <p:stCondLst>
+                                    <p:cond delay="0"/>
+                                  </p:stCondLst>
+                                  <p:childTnLst>
+                                    <p:set>
+                                      <p:cBhvr>
+                                        <p:cTn id="21" dur="1" fill="hold">
+                                          <p:stCondLst>
+                                            <p:cond delay="0"/>
+                                          </p:stCondLst>
+                                        </p:cTn>
+                                        <p:tgtEl>
+                                          <p:spTgt spid="11"/>
+                                        </p:tgtEl>
+                                        <p:attrNameLst>
+                                          <p:attrName>style.visibility</p:attrName>
+                                        </p:attrNameLst>
+                                      </p:cBhvr>
+                                      <p:to>
+                                        <p:strVal val="visible"/>
+                                      </p:to>
+                                    </p:set>
+                                    <p:animEffect transition="in" filter="fade">
+                                      <p:cBhvr>
+                                        <p:cTn id="22" dur="450"/>
+                                        <p:tgtEl>
+                                          <p:spTgt spid="11"/>
+                                        </p:tgtEl>
+                                      </p:cBhvr>
+                                    </p:animEffect>
+                                  </p:childTnLst>
+                                </p:cTn>
+                              </p:par>
+                              <p:par>
+                                <p:cTn id="23" presetID="10" presetClass="entr" presetSubtype="0" fill="hold" grpId="0" nodeType="withEffect">
+                                  <p:stCondLst>
+                                    <p:cond delay="180"/>
+                                  </p:stCondLst>
+                                  <p:childTnLst>
+                                    <p:set>
+                                      <p:cBhvr>
+                                        <p:cTn id="24" dur="1" fill="hold">
+                                          <p:stCondLst>
+                                            <p:cond delay="0"/>
+                                          </p:stCondLst>
+                                        </p:cTn>
+                                        <p:tgtEl>
+                                          <p:spTgt spid="12"/>
+                                        </p:tgtEl>
+                                        <p:attrNameLst>
+                                          <p:attrName>style.visibility</p:attrName>
+                                        </p:attrNameLst>
+                                      </p:cBhvr>
+                                      <p:to>
+                                        <p:strVal val="visible"/>
+                                      </p:to>
+                                    </p:set>
+                                    <p:animEffect transition="in" filter="fade">
+                                      <p:cBhvr>
+                                        <p:cTn id="25" dur="450"/>
+                                        <p:tgtEl>
+                                          <p:spTgt spid="12"/>
+                                        </p:tgtEl>
+                                      </p:cBhvr>
+                                    </p:animEffect>
+                                  </p:childTnLst>
+                                </p:cTn>
+                              </p:par>
+                              <p:par>
+                                <p:cTn id="26" presetID="10" presetClass="entr" presetSubtype="0" fill="hold" grpId="0" nodeType="withEffect">
+                                  <p:stCondLst>
+                                    <p:cond delay="180"/>
+                                  </p:stCondLst>
+                                  <p:childTnLst>
+                                    <p:set>
+                                      <p:cBhvr>
+                                        <p:cTn id="27" dur="1" fill="hold">
+                                          <p:stCondLst>
+                                            <p:cond delay="0"/>
+                                          </p:stCondLst>
+                                        </p:cTn>
+                                        <p:tgtEl>
+                                          <p:spTgt spid="13"/>
+                                        </p:tgtEl>
+                                        <p:attrNameLst>
+                                          <p:attrName>style.visibility</p:attrName>
+                                        </p:attrNameLst>
+                                      </p:cBhvr>
+                                      <p:to>
+                                        <p:strVal val="visible"/>
+                                      </p:to>
+                                    </p:set>
+                                    <p:animEffect transition="in" filter="fade">
+                                      <p:cBhvr>
+                                        <p:cTn id="28" dur="450"/>
+                                        <p:tgtEl>
+                                          <p:spTgt spid="13"/>
+                                        </p:tgtEl>
+                                      </p:cBhvr>
+                                    </p:animEffect>
+                                  </p:childTnLst>
+                                </p:cTn>
+                              </p:par>
+                              <p:par>
+                                <p:cTn id="29" presetID="10" presetClass="entr" presetSubtype="0" fill="hold" grpId="0" nodeType="withEffect">
+                                  <p:stCondLst>
+                                    <p:cond delay="180"/>
+                                  </p:stCondLst>
+                                  <p:childTnLst>
+                                    <p:set>
+                                      <p:cBhvr>
+                                        <p:cTn id="30" dur="1" fill="hold">
+                                          <p:stCondLst>
+                                            <p:cond delay="0"/>
+                                          </p:stCondLst>
+                                        </p:cTn>
+                                        <p:tgtEl>
+                                          <p:spTgt spid="14"/>
+                                        </p:tgtEl>
+                                        <p:attrNameLst>
+                                          <p:attrName>style.visibility</p:attrName>
+                                        </p:attrNameLst>
+                                      </p:cBhvr>
+                                      <p:to>
+                                        <p:strVal val="visible"/>
+                                      </p:to>
+                                    </p:set>
+                                    <p:animEffect transition="in" filter="fade">
+                                      <p:cBhvr>
+                                        <p:cTn id="31" dur="450"/>
+                                        <p:tgtEl>
+                                          <p:spTgt spid="14"/>
+                                        </p:tgtEl>
+                                      </p:cBhvr>
+                                    </p:animEffect>
+                                  </p:childTnLst>
+                                </p:cTn>
+                              </p:par>
+                              <p:par>
+                                <p:cTn id="32" presetID="10" presetClass="entr" presetSubtype="0" fill="hold" grpId="0" nodeType="withEffect">
+                                  <p:stCondLst>
+                                    <p:cond delay="180"/>
+                                  </p:stCondLst>
+                                  <p:childTnLst>
+                                    <p:set>
+                                      <p:cBhvr>
+                                        <p:cTn id="33" dur="1" fill="hold">
+                                          <p:stCondLst>
+                                            <p:cond delay="0"/>
+                                          </p:stCondLst>
+                                        </p:cTn>
+                                        <p:tgtEl>
+                                          <p:spTgt spid="15"/>
+                                        </p:tgtEl>
+                                        <p:attrNameLst>
+                                          <p:attrName>style.visibility</p:attrName>
+                                        </p:attrNameLst>
+                                      </p:cBhvr>
+                                      <p:to>
+                                        <p:strVal val="visible"/>
+                                      </p:to>
+                                    </p:set>
+                                    <p:animEffect transition="in" filter="fade">
+                                      <p:cBhvr>
+                                        <p:cTn id="34" dur="450"/>
+                                        <p:tgtEl>
+                                          <p:spTgt spid="15"/>
+                                        </p:tgtEl>
+                                      </p:cBhvr>
+                                    </p:animEffect>
+                                  </p:childTnLst>
+                                </p:cTn>
+                              </p:par>
+                              <p:par>
+                                <p:cTn id="35" presetID="10" presetClass="entr" presetSubtype="0" fill="hold" grpId="0" nodeType="withEffect">
+                                  <p:stCondLst>
+                                    <p:cond delay="180"/>
+                                  </p:stCondLst>
+                                  <p:childTnLst>
+                                    <p:set>
+                                      <p:cBhvr>
+                                        <p:cTn id="36" dur="1" fill="hold">
+                                          <p:stCondLst>
+                                            <p:cond delay="0"/>
+                                          </p:stCondLst>
+                                        </p:cTn>
+                                        <p:tgtEl>
+                                          <p:spTgt spid="16"/>
+                                        </p:tgtEl>
+                                        <p:attrNameLst>
+                                          <p:attrName>style.visibility</p:attrName>
+                                        </p:attrNameLst>
+                                      </p:cBhvr>
+                                      <p:to>
+                                        <p:strVal val="visible"/>
+                                      </p:to>
+                                    </p:set>
+                                    <p:animEffect transition="in" filter="fade">
+                                      <p:cBhvr>
+                                        <p:cTn id="37" dur="450"/>
+                                        <p:tgtEl>
+                                          <p:spTgt spid="16"/>
+                                        </p:tgtEl>
+                                      </p:cBhvr>
+                                    </p:animEffect>
+                                  </p:childTnLst>
+                                </p:cTn>
+                              </p:par>
+                              <p:par>
+                                <p:cTn id="38" presetID="10" presetClass="entr" presetSubtype="0" fill="hold" grpId="0" nodeType="withEffect">
+                                  <p:stCondLst>
+                                    <p:cond delay="180"/>
+                                  </p:stCondLst>
+                                  <p:childTnLst>
+                                    <p:set>
+                                      <p:cBhvr>
+                                        <p:cTn id="39" dur="1" fill="hold">
+                                          <p:stCondLst>
+                                            <p:cond delay="0"/>
+                                          </p:stCondLst>
+                                        </p:cTn>
+                                        <p:tgtEl>
+                                          <p:spTgt spid="17"/>
+                                        </p:tgtEl>
+                                        <p:attrNameLst>
+                                          <p:attrName>style.visibility</p:attrName>
+                                        </p:attrNameLst>
+                                      </p:cBhvr>
+                                      <p:to>
+                                        <p:strVal val="visible"/>
+                                      </p:to>
+                                    </p:set>
+                                    <p:animEffect transition="in" filter="fade">
+                                      <p:cBhvr>
+                                        <p:cTn id="40" dur="450"/>
+                                        <p:tgtEl>
+                                          <p:spTgt spid="17"/>
+                                        </p:tgtEl>
+                                      </p:cBhvr>
+                                    </p:animEffect>
+                                  </p:childTnLst>
+                                </p:cTn>
+                              </p:par>
+                              <p:par>
+                                <p:cTn id="41" presetID="10" presetClass="entr" presetSubtype="0" fill="hold" grpId="0" nodeType="withEffect">
+                                  <p:stCondLst>
+                                    <p:cond delay="550"/>
+                                  </p:stCondLst>
+                                  <p:childTnLst>
+                                    <p:set>
+                                      <p:cBhvr>
+                                        <p:cTn id="42" dur="1" fill="hold">
+                                          <p:stCondLst>
+                                            <p:cond delay="0"/>
+                                          </p:stCondLst>
+                                        </p:cTn>
+                                        <p:tgtEl>
+                                          <p:spTgt spid="18"/>
+                                        </p:tgtEl>
+                                        <p:attrNameLst>
+                                          <p:attrName>style.visibility</p:attrName>
+                                        </p:attrNameLst>
+                                      </p:cBhvr>
+                                      <p:to>
+                                        <p:strVal val="visible"/>
+                                      </p:to>
+                                    </p:set>
+                                    <p:animEffect transition="in" filter="fade">
+                                      <p:cBhvr>
+                                        <p:cTn id="43" dur="500"/>
+                                        <p:tgtEl>
+                                          <p:spTgt spid="18"/>
+                                        </p:tgtEl>
+                                      </p:cBhvr>
+                                    </p:animEffect>
+                                  </p:childTnLst>
+                                </p:cTn>
+                              </p:par>
+                              <p:par>
+                                <p:cTn id="44" presetID="10" presetClass="entr" presetSubtype="0" fill="hold" grpId="0" nodeType="withEffect">
+                                  <p:stCondLst>
+                                    <p:cond delay="550"/>
+                                  </p:stCondLst>
+                                  <p:childTnLst>
+                                    <p:set>
+                                      <p:cBhvr>
+                                        <p:cTn id="45" dur="1" fill="hold">
+                                          <p:stCondLst>
+                                            <p:cond delay="0"/>
+                                          </p:stCondLst>
+                                        </p:cTn>
+                                        <p:tgtEl>
+                                          <p:spTgt spid="19"/>
+                                        </p:tgtEl>
+                                        <p:attrNameLst>
+                                          <p:attrName>style.visibility</p:attrName>
+                                        </p:attrNameLst>
+                                      </p:cBhvr>
+                                      <p:to>
+                                        <p:strVal val="visible"/>
+                                      </p:to>
+                                    </p:set>
+                                    <p:animEffect transition="in" filter="fade">
+                                      <p:cBhvr>
+                                        <p:cTn id="46" dur="500"/>
+                                        <p:tgtEl>
+                                          <p:spTgt spid="19"/>
+                                        </p:tgtEl>
+                                      </p:cBhvr>
+                                    </p:animEffect>
+                                  </p:childTnLst>
+                                </p:cTn>
+                              </p:par>
+                              <p:par>
+                                <p:cTn id="47" presetID="10" presetClass="entr" presetSubtype="0" fill="hold" grpId="0" nodeType="withEffect">
+                                  <p:stCondLst>
+                                    <p:cond delay="550"/>
+                                  </p:stCondLst>
+                                  <p:childTnLst>
+                                    <p:set>
+                                      <p:cBhvr>
+                                        <p:cTn id="48" dur="1" fill="hold">
+                                          <p:stCondLst>
+                                            <p:cond delay="0"/>
+                                          </p:stCondLst>
+                                        </p:cTn>
+                                        <p:tgtEl>
+                                          <p:spTgt spid="20"/>
+                                        </p:tgtEl>
+                                        <p:attrNameLst>
+                                          <p:attrName>style.visibility</p:attrName>
+                                        </p:attrNameLst>
+                                      </p:cBhvr>
+                                      <p:to>
+                                        <p:strVal val="visible"/>
+                                      </p:to>
+                                    </p:set>
+                                    <p:animEffect transition="in" filter="fade">
+                                      <p:cBhvr>
+                                        <p:cTn id="49" dur="500"/>
+                                        <p:tgtEl>
+                                          <p:spTgt spid="20"/>
+                                        </p:tgtEl>
+                                      </p:cBhvr>
+                                    </p:animEffect>
+                                  </p:childTnLst>
+                                </p:cTn>
+                              </p:par>
+                              <p:par>
+                                <p:cTn id="50" presetID="10" presetClass="entr" presetSubtype="0" fill="hold" grpId="0" nodeType="withEffect">
+                                  <p:stCondLst>
+                                    <p:cond delay="550"/>
+                                  </p:stCondLst>
+                                  <p:childTnLst>
+                                    <p:set>
+                                      <p:cBhvr>
+                                        <p:cTn id="51" dur="1" fill="hold">
+                                          <p:stCondLst>
+                                            <p:cond delay="0"/>
+                                          </p:stCondLst>
+                                        </p:cTn>
+                                        <p:tgtEl>
+                                          <p:spTgt spid="21"/>
+                                        </p:tgtEl>
+                                        <p:attrNameLst>
+                                          <p:attrName>style.visibility</p:attrName>
+                                        </p:attrNameLst>
+                                      </p:cBhvr>
+                                      <p:to>
+                                        <p:strVal val="visible"/>
+                                      </p:to>
+                                    </p:set>
+                                    <p:animEffect transition="in" filter="fade">
+                                      <p:cBhvr>
+                                        <p:cTn id="52" dur="500"/>
+                                        <p:tgtEl>
+                                          <p:spTgt spid="21"/>
+                                        </p:tgtEl>
+                                      </p:cBhvr>
+                                    </p:animEffect>
+                                  </p:childTnLst>
+                                </p:cTn>
+                              </p:par>
+                              <p:par>
+                                <p:cTn id="53" presetID="10" presetClass="entr" presetSubtype="0" fill="hold" grpId="0" nodeType="withEffect">
+                                  <p:stCondLst>
+                                    <p:cond delay="550"/>
+                                  </p:stCondLst>
+                                  <p:childTnLst>
+                                    <p:set>
+                                      <p:cBhvr>
+                                        <p:cTn id="54" dur="1" fill="hold">
+                                          <p:stCondLst>
+                                            <p:cond delay="0"/>
+                                          </p:stCondLst>
+                                        </p:cTn>
+                                        <p:tgtEl>
+                                          <p:spTgt spid="22"/>
+                                        </p:tgtEl>
+                                        <p:attrNameLst>
+                                          <p:attrName>style.visibility</p:attrName>
+                                        </p:attrNameLst>
+                                      </p:cBhvr>
+                                      <p:to>
+                                        <p:strVal val="visible"/>
+                                      </p:to>
+                                    </p:set>
+                                    <p:animEffect transition="in" filter="fade">
+                                      <p:cBhvr>
+                                        <p:cTn id="55" dur="500"/>
+                                        <p:tgtEl>
+                                          <p:spTgt spid="22"/>
+                                        </p:tgtEl>
+                                      </p:cBhvr>
+                                    </p:animEffect>
+                                  </p:childTnLst>
+                                </p:cTn>
+                              </p:par>
+                              <p:par>
+                                <p:cTn id="56" presetID="10" presetClass="entr" presetSubtype="0" fill="hold" grpId="0" nodeType="withEffect">
+                                  <p:stCondLst>
+                                    <p:cond delay="550"/>
+                                  </p:stCondLst>
+                                  <p:childTnLst>
+                                    <p:set>
+                                      <p:cBhvr>
+                                        <p:cTn id="57" dur="1" fill="hold">
+                                          <p:stCondLst>
+                                            <p:cond delay="0"/>
+                                          </p:stCondLst>
+                                        </p:cTn>
+                                        <p:tgtEl>
+                                          <p:spTgt spid="23"/>
+                                        </p:tgtEl>
+                                        <p:attrNameLst>
+                                          <p:attrName>style.visibility</p:attrName>
+                                        </p:attrNameLst>
+                                      </p:cBhvr>
+                                      <p:to>
+                                        <p:strVal val="visible"/>
+                                      </p:to>
+                                    </p:set>
+                                    <p:animEffect transition="in" filter="fade">
+                                      <p:cBhvr>
+                                        <p:cTn id="58" dur="500"/>
+                                        <p:tgtEl>
+                                          <p:spTgt spid="23"/>
+                                        </p:tgtEl>
+                                      </p:cBhvr>
+                                    </p:animEffect>
+                                  </p:childTnLst>
+                                </p:cTn>
+                              </p:par>
+                              <p:par>
+                                <p:cTn id="59" presetID="10" presetClass="entr" presetSubtype="0" fill="hold" grpId="0" nodeType="withEffect">
+                                  <p:stCondLst>
+                                    <p:cond delay="800"/>
+                                  </p:stCondLst>
+                                  <p:childTnLst>
+                                    <p:set>
+                                      <p:cBhvr>
+                                        <p:cTn id="60" dur="1" fill="hold">
+                                          <p:stCondLst>
+                                            <p:cond delay="0"/>
+                                          </p:stCondLst>
+                                        </p:cTn>
+                                        <p:tgtEl>
+                                          <p:spTgt spid="4"/>
+                                        </p:tgtEl>
+                                        <p:attrNameLst>
+                                          <p:attrName>style.visibility</p:attrName>
+                                        </p:attrNameLst>
+                                      </p:cBhvr>
+                                      <p:to>
+                                        <p:strVal val="visible"/>
+                                      </p:to>
+                                    </p:set>
+                                    <p:animEffect transition="in" filter="fade">
+                                      <p:cBhvr>
+                                        <p:cTn id="61" dur="400"/>
+                                        <p:tgtEl>
+                                          <p:spTgt spid="4"/>
+                                        </p:tgtEl>
+                                      </p:cBhvr>
+                                    </p:animEffect>
+                                  </p:childTnLst>
+                                </p:cTn>
+                              </p:par>
+                              <p:par>
+                                <p:cTn id="62" presetID="10" presetClass="entr" presetSubtype="0" fill="hold" grpId="0" nodeType="withEffect">
+                                  <p:stCondLst>
+                                    <p:cond delay="800"/>
+                                  </p:stCondLst>
+                                  <p:childTnLst>
+                                    <p:set>
+                                      <p:cBhvr>
+                                        <p:cTn id="63" dur="1" fill="hold">
+                                          <p:stCondLst>
+                                            <p:cond delay="0"/>
+                                          </p:stCondLst>
+                                        </p:cTn>
+                                        <p:tgtEl>
+                                          <p:spTgt spid="5"/>
+                                        </p:tgtEl>
+                                        <p:attrNameLst>
+                                          <p:attrName>style.visibility</p:attrName>
+                                        </p:attrNameLst>
+                                      </p:cBhvr>
+                                      <p:to>
+                                        <p:strVal val="visible"/>
+                                      </p:to>
+                                    </p:set>
+                                    <p:animEffect transition="in" filter="fade">
+                                      <p:cBhvr>
+                                        <p:cTn id="64" dur="400"/>
+                                        <p:tgtEl>
+                                          <p:spTgt spid="5"/>
+                                        </p:tgtEl>
+                                      </p:cBhvr>
+                                    </p:animEffect>
+                                  </p:childTnLst>
+                                </p:cTn>
+                              </p:par>
+                            </p:childTnLst>
+                          </p:cTn>
+                        </p:par>
+                      </p:childTnLst>
+                    </p:cTn>
+                  </p:par>
+                </p:childTnLst>
+              </p:cTn>
+              <p:prevCondLst>
+                <p:cond evt="onPrev" delay="0">
+                  <p:tgtEl>
+                    <p:sldTgt/>
+                  </p:tgtEl>
+                </p:cond>
+              </p:prevCondLst>
+              <p:nextCondLst>
+                <p:cond evt="onNext" delay="0">
+                  <p:tgtEl>
+                    <p:sldTgt/>
+                  </p:tgtEl>
+                </p:cond>
+              </p:nextCondLst>
+            </p:seq>
+          </p:childTnLst>
+        </p:cTn>
+      </p:par>
+    </p:tnLst>
+  </p:timing>
 </p:sld>
 </file>
 
@@ -22884,6 +24100,1594 @@
       </p:transition>
     </mc:Fallback>
   </mc:AlternateContent>
+  <p:timing>
+    <p:tnLst>
+      <p:par>
+        <p:cTn id="1" dur="indefinite" restart="never" nodeType="tmRoot">
+          <p:childTnLst>
+            <p:seq concurrent="1" nextAc="seek">
+              <p:cTn id="2" dur="indefinite" nodeType="mainSeq">
+                <p:childTnLst>
+                  <p:par>
+                    <p:cTn id="3" fill="hold">
+                      <p:stCondLst>
+                        <p:cond delay="0"/>
+                      </p:stCondLst>
+                      <p:childTnLst>
+                        <p:par>
+                          <p:cTn id="4" fill="hold">
+                            <p:stCondLst>
+                              <p:cond delay="0"/>
+                            </p:stCondLst>
+                            <p:childTnLst>
+                              <p:par>
+                                <p:cTn id="5" presetID="10" presetClass="entr" presetSubtype="0" fill="hold" grpId="0" nodeType="withEffect">
+                                  <p:stCondLst>
+                                    <p:cond delay="150"/>
+                                  </p:stCondLst>
+                                  <p:childTnLst>
+                                    <p:set>
+                                      <p:cBhvr>
+                                        <p:cTn id="6" dur="1" fill="hold">
+                                          <p:stCondLst>
+                                            <p:cond delay="0"/>
+                                          </p:stCondLst>
+                                        </p:cTn>
+                                        <p:tgtEl>
+                                          <p:spTgt spid="6"/>
+                                        </p:tgtEl>
+                                        <p:attrNameLst>
+                                          <p:attrName>style.visibility</p:attrName>
+                                        </p:attrNameLst>
+                                      </p:cBhvr>
+                                      <p:to>
+                                        <p:strVal val="visible"/>
+                                      </p:to>
+                                    </p:set>
+                                    <p:animEffect transition="in" filter="fade">
+                                      <p:cBhvr>
+                                        <p:cTn id="7" dur="450"/>
+                                        <p:tgtEl>
+                                          <p:spTgt spid="6"/>
+                                        </p:tgtEl>
+                                      </p:cBhvr>
+                                    </p:animEffect>
+                                  </p:childTnLst>
+                                </p:cTn>
+                              </p:par>
+                              <p:par>
+                                <p:cTn id="8" presetID="10" presetClass="entr" presetSubtype="0" fill="hold" grpId="0" nodeType="withEffect">
+                                  <p:stCondLst>
+                                    <p:cond delay="185"/>
+                                  </p:stCondLst>
+                                  <p:childTnLst>
+                                    <p:set>
+                                      <p:cBhvr>
+                                        <p:cTn id="9" dur="1" fill="hold">
+                                          <p:stCondLst>
+                                            <p:cond delay="0"/>
+                                          </p:stCondLst>
+                                        </p:cTn>
+                                        <p:tgtEl>
+                                          <p:spTgt spid="7"/>
+                                        </p:tgtEl>
+                                        <p:attrNameLst>
+                                          <p:attrName>style.visibility</p:attrName>
+                                        </p:attrNameLst>
+                                      </p:cBhvr>
+                                      <p:to>
+                                        <p:strVal val="visible"/>
+                                      </p:to>
+                                    </p:set>
+                                    <p:animEffect transition="in" filter="fade">
+                                      <p:cBhvr>
+                                        <p:cTn id="10" dur="450"/>
+                                        <p:tgtEl>
+                                          <p:spTgt spid="7"/>
+                                        </p:tgtEl>
+                                      </p:cBhvr>
+                                    </p:animEffect>
+                                  </p:childTnLst>
+                                </p:cTn>
+                              </p:par>
+                              <p:par>
+                                <p:cTn id="11" presetID="10" presetClass="entr" presetSubtype="0" fill="hold" grpId="0" nodeType="withEffect">
+                                  <p:stCondLst>
+                                    <p:cond delay="220"/>
+                                  </p:stCondLst>
+                                  <p:childTnLst>
+                                    <p:set>
+                                      <p:cBhvr>
+                                        <p:cTn id="12" dur="1" fill="hold">
+                                          <p:stCondLst>
+                                            <p:cond delay="0"/>
+                                          </p:stCondLst>
+                                        </p:cTn>
+                                        <p:tgtEl>
+                                          <p:spTgt spid="8"/>
+                                        </p:tgtEl>
+                                        <p:attrNameLst>
+                                          <p:attrName>style.visibility</p:attrName>
+                                        </p:attrNameLst>
+                                      </p:cBhvr>
+                                      <p:to>
+                                        <p:strVal val="visible"/>
+                                      </p:to>
+                                    </p:set>
+                                    <p:animEffect transition="in" filter="fade">
+                                      <p:cBhvr>
+                                        <p:cTn id="13" dur="450"/>
+                                        <p:tgtEl>
+                                          <p:spTgt spid="8"/>
+                                        </p:tgtEl>
+                                      </p:cBhvr>
+                                    </p:animEffect>
+                                  </p:childTnLst>
+                                </p:cTn>
+                              </p:par>
+                              <p:par>
+                                <p:cTn id="14" presetID="10" presetClass="entr" presetSubtype="0" fill="hold" grpId="0" nodeType="withEffect">
+                                  <p:stCondLst>
+                                    <p:cond delay="255"/>
+                                  </p:stCondLst>
+                                  <p:childTnLst>
+                                    <p:set>
+                                      <p:cBhvr>
+                                        <p:cTn id="15" dur="1" fill="hold">
+                                          <p:stCondLst>
+                                            <p:cond delay="0"/>
+                                          </p:stCondLst>
+                                        </p:cTn>
+                                        <p:tgtEl>
+                                          <p:spTgt spid="9"/>
+                                        </p:tgtEl>
+                                        <p:attrNameLst>
+                                          <p:attrName>style.visibility</p:attrName>
+                                        </p:attrNameLst>
+                                      </p:cBhvr>
+                                      <p:to>
+                                        <p:strVal val="visible"/>
+                                      </p:to>
+                                    </p:set>
+                                    <p:animEffect transition="in" filter="fade">
+                                      <p:cBhvr>
+                                        <p:cTn id="16" dur="450"/>
+                                        <p:tgtEl>
+                                          <p:spTgt spid="9"/>
+                                        </p:tgtEl>
+                                      </p:cBhvr>
+                                    </p:animEffect>
+                                  </p:childTnLst>
+                                </p:cTn>
+                              </p:par>
+                              <p:par>
+                                <p:cTn id="17" presetID="10" presetClass="entr" presetSubtype="0" fill="hold" grpId="0" nodeType="withEffect">
+                                  <p:stCondLst>
+                                    <p:cond delay="290"/>
+                                  </p:stCondLst>
+                                  <p:childTnLst>
+                                    <p:set>
+                                      <p:cBhvr>
+                                        <p:cTn id="18" dur="1" fill="hold">
+                                          <p:stCondLst>
+                                            <p:cond delay="0"/>
+                                          </p:stCondLst>
+                                        </p:cTn>
+                                        <p:tgtEl>
+                                          <p:spTgt spid="10"/>
+                                        </p:tgtEl>
+                                        <p:attrNameLst>
+                                          <p:attrName>style.visibility</p:attrName>
+                                        </p:attrNameLst>
+                                      </p:cBhvr>
+                                      <p:to>
+                                        <p:strVal val="visible"/>
+                                      </p:to>
+                                    </p:set>
+                                    <p:animEffect transition="in" filter="fade">
+                                      <p:cBhvr>
+                                        <p:cTn id="19" dur="450"/>
+                                        <p:tgtEl>
+                                          <p:spTgt spid="10"/>
+                                        </p:tgtEl>
+                                      </p:cBhvr>
+                                    </p:animEffect>
+                                  </p:childTnLst>
+                                </p:cTn>
+                              </p:par>
+                              <p:par>
+                                <p:cTn id="20" presetID="10" presetClass="entr" presetSubtype="0" fill="hold" grpId="0" nodeType="withEffect">
+                                  <p:stCondLst>
+                                    <p:cond delay="325"/>
+                                  </p:stCondLst>
+                                  <p:childTnLst>
+                                    <p:set>
+                                      <p:cBhvr>
+                                        <p:cTn id="21" dur="1" fill="hold">
+                                          <p:stCondLst>
+                                            <p:cond delay="0"/>
+                                          </p:stCondLst>
+                                        </p:cTn>
+                                        <p:tgtEl>
+                                          <p:spTgt spid="11"/>
+                                        </p:tgtEl>
+                                        <p:attrNameLst>
+                                          <p:attrName>style.visibility</p:attrName>
+                                        </p:attrNameLst>
+                                      </p:cBhvr>
+                                      <p:to>
+                                        <p:strVal val="visible"/>
+                                      </p:to>
+                                    </p:set>
+                                    <p:animEffect transition="in" filter="fade">
+                                      <p:cBhvr>
+                                        <p:cTn id="22" dur="450"/>
+                                        <p:tgtEl>
+                                          <p:spTgt spid="11"/>
+                                        </p:tgtEl>
+                                      </p:cBhvr>
+                                    </p:animEffect>
+                                  </p:childTnLst>
+                                </p:cTn>
+                              </p:par>
+                              <p:par>
+                                <p:cTn id="23" presetID="10" presetClass="entr" presetSubtype="0" fill="hold" grpId="0" nodeType="withEffect">
+                                  <p:stCondLst>
+                                    <p:cond delay="360"/>
+                                  </p:stCondLst>
+                                  <p:childTnLst>
+                                    <p:set>
+                                      <p:cBhvr>
+                                        <p:cTn id="24" dur="1" fill="hold">
+                                          <p:stCondLst>
+                                            <p:cond delay="0"/>
+                                          </p:stCondLst>
+                                        </p:cTn>
+                                        <p:tgtEl>
+                                          <p:spTgt spid="12"/>
+                                        </p:tgtEl>
+                                        <p:attrNameLst>
+                                          <p:attrName>style.visibility</p:attrName>
+                                        </p:attrNameLst>
+                                      </p:cBhvr>
+                                      <p:to>
+                                        <p:strVal val="visible"/>
+                                      </p:to>
+                                    </p:set>
+                                    <p:animEffect transition="in" filter="fade">
+                                      <p:cBhvr>
+                                        <p:cTn id="25" dur="450"/>
+                                        <p:tgtEl>
+                                          <p:spTgt spid="12"/>
+                                        </p:tgtEl>
+                                      </p:cBhvr>
+                                    </p:animEffect>
+                                  </p:childTnLst>
+                                </p:cTn>
+                              </p:par>
+                              <p:par>
+                                <p:cTn id="26" presetID="10" presetClass="entr" presetSubtype="0" fill="hold" grpId="0" nodeType="withEffect">
+                                  <p:stCondLst>
+                                    <p:cond delay="395"/>
+                                  </p:stCondLst>
+                                  <p:childTnLst>
+                                    <p:set>
+                                      <p:cBhvr>
+                                        <p:cTn id="27" dur="1" fill="hold">
+                                          <p:stCondLst>
+                                            <p:cond delay="0"/>
+                                          </p:stCondLst>
+                                        </p:cTn>
+                                        <p:tgtEl>
+                                          <p:spTgt spid="13"/>
+                                        </p:tgtEl>
+                                        <p:attrNameLst>
+                                          <p:attrName>style.visibility</p:attrName>
+                                        </p:attrNameLst>
+                                      </p:cBhvr>
+                                      <p:to>
+                                        <p:strVal val="visible"/>
+                                      </p:to>
+                                    </p:set>
+                                    <p:animEffect transition="in" filter="fade">
+                                      <p:cBhvr>
+                                        <p:cTn id="28" dur="450"/>
+                                        <p:tgtEl>
+                                          <p:spTgt spid="13"/>
+                                        </p:tgtEl>
+                                      </p:cBhvr>
+                                    </p:animEffect>
+                                  </p:childTnLst>
+                                </p:cTn>
+                              </p:par>
+                              <p:par>
+                                <p:cTn id="29" presetID="10" presetClass="entr" presetSubtype="0" fill="hold" grpId="0" nodeType="withEffect">
+                                  <p:stCondLst>
+                                    <p:cond delay="430"/>
+                                  </p:stCondLst>
+                                  <p:childTnLst>
+                                    <p:set>
+                                      <p:cBhvr>
+                                        <p:cTn id="30" dur="1" fill="hold">
+                                          <p:stCondLst>
+                                            <p:cond delay="0"/>
+                                          </p:stCondLst>
+                                        </p:cTn>
+                                        <p:tgtEl>
+                                          <p:spTgt spid="14"/>
+                                        </p:tgtEl>
+                                        <p:attrNameLst>
+                                          <p:attrName>style.visibility</p:attrName>
+                                        </p:attrNameLst>
+                                      </p:cBhvr>
+                                      <p:to>
+                                        <p:strVal val="visible"/>
+                                      </p:to>
+                                    </p:set>
+                                    <p:animEffect transition="in" filter="fade">
+                                      <p:cBhvr>
+                                        <p:cTn id="31" dur="450"/>
+                                        <p:tgtEl>
+                                          <p:spTgt spid="14"/>
+                                        </p:tgtEl>
+                                      </p:cBhvr>
+                                    </p:animEffect>
+                                  </p:childTnLst>
+                                </p:cTn>
+                              </p:par>
+                              <p:par>
+                                <p:cTn id="32" presetID="10" presetClass="entr" presetSubtype="0" fill="hold" grpId="0" nodeType="withEffect">
+                                  <p:stCondLst>
+                                    <p:cond delay="465"/>
+                                  </p:stCondLst>
+                                  <p:childTnLst>
+                                    <p:set>
+                                      <p:cBhvr>
+                                        <p:cTn id="33" dur="1" fill="hold">
+                                          <p:stCondLst>
+                                            <p:cond delay="0"/>
+                                          </p:stCondLst>
+                                        </p:cTn>
+                                        <p:tgtEl>
+                                          <p:spTgt spid="15"/>
+                                        </p:tgtEl>
+                                        <p:attrNameLst>
+                                          <p:attrName>style.visibility</p:attrName>
+                                        </p:attrNameLst>
+                                      </p:cBhvr>
+                                      <p:to>
+                                        <p:strVal val="visible"/>
+                                      </p:to>
+                                    </p:set>
+                                    <p:animEffect transition="in" filter="fade">
+                                      <p:cBhvr>
+                                        <p:cTn id="34" dur="450"/>
+                                        <p:tgtEl>
+                                          <p:spTgt spid="15"/>
+                                        </p:tgtEl>
+                                      </p:cBhvr>
+                                    </p:animEffect>
+                                  </p:childTnLst>
+                                </p:cTn>
+                              </p:par>
+                              <p:par>
+                                <p:cTn id="35" presetID="10" presetClass="entr" presetSubtype="0" fill="hold" grpId="0" nodeType="withEffect">
+                                  <p:stCondLst>
+                                    <p:cond delay="500"/>
+                                  </p:stCondLst>
+                                  <p:childTnLst>
+                                    <p:set>
+                                      <p:cBhvr>
+                                        <p:cTn id="36" dur="1" fill="hold">
+                                          <p:stCondLst>
+                                            <p:cond delay="0"/>
+                                          </p:stCondLst>
+                                        </p:cTn>
+                                        <p:tgtEl>
+                                          <p:spTgt spid="16"/>
+                                        </p:tgtEl>
+                                        <p:attrNameLst>
+                                          <p:attrName>style.visibility</p:attrName>
+                                        </p:attrNameLst>
+                                      </p:cBhvr>
+                                      <p:to>
+                                        <p:strVal val="visible"/>
+                                      </p:to>
+                                    </p:set>
+                                    <p:animEffect transition="in" filter="fade">
+                                      <p:cBhvr>
+                                        <p:cTn id="37" dur="450"/>
+                                        <p:tgtEl>
+                                          <p:spTgt spid="16"/>
+                                        </p:tgtEl>
+                                      </p:cBhvr>
+                                    </p:animEffect>
+                                  </p:childTnLst>
+                                </p:cTn>
+                              </p:par>
+                              <p:par>
+                                <p:cTn id="38" presetID="10" presetClass="entr" presetSubtype="0" fill="hold" grpId="0" nodeType="withEffect">
+                                  <p:stCondLst>
+                                    <p:cond delay="535"/>
+                                  </p:stCondLst>
+                                  <p:childTnLst>
+                                    <p:set>
+                                      <p:cBhvr>
+                                        <p:cTn id="39" dur="1" fill="hold">
+                                          <p:stCondLst>
+                                            <p:cond delay="0"/>
+                                          </p:stCondLst>
+                                        </p:cTn>
+                                        <p:tgtEl>
+                                          <p:spTgt spid="17"/>
+                                        </p:tgtEl>
+                                        <p:attrNameLst>
+                                          <p:attrName>style.visibility</p:attrName>
+                                        </p:attrNameLst>
+                                      </p:cBhvr>
+                                      <p:to>
+                                        <p:strVal val="visible"/>
+                                      </p:to>
+                                    </p:set>
+                                    <p:animEffect transition="in" filter="fade">
+                                      <p:cBhvr>
+                                        <p:cTn id="40" dur="450"/>
+                                        <p:tgtEl>
+                                          <p:spTgt spid="17"/>
+                                        </p:tgtEl>
+                                      </p:cBhvr>
+                                    </p:animEffect>
+                                  </p:childTnLst>
+                                </p:cTn>
+                              </p:par>
+                              <p:par>
+                                <p:cTn id="41" presetID="10" presetClass="entr" presetSubtype="0" fill="hold" grpId="0" nodeType="withEffect">
+                                  <p:stCondLst>
+                                    <p:cond delay="570"/>
+                                  </p:stCondLst>
+                                  <p:childTnLst>
+                                    <p:set>
+                                      <p:cBhvr>
+                                        <p:cTn id="42" dur="1" fill="hold">
+                                          <p:stCondLst>
+                                            <p:cond delay="0"/>
+                                          </p:stCondLst>
+                                        </p:cTn>
+                                        <p:tgtEl>
+                                          <p:spTgt spid="18"/>
+                                        </p:tgtEl>
+                                        <p:attrNameLst>
+                                          <p:attrName>style.visibility</p:attrName>
+                                        </p:attrNameLst>
+                                      </p:cBhvr>
+                                      <p:to>
+                                        <p:strVal val="visible"/>
+                                      </p:to>
+                                    </p:set>
+                                    <p:animEffect transition="in" filter="fade">
+                                      <p:cBhvr>
+                                        <p:cTn id="43" dur="450"/>
+                                        <p:tgtEl>
+                                          <p:spTgt spid="18"/>
+                                        </p:tgtEl>
+                                      </p:cBhvr>
+                                    </p:animEffect>
+                                  </p:childTnLst>
+                                </p:cTn>
+                              </p:par>
+                              <p:par>
+                                <p:cTn id="44" presetID="10" presetClass="entr" presetSubtype="0" fill="hold" grpId="0" nodeType="withEffect">
+                                  <p:stCondLst>
+                                    <p:cond delay="605"/>
+                                  </p:stCondLst>
+                                  <p:childTnLst>
+                                    <p:set>
+                                      <p:cBhvr>
+                                        <p:cTn id="45" dur="1" fill="hold">
+                                          <p:stCondLst>
+                                            <p:cond delay="0"/>
+                                          </p:stCondLst>
+                                        </p:cTn>
+                                        <p:tgtEl>
+                                          <p:spTgt spid="19"/>
+                                        </p:tgtEl>
+                                        <p:attrNameLst>
+                                          <p:attrName>style.visibility</p:attrName>
+                                        </p:attrNameLst>
+                                      </p:cBhvr>
+                                      <p:to>
+                                        <p:strVal val="visible"/>
+                                      </p:to>
+                                    </p:set>
+                                    <p:animEffect transition="in" filter="fade">
+                                      <p:cBhvr>
+                                        <p:cTn id="46" dur="450"/>
+                                        <p:tgtEl>
+                                          <p:spTgt spid="19"/>
+                                        </p:tgtEl>
+                                      </p:cBhvr>
+                                    </p:animEffect>
+                                  </p:childTnLst>
+                                </p:cTn>
+                              </p:par>
+                              <p:par>
+                                <p:cTn id="47" presetID="10" presetClass="entr" presetSubtype="0" fill="hold" grpId="0" nodeType="withEffect">
+                                  <p:stCondLst>
+                                    <p:cond delay="640"/>
+                                  </p:stCondLst>
+                                  <p:childTnLst>
+                                    <p:set>
+                                      <p:cBhvr>
+                                        <p:cTn id="48" dur="1" fill="hold">
+                                          <p:stCondLst>
+                                            <p:cond delay="0"/>
+                                          </p:stCondLst>
+                                        </p:cTn>
+                                        <p:tgtEl>
+                                          <p:spTgt spid="20"/>
+                                        </p:tgtEl>
+                                        <p:attrNameLst>
+                                          <p:attrName>style.visibility</p:attrName>
+                                        </p:attrNameLst>
+                                      </p:cBhvr>
+                                      <p:to>
+                                        <p:strVal val="visible"/>
+                                      </p:to>
+                                    </p:set>
+                                    <p:animEffect transition="in" filter="fade">
+                                      <p:cBhvr>
+                                        <p:cTn id="49" dur="450"/>
+                                        <p:tgtEl>
+                                          <p:spTgt spid="20"/>
+                                        </p:tgtEl>
+                                      </p:cBhvr>
+                                    </p:animEffect>
+                                  </p:childTnLst>
+                                </p:cTn>
+                              </p:par>
+                              <p:par>
+                                <p:cTn id="50" presetID="10" presetClass="entr" presetSubtype="0" fill="hold" grpId="0" nodeType="withEffect">
+                                  <p:stCondLst>
+                                    <p:cond delay="675"/>
+                                  </p:stCondLst>
+                                  <p:childTnLst>
+                                    <p:set>
+                                      <p:cBhvr>
+                                        <p:cTn id="51" dur="1" fill="hold">
+                                          <p:stCondLst>
+                                            <p:cond delay="0"/>
+                                          </p:stCondLst>
+                                        </p:cTn>
+                                        <p:tgtEl>
+                                          <p:spTgt spid="21"/>
+                                        </p:tgtEl>
+                                        <p:attrNameLst>
+                                          <p:attrName>style.visibility</p:attrName>
+                                        </p:attrNameLst>
+                                      </p:cBhvr>
+                                      <p:to>
+                                        <p:strVal val="visible"/>
+                                      </p:to>
+                                    </p:set>
+                                    <p:animEffect transition="in" filter="fade">
+                                      <p:cBhvr>
+                                        <p:cTn id="52" dur="450"/>
+                                        <p:tgtEl>
+                                          <p:spTgt spid="21"/>
+                                        </p:tgtEl>
+                                      </p:cBhvr>
+                                    </p:animEffect>
+                                  </p:childTnLst>
+                                </p:cTn>
+                              </p:par>
+                              <p:par>
+                                <p:cTn id="53" presetID="10" presetClass="entr" presetSubtype="0" fill="hold" grpId="0" nodeType="withEffect">
+                                  <p:stCondLst>
+                                    <p:cond delay="710"/>
+                                  </p:stCondLst>
+                                  <p:childTnLst>
+                                    <p:set>
+                                      <p:cBhvr>
+                                        <p:cTn id="54" dur="1" fill="hold">
+                                          <p:stCondLst>
+                                            <p:cond delay="0"/>
+                                          </p:stCondLst>
+                                        </p:cTn>
+                                        <p:tgtEl>
+                                          <p:spTgt spid="22"/>
+                                        </p:tgtEl>
+                                        <p:attrNameLst>
+                                          <p:attrName>style.visibility</p:attrName>
+                                        </p:attrNameLst>
+                                      </p:cBhvr>
+                                      <p:to>
+                                        <p:strVal val="visible"/>
+                                      </p:to>
+                                    </p:set>
+                                    <p:animEffect transition="in" filter="fade">
+                                      <p:cBhvr>
+                                        <p:cTn id="55" dur="450"/>
+                                        <p:tgtEl>
+                                          <p:spTgt spid="22"/>
+                                        </p:tgtEl>
+                                      </p:cBhvr>
+                                    </p:animEffect>
+                                  </p:childTnLst>
+                                </p:cTn>
+                              </p:par>
+                              <p:par>
+                                <p:cTn id="56" presetID="10" presetClass="entr" presetSubtype="0" fill="hold" grpId="0" nodeType="withEffect">
+                                  <p:stCondLst>
+                                    <p:cond delay="745"/>
+                                  </p:stCondLst>
+                                  <p:childTnLst>
+                                    <p:set>
+                                      <p:cBhvr>
+                                        <p:cTn id="57" dur="1" fill="hold">
+                                          <p:stCondLst>
+                                            <p:cond delay="0"/>
+                                          </p:stCondLst>
+                                        </p:cTn>
+                                        <p:tgtEl>
+                                          <p:spTgt spid="23"/>
+                                        </p:tgtEl>
+                                        <p:attrNameLst>
+                                          <p:attrName>style.visibility</p:attrName>
+                                        </p:attrNameLst>
+                                      </p:cBhvr>
+                                      <p:to>
+                                        <p:strVal val="visible"/>
+                                      </p:to>
+                                    </p:set>
+                                    <p:animEffect transition="in" filter="fade">
+                                      <p:cBhvr>
+                                        <p:cTn id="58" dur="450"/>
+                                        <p:tgtEl>
+                                          <p:spTgt spid="23"/>
+                                        </p:tgtEl>
+                                      </p:cBhvr>
+                                    </p:animEffect>
+                                  </p:childTnLst>
+                                </p:cTn>
+                              </p:par>
+                              <p:par>
+                                <p:cTn id="59" presetID="10" presetClass="entr" presetSubtype="0" fill="hold" grpId="0" nodeType="withEffect">
+                                  <p:stCondLst>
+                                    <p:cond delay="780"/>
+                                  </p:stCondLst>
+                                  <p:childTnLst>
+                                    <p:set>
+                                      <p:cBhvr>
+                                        <p:cTn id="60" dur="1" fill="hold">
+                                          <p:stCondLst>
+                                            <p:cond delay="0"/>
+                                          </p:stCondLst>
+                                        </p:cTn>
+                                        <p:tgtEl>
+                                          <p:spTgt spid="24"/>
+                                        </p:tgtEl>
+                                        <p:attrNameLst>
+                                          <p:attrName>style.visibility</p:attrName>
+                                        </p:attrNameLst>
+                                      </p:cBhvr>
+                                      <p:to>
+                                        <p:strVal val="visible"/>
+                                      </p:to>
+                                    </p:set>
+                                    <p:animEffect transition="in" filter="fade">
+                                      <p:cBhvr>
+                                        <p:cTn id="61" dur="450"/>
+                                        <p:tgtEl>
+                                          <p:spTgt spid="24"/>
+                                        </p:tgtEl>
+                                      </p:cBhvr>
+                                    </p:animEffect>
+                                  </p:childTnLst>
+                                </p:cTn>
+                              </p:par>
+                              <p:par>
+                                <p:cTn id="62" presetID="10" presetClass="entr" presetSubtype="0" fill="hold" grpId="0" nodeType="withEffect">
+                                  <p:stCondLst>
+                                    <p:cond delay="815"/>
+                                  </p:stCondLst>
+                                  <p:childTnLst>
+                                    <p:set>
+                                      <p:cBhvr>
+                                        <p:cTn id="63" dur="1" fill="hold">
+                                          <p:stCondLst>
+                                            <p:cond delay="0"/>
+                                          </p:stCondLst>
+                                        </p:cTn>
+                                        <p:tgtEl>
+                                          <p:spTgt spid="25"/>
+                                        </p:tgtEl>
+                                        <p:attrNameLst>
+                                          <p:attrName>style.visibility</p:attrName>
+                                        </p:attrNameLst>
+                                      </p:cBhvr>
+                                      <p:to>
+                                        <p:strVal val="visible"/>
+                                      </p:to>
+                                    </p:set>
+                                    <p:animEffect transition="in" filter="fade">
+                                      <p:cBhvr>
+                                        <p:cTn id="64" dur="450"/>
+                                        <p:tgtEl>
+                                          <p:spTgt spid="25"/>
+                                        </p:tgtEl>
+                                      </p:cBhvr>
+                                    </p:animEffect>
+                                  </p:childTnLst>
+                                </p:cTn>
+                              </p:par>
+                              <p:par>
+                                <p:cTn id="65" presetID="10" presetClass="entr" presetSubtype="0" fill="hold" grpId="0" nodeType="withEffect">
+                                  <p:stCondLst>
+                                    <p:cond delay="850"/>
+                                  </p:stCondLst>
+                                  <p:childTnLst>
+                                    <p:set>
+                                      <p:cBhvr>
+                                        <p:cTn id="66" dur="1" fill="hold">
+                                          <p:stCondLst>
+                                            <p:cond delay="0"/>
+                                          </p:stCondLst>
+                                        </p:cTn>
+                                        <p:tgtEl>
+                                          <p:spTgt spid="26"/>
+                                        </p:tgtEl>
+                                        <p:attrNameLst>
+                                          <p:attrName>style.visibility</p:attrName>
+                                        </p:attrNameLst>
+                                      </p:cBhvr>
+                                      <p:to>
+                                        <p:strVal val="visible"/>
+                                      </p:to>
+                                    </p:set>
+                                    <p:animEffect transition="in" filter="fade">
+                                      <p:cBhvr>
+                                        <p:cTn id="67" dur="450"/>
+                                        <p:tgtEl>
+                                          <p:spTgt spid="26"/>
+                                        </p:tgtEl>
+                                      </p:cBhvr>
+                                    </p:animEffect>
+                                  </p:childTnLst>
+                                </p:cTn>
+                              </p:par>
+                              <p:par>
+                                <p:cTn id="68" presetID="10" presetClass="entr" presetSubtype="0" fill="hold" grpId="0" nodeType="withEffect">
+                                  <p:stCondLst>
+                                    <p:cond delay="885"/>
+                                  </p:stCondLst>
+                                  <p:childTnLst>
+                                    <p:set>
+                                      <p:cBhvr>
+                                        <p:cTn id="69" dur="1" fill="hold">
+                                          <p:stCondLst>
+                                            <p:cond delay="0"/>
+                                          </p:stCondLst>
+                                        </p:cTn>
+                                        <p:tgtEl>
+                                          <p:spTgt spid="27"/>
+                                        </p:tgtEl>
+                                        <p:attrNameLst>
+                                          <p:attrName>style.visibility</p:attrName>
+                                        </p:attrNameLst>
+                                      </p:cBhvr>
+                                      <p:to>
+                                        <p:strVal val="visible"/>
+                                      </p:to>
+                                    </p:set>
+                                    <p:animEffect transition="in" filter="fade">
+                                      <p:cBhvr>
+                                        <p:cTn id="70" dur="450"/>
+                                        <p:tgtEl>
+                                          <p:spTgt spid="27"/>
+                                        </p:tgtEl>
+                                      </p:cBhvr>
+                                    </p:animEffect>
+                                  </p:childTnLst>
+                                </p:cTn>
+                              </p:par>
+                              <p:par>
+                                <p:cTn id="71" presetID="10" presetClass="entr" presetSubtype="0" fill="hold" grpId="0" nodeType="withEffect">
+                                  <p:stCondLst>
+                                    <p:cond delay="920"/>
+                                  </p:stCondLst>
+                                  <p:childTnLst>
+                                    <p:set>
+                                      <p:cBhvr>
+                                        <p:cTn id="72" dur="1" fill="hold">
+                                          <p:stCondLst>
+                                            <p:cond delay="0"/>
+                                          </p:stCondLst>
+                                        </p:cTn>
+                                        <p:tgtEl>
+                                          <p:spTgt spid="28"/>
+                                        </p:tgtEl>
+                                        <p:attrNameLst>
+                                          <p:attrName>style.visibility</p:attrName>
+                                        </p:attrNameLst>
+                                      </p:cBhvr>
+                                      <p:to>
+                                        <p:strVal val="visible"/>
+                                      </p:to>
+                                    </p:set>
+                                    <p:animEffect transition="in" filter="fade">
+                                      <p:cBhvr>
+                                        <p:cTn id="73" dur="450"/>
+                                        <p:tgtEl>
+                                          <p:spTgt spid="28"/>
+                                        </p:tgtEl>
+                                      </p:cBhvr>
+                                    </p:animEffect>
+                                  </p:childTnLst>
+                                </p:cTn>
+                              </p:par>
+                              <p:par>
+                                <p:cTn id="74" presetID="10" presetClass="entr" presetSubtype="0" fill="hold" grpId="0" nodeType="withEffect">
+                                  <p:stCondLst>
+                                    <p:cond delay="955"/>
+                                  </p:stCondLst>
+                                  <p:childTnLst>
+                                    <p:set>
+                                      <p:cBhvr>
+                                        <p:cTn id="75" dur="1" fill="hold">
+                                          <p:stCondLst>
+                                            <p:cond delay="0"/>
+                                          </p:stCondLst>
+                                        </p:cTn>
+                                        <p:tgtEl>
+                                          <p:spTgt spid="29"/>
+                                        </p:tgtEl>
+                                        <p:attrNameLst>
+                                          <p:attrName>style.visibility</p:attrName>
+                                        </p:attrNameLst>
+                                      </p:cBhvr>
+                                      <p:to>
+                                        <p:strVal val="visible"/>
+                                      </p:to>
+                                    </p:set>
+                                    <p:animEffect transition="in" filter="fade">
+                                      <p:cBhvr>
+                                        <p:cTn id="76" dur="450"/>
+                                        <p:tgtEl>
+                                          <p:spTgt spid="29"/>
+                                        </p:tgtEl>
+                                      </p:cBhvr>
+                                    </p:animEffect>
+                                  </p:childTnLst>
+                                </p:cTn>
+                              </p:par>
+                              <p:par>
+                                <p:cTn id="77" presetID="10" presetClass="entr" presetSubtype="0" fill="hold" grpId="0" nodeType="withEffect">
+                                  <p:stCondLst>
+                                    <p:cond delay="990"/>
+                                  </p:stCondLst>
+                                  <p:childTnLst>
+                                    <p:set>
+                                      <p:cBhvr>
+                                        <p:cTn id="78" dur="1" fill="hold">
+                                          <p:stCondLst>
+                                            <p:cond delay="0"/>
+                                          </p:stCondLst>
+                                        </p:cTn>
+                                        <p:tgtEl>
+                                          <p:spTgt spid="30"/>
+                                        </p:tgtEl>
+                                        <p:attrNameLst>
+                                          <p:attrName>style.visibility</p:attrName>
+                                        </p:attrNameLst>
+                                      </p:cBhvr>
+                                      <p:to>
+                                        <p:strVal val="visible"/>
+                                      </p:to>
+                                    </p:set>
+                                    <p:animEffect transition="in" filter="fade">
+                                      <p:cBhvr>
+                                        <p:cTn id="79" dur="450"/>
+                                        <p:tgtEl>
+                                          <p:spTgt spid="30"/>
+                                        </p:tgtEl>
+                                      </p:cBhvr>
+                                    </p:animEffect>
+                                  </p:childTnLst>
+                                </p:cTn>
+                              </p:par>
+                              <p:par>
+                                <p:cTn id="80" presetID="10" presetClass="entr" presetSubtype="0" fill="hold" grpId="0" nodeType="withEffect">
+                                  <p:stCondLst>
+                                    <p:cond delay="1025"/>
+                                  </p:stCondLst>
+                                  <p:childTnLst>
+                                    <p:set>
+                                      <p:cBhvr>
+                                        <p:cTn id="81" dur="1" fill="hold">
+                                          <p:stCondLst>
+                                            <p:cond delay="0"/>
+                                          </p:stCondLst>
+                                        </p:cTn>
+                                        <p:tgtEl>
+                                          <p:spTgt spid="31"/>
+                                        </p:tgtEl>
+                                        <p:attrNameLst>
+                                          <p:attrName>style.visibility</p:attrName>
+                                        </p:attrNameLst>
+                                      </p:cBhvr>
+                                      <p:to>
+                                        <p:strVal val="visible"/>
+                                      </p:to>
+                                    </p:set>
+                                    <p:animEffect transition="in" filter="fade">
+                                      <p:cBhvr>
+                                        <p:cTn id="82" dur="450"/>
+                                        <p:tgtEl>
+                                          <p:spTgt spid="31"/>
+                                        </p:tgtEl>
+                                      </p:cBhvr>
+                                    </p:animEffect>
+                                  </p:childTnLst>
+                                </p:cTn>
+                              </p:par>
+                              <p:par>
+                                <p:cTn id="83" presetID="10" presetClass="entr" presetSubtype="0" fill="hold" grpId="0" nodeType="withEffect">
+                                  <p:stCondLst>
+                                    <p:cond delay="1060"/>
+                                  </p:stCondLst>
+                                  <p:childTnLst>
+                                    <p:set>
+                                      <p:cBhvr>
+                                        <p:cTn id="84" dur="1" fill="hold">
+                                          <p:stCondLst>
+                                            <p:cond delay="0"/>
+                                          </p:stCondLst>
+                                        </p:cTn>
+                                        <p:tgtEl>
+                                          <p:spTgt spid="32"/>
+                                        </p:tgtEl>
+                                        <p:attrNameLst>
+                                          <p:attrName>style.visibility</p:attrName>
+                                        </p:attrNameLst>
+                                      </p:cBhvr>
+                                      <p:to>
+                                        <p:strVal val="visible"/>
+                                      </p:to>
+                                    </p:set>
+                                    <p:animEffect transition="in" filter="fade">
+                                      <p:cBhvr>
+                                        <p:cTn id="85" dur="450"/>
+                                        <p:tgtEl>
+                                          <p:spTgt spid="32"/>
+                                        </p:tgtEl>
+                                      </p:cBhvr>
+                                    </p:animEffect>
+                                  </p:childTnLst>
+                                </p:cTn>
+                              </p:par>
+                              <p:par>
+                                <p:cTn id="86" presetID="10" presetClass="entr" presetSubtype="0" fill="hold" grpId="0" nodeType="withEffect">
+                                  <p:stCondLst>
+                                    <p:cond delay="1095"/>
+                                  </p:stCondLst>
+                                  <p:childTnLst>
+                                    <p:set>
+                                      <p:cBhvr>
+                                        <p:cTn id="87" dur="1" fill="hold">
+                                          <p:stCondLst>
+                                            <p:cond delay="0"/>
+                                          </p:stCondLst>
+                                        </p:cTn>
+                                        <p:tgtEl>
+                                          <p:spTgt spid="33"/>
+                                        </p:tgtEl>
+                                        <p:attrNameLst>
+                                          <p:attrName>style.visibility</p:attrName>
+                                        </p:attrNameLst>
+                                      </p:cBhvr>
+                                      <p:to>
+                                        <p:strVal val="visible"/>
+                                      </p:to>
+                                    </p:set>
+                                    <p:animEffect transition="in" filter="fade">
+                                      <p:cBhvr>
+                                        <p:cTn id="88" dur="450"/>
+                                        <p:tgtEl>
+                                          <p:spTgt spid="33"/>
+                                        </p:tgtEl>
+                                      </p:cBhvr>
+                                    </p:animEffect>
+                                  </p:childTnLst>
+                                </p:cTn>
+                              </p:par>
+                              <p:par>
+                                <p:cTn id="89" presetID="10" presetClass="entr" presetSubtype="0" fill="hold" grpId="0" nodeType="withEffect">
+                                  <p:stCondLst>
+                                    <p:cond delay="1130"/>
+                                  </p:stCondLst>
+                                  <p:childTnLst>
+                                    <p:set>
+                                      <p:cBhvr>
+                                        <p:cTn id="90" dur="1" fill="hold">
+                                          <p:stCondLst>
+                                            <p:cond delay="0"/>
+                                          </p:stCondLst>
+                                        </p:cTn>
+                                        <p:tgtEl>
+                                          <p:spTgt spid="34"/>
+                                        </p:tgtEl>
+                                        <p:attrNameLst>
+                                          <p:attrName>style.visibility</p:attrName>
+                                        </p:attrNameLst>
+                                      </p:cBhvr>
+                                      <p:to>
+                                        <p:strVal val="visible"/>
+                                      </p:to>
+                                    </p:set>
+                                    <p:animEffect transition="in" filter="fade">
+                                      <p:cBhvr>
+                                        <p:cTn id="91" dur="450"/>
+                                        <p:tgtEl>
+                                          <p:spTgt spid="34"/>
+                                        </p:tgtEl>
+                                      </p:cBhvr>
+                                    </p:animEffect>
+                                  </p:childTnLst>
+                                </p:cTn>
+                              </p:par>
+                              <p:par>
+                                <p:cTn id="92" presetID="10" presetClass="entr" presetSubtype="0" fill="hold" grpId="0" nodeType="withEffect">
+                                  <p:stCondLst>
+                                    <p:cond delay="1165"/>
+                                  </p:stCondLst>
+                                  <p:childTnLst>
+                                    <p:set>
+                                      <p:cBhvr>
+                                        <p:cTn id="93" dur="1" fill="hold">
+                                          <p:stCondLst>
+                                            <p:cond delay="0"/>
+                                          </p:stCondLst>
+                                        </p:cTn>
+                                        <p:tgtEl>
+                                          <p:spTgt spid="35"/>
+                                        </p:tgtEl>
+                                        <p:attrNameLst>
+                                          <p:attrName>style.visibility</p:attrName>
+                                        </p:attrNameLst>
+                                      </p:cBhvr>
+                                      <p:to>
+                                        <p:strVal val="visible"/>
+                                      </p:to>
+                                    </p:set>
+                                    <p:animEffect transition="in" filter="fade">
+                                      <p:cBhvr>
+                                        <p:cTn id="94" dur="450"/>
+                                        <p:tgtEl>
+                                          <p:spTgt spid="35"/>
+                                        </p:tgtEl>
+                                      </p:cBhvr>
+                                    </p:animEffect>
+                                  </p:childTnLst>
+                                </p:cTn>
+                              </p:par>
+                              <p:par>
+                                <p:cTn id="95" presetID="10" presetClass="entr" presetSubtype="0" fill="hold" grpId="0" nodeType="withEffect">
+                                  <p:stCondLst>
+                                    <p:cond delay="1200"/>
+                                  </p:stCondLst>
+                                  <p:childTnLst>
+                                    <p:set>
+                                      <p:cBhvr>
+                                        <p:cTn id="96" dur="1" fill="hold">
+                                          <p:stCondLst>
+                                            <p:cond delay="0"/>
+                                          </p:stCondLst>
+                                        </p:cTn>
+                                        <p:tgtEl>
+                                          <p:spTgt spid="36"/>
+                                        </p:tgtEl>
+                                        <p:attrNameLst>
+                                          <p:attrName>style.visibility</p:attrName>
+                                        </p:attrNameLst>
+                                      </p:cBhvr>
+                                      <p:to>
+                                        <p:strVal val="visible"/>
+                                      </p:to>
+                                    </p:set>
+                                    <p:animEffect transition="in" filter="fade">
+                                      <p:cBhvr>
+                                        <p:cTn id="97" dur="450"/>
+                                        <p:tgtEl>
+                                          <p:spTgt spid="36"/>
+                                        </p:tgtEl>
+                                      </p:cBhvr>
+                                    </p:animEffect>
+                                  </p:childTnLst>
+                                </p:cTn>
+                              </p:par>
+                              <p:par>
+                                <p:cTn id="98" presetID="10" presetClass="entr" presetSubtype="0" fill="hold" grpId="0" nodeType="withEffect">
+                                  <p:stCondLst>
+                                    <p:cond delay="1235"/>
+                                  </p:stCondLst>
+                                  <p:childTnLst>
+                                    <p:set>
+                                      <p:cBhvr>
+                                        <p:cTn id="99" dur="1" fill="hold">
+                                          <p:stCondLst>
+                                            <p:cond delay="0"/>
+                                          </p:stCondLst>
+                                        </p:cTn>
+                                        <p:tgtEl>
+                                          <p:spTgt spid="37"/>
+                                        </p:tgtEl>
+                                        <p:attrNameLst>
+                                          <p:attrName>style.visibility</p:attrName>
+                                        </p:attrNameLst>
+                                      </p:cBhvr>
+                                      <p:to>
+                                        <p:strVal val="visible"/>
+                                      </p:to>
+                                    </p:set>
+                                    <p:animEffect transition="in" filter="fade">
+                                      <p:cBhvr>
+                                        <p:cTn id="100" dur="450"/>
+                                        <p:tgtEl>
+                                          <p:spTgt spid="37"/>
+                                        </p:tgtEl>
+                                      </p:cBhvr>
+                                    </p:animEffect>
+                                  </p:childTnLst>
+                                </p:cTn>
+                              </p:par>
+                              <p:par>
+                                <p:cTn id="101" presetID="10" presetClass="entr" presetSubtype="0" fill="hold" grpId="0" nodeType="withEffect">
+                                  <p:stCondLst>
+                                    <p:cond delay="1270"/>
+                                  </p:stCondLst>
+                                  <p:childTnLst>
+                                    <p:set>
+                                      <p:cBhvr>
+                                        <p:cTn id="102" dur="1" fill="hold">
+                                          <p:stCondLst>
+                                            <p:cond delay="0"/>
+                                          </p:stCondLst>
+                                        </p:cTn>
+                                        <p:tgtEl>
+                                          <p:spTgt spid="38"/>
+                                        </p:tgtEl>
+                                        <p:attrNameLst>
+                                          <p:attrName>style.visibility</p:attrName>
+                                        </p:attrNameLst>
+                                      </p:cBhvr>
+                                      <p:to>
+                                        <p:strVal val="visible"/>
+                                      </p:to>
+                                    </p:set>
+                                    <p:animEffect transition="in" filter="fade">
+                                      <p:cBhvr>
+                                        <p:cTn id="103" dur="450"/>
+                                        <p:tgtEl>
+                                          <p:spTgt spid="38"/>
+                                        </p:tgtEl>
+                                      </p:cBhvr>
+                                    </p:animEffect>
+                                  </p:childTnLst>
+                                </p:cTn>
+                              </p:par>
+                              <p:par>
+                                <p:cTn id="104" presetID="10" presetClass="entr" presetSubtype="0" fill="hold" grpId="0" nodeType="withEffect">
+                                  <p:stCondLst>
+                                    <p:cond delay="1305"/>
+                                  </p:stCondLst>
+                                  <p:childTnLst>
+                                    <p:set>
+                                      <p:cBhvr>
+                                        <p:cTn id="105" dur="1" fill="hold">
+                                          <p:stCondLst>
+                                            <p:cond delay="0"/>
+                                          </p:stCondLst>
+                                        </p:cTn>
+                                        <p:tgtEl>
+                                          <p:spTgt spid="39"/>
+                                        </p:tgtEl>
+                                        <p:attrNameLst>
+                                          <p:attrName>style.visibility</p:attrName>
+                                        </p:attrNameLst>
+                                      </p:cBhvr>
+                                      <p:to>
+                                        <p:strVal val="visible"/>
+                                      </p:to>
+                                    </p:set>
+                                    <p:animEffect transition="in" filter="fade">
+                                      <p:cBhvr>
+                                        <p:cTn id="106" dur="450"/>
+                                        <p:tgtEl>
+                                          <p:spTgt spid="39"/>
+                                        </p:tgtEl>
+                                      </p:cBhvr>
+                                    </p:animEffect>
+                                  </p:childTnLst>
+                                </p:cTn>
+                              </p:par>
+                              <p:par>
+                                <p:cTn id="107" presetID="10" presetClass="entr" presetSubtype="0" fill="hold" grpId="0" nodeType="withEffect">
+                                  <p:stCondLst>
+                                    <p:cond delay="1340"/>
+                                  </p:stCondLst>
+                                  <p:childTnLst>
+                                    <p:set>
+                                      <p:cBhvr>
+                                        <p:cTn id="108" dur="1" fill="hold">
+                                          <p:stCondLst>
+                                            <p:cond delay="0"/>
+                                          </p:stCondLst>
+                                        </p:cTn>
+                                        <p:tgtEl>
+                                          <p:spTgt spid="40"/>
+                                        </p:tgtEl>
+                                        <p:attrNameLst>
+                                          <p:attrName>style.visibility</p:attrName>
+                                        </p:attrNameLst>
+                                      </p:cBhvr>
+                                      <p:to>
+                                        <p:strVal val="visible"/>
+                                      </p:to>
+                                    </p:set>
+                                    <p:animEffect transition="in" filter="fade">
+                                      <p:cBhvr>
+                                        <p:cTn id="109" dur="450"/>
+                                        <p:tgtEl>
+                                          <p:spTgt spid="40"/>
+                                        </p:tgtEl>
+                                      </p:cBhvr>
+                                    </p:animEffect>
+                                  </p:childTnLst>
+                                </p:cTn>
+                              </p:par>
+                              <p:par>
+                                <p:cTn id="110" presetID="10" presetClass="entr" presetSubtype="0" fill="hold" grpId="0" nodeType="withEffect">
+                                  <p:stCondLst>
+                                    <p:cond delay="1375"/>
+                                  </p:stCondLst>
+                                  <p:childTnLst>
+                                    <p:set>
+                                      <p:cBhvr>
+                                        <p:cTn id="111" dur="1" fill="hold">
+                                          <p:stCondLst>
+                                            <p:cond delay="0"/>
+                                          </p:stCondLst>
+                                        </p:cTn>
+                                        <p:tgtEl>
+                                          <p:spTgt spid="41"/>
+                                        </p:tgtEl>
+                                        <p:attrNameLst>
+                                          <p:attrName>style.visibility</p:attrName>
+                                        </p:attrNameLst>
+                                      </p:cBhvr>
+                                      <p:to>
+                                        <p:strVal val="visible"/>
+                                      </p:to>
+                                    </p:set>
+                                    <p:animEffect transition="in" filter="fade">
+                                      <p:cBhvr>
+                                        <p:cTn id="112" dur="450"/>
+                                        <p:tgtEl>
+                                          <p:spTgt spid="41"/>
+                                        </p:tgtEl>
+                                      </p:cBhvr>
+                                    </p:animEffect>
+                                  </p:childTnLst>
+                                </p:cTn>
+                              </p:par>
+                              <p:par>
+                                <p:cTn id="113" presetID="10" presetClass="entr" presetSubtype="0" fill="hold" grpId="0" nodeType="withEffect">
+                                  <p:stCondLst>
+                                    <p:cond delay="1410"/>
+                                  </p:stCondLst>
+                                  <p:childTnLst>
+                                    <p:set>
+                                      <p:cBhvr>
+                                        <p:cTn id="114" dur="1" fill="hold">
+                                          <p:stCondLst>
+                                            <p:cond delay="0"/>
+                                          </p:stCondLst>
+                                        </p:cTn>
+                                        <p:tgtEl>
+                                          <p:spTgt spid="42"/>
+                                        </p:tgtEl>
+                                        <p:attrNameLst>
+                                          <p:attrName>style.visibility</p:attrName>
+                                        </p:attrNameLst>
+                                      </p:cBhvr>
+                                      <p:to>
+                                        <p:strVal val="visible"/>
+                                      </p:to>
+                                    </p:set>
+                                    <p:animEffect transition="in" filter="fade">
+                                      <p:cBhvr>
+                                        <p:cTn id="115" dur="450"/>
+                                        <p:tgtEl>
+                                          <p:spTgt spid="42"/>
+                                        </p:tgtEl>
+                                      </p:cBhvr>
+                                    </p:animEffect>
+                                  </p:childTnLst>
+                                </p:cTn>
+                              </p:par>
+                              <p:par>
+                                <p:cTn id="116" presetID="10" presetClass="entr" presetSubtype="0" fill="hold" grpId="0" nodeType="withEffect">
+                                  <p:stCondLst>
+                                    <p:cond delay="1445"/>
+                                  </p:stCondLst>
+                                  <p:childTnLst>
+                                    <p:set>
+                                      <p:cBhvr>
+                                        <p:cTn id="117" dur="1" fill="hold">
+                                          <p:stCondLst>
+                                            <p:cond delay="0"/>
+                                          </p:stCondLst>
+                                        </p:cTn>
+                                        <p:tgtEl>
+                                          <p:spTgt spid="43"/>
+                                        </p:tgtEl>
+                                        <p:attrNameLst>
+                                          <p:attrName>style.visibility</p:attrName>
+                                        </p:attrNameLst>
+                                      </p:cBhvr>
+                                      <p:to>
+                                        <p:strVal val="visible"/>
+                                      </p:to>
+                                    </p:set>
+                                    <p:animEffect transition="in" filter="fade">
+                                      <p:cBhvr>
+                                        <p:cTn id="118" dur="450"/>
+                                        <p:tgtEl>
+                                          <p:spTgt spid="43"/>
+                                        </p:tgtEl>
+                                      </p:cBhvr>
+                                    </p:animEffect>
+                                  </p:childTnLst>
+                                </p:cTn>
+                              </p:par>
+                              <p:par>
+                                <p:cTn id="119" presetID="10" presetClass="entr" presetSubtype="0" fill="hold" grpId="0" nodeType="withEffect">
+                                  <p:stCondLst>
+                                    <p:cond delay="1480"/>
+                                  </p:stCondLst>
+                                  <p:childTnLst>
+                                    <p:set>
+                                      <p:cBhvr>
+                                        <p:cTn id="120" dur="1" fill="hold">
+                                          <p:stCondLst>
+                                            <p:cond delay="0"/>
+                                          </p:stCondLst>
+                                        </p:cTn>
+                                        <p:tgtEl>
+                                          <p:spTgt spid="44"/>
+                                        </p:tgtEl>
+                                        <p:attrNameLst>
+                                          <p:attrName>style.visibility</p:attrName>
+                                        </p:attrNameLst>
+                                      </p:cBhvr>
+                                      <p:to>
+                                        <p:strVal val="visible"/>
+                                      </p:to>
+                                    </p:set>
+                                    <p:animEffect transition="in" filter="fade">
+                                      <p:cBhvr>
+                                        <p:cTn id="121" dur="450"/>
+                                        <p:tgtEl>
+                                          <p:spTgt spid="44"/>
+                                        </p:tgtEl>
+                                      </p:cBhvr>
+                                    </p:animEffect>
+                                  </p:childTnLst>
+                                </p:cTn>
+                              </p:par>
+                              <p:par>
+                                <p:cTn id="122" presetID="10" presetClass="entr" presetSubtype="0" fill="hold" grpId="0" nodeType="withEffect">
+                                  <p:stCondLst>
+                                    <p:cond delay="1515"/>
+                                  </p:stCondLst>
+                                  <p:childTnLst>
+                                    <p:set>
+                                      <p:cBhvr>
+                                        <p:cTn id="123" dur="1" fill="hold">
+                                          <p:stCondLst>
+                                            <p:cond delay="0"/>
+                                          </p:stCondLst>
+                                        </p:cTn>
+                                        <p:tgtEl>
+                                          <p:spTgt spid="45"/>
+                                        </p:tgtEl>
+                                        <p:attrNameLst>
+                                          <p:attrName>style.visibility</p:attrName>
+                                        </p:attrNameLst>
+                                      </p:cBhvr>
+                                      <p:to>
+                                        <p:strVal val="visible"/>
+                                      </p:to>
+                                    </p:set>
+                                    <p:animEffect transition="in" filter="fade">
+                                      <p:cBhvr>
+                                        <p:cTn id="124" dur="450"/>
+                                        <p:tgtEl>
+                                          <p:spTgt spid="45"/>
+                                        </p:tgtEl>
+                                      </p:cBhvr>
+                                    </p:animEffect>
+                                  </p:childTnLst>
+                                </p:cTn>
+                              </p:par>
+                              <p:par>
+                                <p:cTn id="125" presetID="10" presetClass="entr" presetSubtype="0" fill="hold" grpId="0" nodeType="withEffect">
+                                  <p:stCondLst>
+                                    <p:cond delay="1550"/>
+                                  </p:stCondLst>
+                                  <p:childTnLst>
+                                    <p:set>
+                                      <p:cBhvr>
+                                        <p:cTn id="126" dur="1" fill="hold">
+                                          <p:stCondLst>
+                                            <p:cond delay="0"/>
+                                          </p:stCondLst>
+                                        </p:cTn>
+                                        <p:tgtEl>
+                                          <p:spTgt spid="46"/>
+                                        </p:tgtEl>
+                                        <p:attrNameLst>
+                                          <p:attrName>style.visibility</p:attrName>
+                                        </p:attrNameLst>
+                                      </p:cBhvr>
+                                      <p:to>
+                                        <p:strVal val="visible"/>
+                                      </p:to>
+                                    </p:set>
+                                    <p:animEffect transition="in" filter="fade">
+                                      <p:cBhvr>
+                                        <p:cTn id="127" dur="450"/>
+                                        <p:tgtEl>
+                                          <p:spTgt spid="46"/>
+                                        </p:tgtEl>
+                                      </p:cBhvr>
+                                    </p:animEffect>
+                                  </p:childTnLst>
+                                </p:cTn>
+                              </p:par>
+                              <p:par>
+                                <p:cTn id="128" presetID="10" presetClass="entr" presetSubtype="0" fill="hold" grpId="0" nodeType="withEffect">
+                                  <p:stCondLst>
+                                    <p:cond delay="1585"/>
+                                  </p:stCondLst>
+                                  <p:childTnLst>
+                                    <p:set>
+                                      <p:cBhvr>
+                                        <p:cTn id="129" dur="1" fill="hold">
+                                          <p:stCondLst>
+                                            <p:cond delay="0"/>
+                                          </p:stCondLst>
+                                        </p:cTn>
+                                        <p:tgtEl>
+                                          <p:spTgt spid="47"/>
+                                        </p:tgtEl>
+                                        <p:attrNameLst>
+                                          <p:attrName>style.visibility</p:attrName>
+                                        </p:attrNameLst>
+                                      </p:cBhvr>
+                                      <p:to>
+                                        <p:strVal val="visible"/>
+                                      </p:to>
+                                    </p:set>
+                                    <p:animEffect transition="in" filter="fade">
+                                      <p:cBhvr>
+                                        <p:cTn id="130" dur="450"/>
+                                        <p:tgtEl>
+                                          <p:spTgt spid="47"/>
+                                        </p:tgtEl>
+                                      </p:cBhvr>
+                                    </p:animEffect>
+                                  </p:childTnLst>
+                                </p:cTn>
+                              </p:par>
+                              <p:par>
+                                <p:cTn id="131" presetID="10" presetClass="entr" presetSubtype="0" fill="hold" grpId="0" nodeType="withEffect">
+                                  <p:stCondLst>
+                                    <p:cond delay="1620"/>
+                                  </p:stCondLst>
+                                  <p:childTnLst>
+                                    <p:set>
+                                      <p:cBhvr>
+                                        <p:cTn id="132" dur="1" fill="hold">
+                                          <p:stCondLst>
+                                            <p:cond delay="0"/>
+                                          </p:stCondLst>
+                                        </p:cTn>
+                                        <p:tgtEl>
+                                          <p:spTgt spid="48"/>
+                                        </p:tgtEl>
+                                        <p:attrNameLst>
+                                          <p:attrName>style.visibility</p:attrName>
+                                        </p:attrNameLst>
+                                      </p:cBhvr>
+                                      <p:to>
+                                        <p:strVal val="visible"/>
+                                      </p:to>
+                                    </p:set>
+                                    <p:animEffect transition="in" filter="fade">
+                                      <p:cBhvr>
+                                        <p:cTn id="133" dur="450"/>
+                                        <p:tgtEl>
+                                          <p:spTgt spid="48"/>
+                                        </p:tgtEl>
+                                      </p:cBhvr>
+                                    </p:animEffect>
+                                  </p:childTnLst>
+                                </p:cTn>
+                              </p:par>
+                              <p:par>
+                                <p:cTn id="134" presetID="10" presetClass="entr" presetSubtype="0" fill="hold" grpId="0" nodeType="withEffect">
+                                  <p:stCondLst>
+                                    <p:cond delay="1655"/>
+                                  </p:stCondLst>
+                                  <p:childTnLst>
+                                    <p:set>
+                                      <p:cBhvr>
+                                        <p:cTn id="135" dur="1" fill="hold">
+                                          <p:stCondLst>
+                                            <p:cond delay="0"/>
+                                          </p:stCondLst>
+                                        </p:cTn>
+                                        <p:tgtEl>
+                                          <p:spTgt spid="49"/>
+                                        </p:tgtEl>
+                                        <p:attrNameLst>
+                                          <p:attrName>style.visibility</p:attrName>
+                                        </p:attrNameLst>
+                                      </p:cBhvr>
+                                      <p:to>
+                                        <p:strVal val="visible"/>
+                                      </p:to>
+                                    </p:set>
+                                    <p:animEffect transition="in" filter="fade">
+                                      <p:cBhvr>
+                                        <p:cTn id="136" dur="450"/>
+                                        <p:tgtEl>
+                                          <p:spTgt spid="49"/>
+                                        </p:tgtEl>
+                                      </p:cBhvr>
+                                    </p:animEffect>
+                                  </p:childTnLst>
+                                </p:cTn>
+                              </p:par>
+                            </p:childTnLst>
+                          </p:cTn>
+                        </p:par>
+                      </p:childTnLst>
+                    </p:cTn>
+                  </p:par>
+                </p:childTnLst>
+              </p:cTn>
+              <p:prevCondLst>
+                <p:cond evt="onPrev" delay="0">
+                  <p:tgtEl>
+                    <p:sldTgt/>
+                  </p:tgtEl>
+                </p:cond>
+              </p:prevCondLst>
+              <p:nextCondLst>
+                <p:cond evt="onNext" delay="0">
+                  <p:tgtEl>
+                    <p:sldTgt/>
+                  </p:tgtEl>
+                </p:cond>
+              </p:nextCondLst>
+            </p:seq>
+          </p:childTnLst>
+        </p:cTn>
+      </p:par>
+    </p:tnLst>
+  </p:timing>
 </p:sld>
 </file>
 
@@ -26168,16 +28972,1044 @@
   </p:clrMapOvr>
   <mc:AlternateContent xmlns:mc="http://schemas.openxmlformats.org/markup-compatibility/2006">
     <mc:Choice xmlns:p159="http://schemas.microsoft.com/office/powerpoint/2015/09/main" Requires="p159">
-      <p:transition xmlns:p14="http://schemas.microsoft.com/office/powerpoint/2010/main" spd="slow" p14:dur="800" advTm="400">
+      <p:transition xmlns:p14="http://schemas.microsoft.com/office/powerpoint/2010/main" spd="slow" p14:dur="800" advTm="1000">
         <p159:morph option="byObject"/>
       </p:transition>
     </mc:Choice>
     <mc:Fallback>
-      <p:transition spd="fast" advTm="400">
+      <p:transition spd="fast" advTm="1000">
         <p:fade/>
       </p:transition>
     </mc:Fallback>
   </mc:AlternateContent>
+  <p:timing>
+    <p:tnLst>
+      <p:par>
+        <p:cTn id="1" dur="indefinite" restart="never" nodeType="tmRoot">
+          <p:childTnLst>
+            <p:seq concurrent="1" nextAc="seek">
+              <p:cTn id="2" dur="indefinite" nodeType="mainSeq">
+                <p:childTnLst>
+                  <p:par>
+                    <p:cTn id="3" fill="hold">
+                      <p:stCondLst>
+                        <p:cond delay="0"/>
+                      </p:stCondLst>
+                      <p:childTnLst>
+                        <p:par>
+                          <p:cTn id="4" fill="hold">
+                            <p:stCondLst>
+                              <p:cond delay="0"/>
+                            </p:stCondLst>
+                            <p:childTnLst>
+                              <p:par>
+                                <p:cTn id="5" presetID="10" presetClass="entr" presetSubtype="0" fill="hold" grpId="0" nodeType="withEffect">
+                                  <p:stCondLst>
+                                    <p:cond delay="100"/>
+                                  </p:stCondLst>
+                                  <p:childTnLst>
+                                    <p:set>
+                                      <p:cBhvr>
+                                        <p:cTn id="6" dur="1" fill="hold">
+                                          <p:stCondLst>
+                                            <p:cond delay="0"/>
+                                          </p:stCondLst>
+                                        </p:cTn>
+                                        <p:tgtEl>
+                                          <p:spTgt spid="29"/>
+                                        </p:tgtEl>
+                                        <p:attrNameLst>
+                                          <p:attrName>style.visibility</p:attrName>
+                                        </p:attrNameLst>
+                                      </p:cBhvr>
+                                      <p:to>
+                                        <p:strVal val="visible"/>
+                                      </p:to>
+                                    </p:set>
+                                    <p:animEffect transition="in" filter="fade">
+                                      <p:cBhvr>
+                                        <p:cTn id="7" dur="350"/>
+                                        <p:tgtEl>
+                                          <p:spTgt spid="29"/>
+                                        </p:tgtEl>
+                                      </p:cBhvr>
+                                    </p:animEffect>
+                                  </p:childTnLst>
+                                </p:cTn>
+                              </p:par>
+                              <p:par>
+                                <p:cTn id="8" presetID="10" presetClass="entr" presetSubtype="0" fill="hold" grpId="0" nodeType="withEffect">
+                                  <p:stCondLst>
+                                    <p:cond delay="100"/>
+                                  </p:stCondLst>
+                                  <p:childTnLst>
+                                    <p:set>
+                                      <p:cBhvr>
+                                        <p:cTn id="9" dur="1" fill="hold">
+                                          <p:stCondLst>
+                                            <p:cond delay="0"/>
+                                          </p:stCondLst>
+                                        </p:cTn>
+                                        <p:tgtEl>
+                                          <p:spTgt spid="30"/>
+                                        </p:tgtEl>
+                                        <p:attrNameLst>
+                                          <p:attrName>style.visibility</p:attrName>
+                                        </p:attrNameLst>
+                                      </p:cBhvr>
+                                      <p:to>
+                                        <p:strVal val="visible"/>
+                                      </p:to>
+                                    </p:set>
+                                    <p:animEffect transition="in" filter="fade">
+                                      <p:cBhvr>
+                                        <p:cTn id="10" dur="350"/>
+                                        <p:tgtEl>
+                                          <p:spTgt spid="30"/>
+                                        </p:tgtEl>
+                                      </p:cBhvr>
+                                    </p:animEffect>
+                                  </p:childTnLst>
+                                </p:cTn>
+                              </p:par>
+                              <p:par>
+                                <p:cTn id="11" presetID="10" presetClass="entr" presetSubtype="0" fill="hold" grpId="0" nodeType="withEffect">
+                                  <p:stCondLst>
+                                    <p:cond delay="100"/>
+                                  </p:stCondLst>
+                                  <p:childTnLst>
+                                    <p:set>
+                                      <p:cBhvr>
+                                        <p:cTn id="12" dur="1" fill="hold">
+                                          <p:stCondLst>
+                                            <p:cond delay="0"/>
+                                          </p:stCondLst>
+                                        </p:cTn>
+                                        <p:tgtEl>
+                                          <p:spTgt spid="31"/>
+                                        </p:tgtEl>
+                                        <p:attrNameLst>
+                                          <p:attrName>style.visibility</p:attrName>
+                                        </p:attrNameLst>
+                                      </p:cBhvr>
+                                      <p:to>
+                                        <p:strVal val="visible"/>
+                                      </p:to>
+                                    </p:set>
+                                    <p:animEffect transition="in" filter="fade">
+                                      <p:cBhvr>
+                                        <p:cTn id="13" dur="350"/>
+                                        <p:tgtEl>
+                                          <p:spTgt spid="31"/>
+                                        </p:tgtEl>
+                                      </p:cBhvr>
+                                    </p:animEffect>
+                                  </p:childTnLst>
+                                </p:cTn>
+                              </p:par>
+                              <p:par>
+                                <p:cTn id="14" presetID="10" presetClass="entr" presetSubtype="0" fill="hold" grpId="0" nodeType="withEffect">
+                                  <p:stCondLst>
+                                    <p:cond delay="100"/>
+                                  </p:stCondLst>
+                                  <p:childTnLst>
+                                    <p:set>
+                                      <p:cBhvr>
+                                        <p:cTn id="15" dur="1" fill="hold">
+                                          <p:stCondLst>
+                                            <p:cond delay="0"/>
+                                          </p:stCondLst>
+                                        </p:cTn>
+                                        <p:tgtEl>
+                                          <p:spTgt spid="32"/>
+                                        </p:tgtEl>
+                                        <p:attrNameLst>
+                                          <p:attrName>style.visibility</p:attrName>
+                                        </p:attrNameLst>
+                                      </p:cBhvr>
+                                      <p:to>
+                                        <p:strVal val="visible"/>
+                                      </p:to>
+                                    </p:set>
+                                    <p:animEffect transition="in" filter="fade">
+                                      <p:cBhvr>
+                                        <p:cTn id="16" dur="350"/>
+                                        <p:tgtEl>
+                                          <p:spTgt spid="32"/>
+                                        </p:tgtEl>
+                                      </p:cBhvr>
+                                    </p:animEffect>
+                                  </p:childTnLst>
+                                </p:cTn>
+                              </p:par>
+                              <p:par>
+                                <p:cTn id="17" presetID="10" presetClass="entr" presetSubtype="0" fill="hold" grpId="0" nodeType="withEffect">
+                                  <p:stCondLst>
+                                    <p:cond delay="100"/>
+                                  </p:stCondLst>
+                                  <p:childTnLst>
+                                    <p:set>
+                                      <p:cBhvr>
+                                        <p:cTn id="18" dur="1" fill="hold">
+                                          <p:stCondLst>
+                                            <p:cond delay="0"/>
+                                          </p:stCondLst>
+                                        </p:cTn>
+                                        <p:tgtEl>
+                                          <p:spTgt spid="33"/>
+                                        </p:tgtEl>
+                                        <p:attrNameLst>
+                                          <p:attrName>style.visibility</p:attrName>
+                                        </p:attrNameLst>
+                                      </p:cBhvr>
+                                      <p:to>
+                                        <p:strVal val="visible"/>
+                                      </p:to>
+                                    </p:set>
+                                    <p:animEffect transition="in" filter="fade">
+                                      <p:cBhvr>
+                                        <p:cTn id="19" dur="350"/>
+                                        <p:tgtEl>
+                                          <p:spTgt spid="33"/>
+                                        </p:tgtEl>
+                                      </p:cBhvr>
+                                    </p:animEffect>
+                                  </p:childTnLst>
+                                </p:cTn>
+                              </p:par>
+                              <p:par>
+                                <p:cTn id="20" presetID="10" presetClass="entr" presetSubtype="0" fill="hold" grpId="0" nodeType="withEffect">
+                                  <p:stCondLst>
+                                    <p:cond delay="100"/>
+                                  </p:stCondLst>
+                                  <p:childTnLst>
+                                    <p:set>
+                                      <p:cBhvr>
+                                        <p:cTn id="21" dur="1" fill="hold">
+                                          <p:stCondLst>
+                                            <p:cond delay="0"/>
+                                          </p:stCondLst>
+                                        </p:cTn>
+                                        <p:tgtEl>
+                                          <p:spTgt spid="34"/>
+                                        </p:tgtEl>
+                                        <p:attrNameLst>
+                                          <p:attrName>style.visibility</p:attrName>
+                                        </p:attrNameLst>
+                                      </p:cBhvr>
+                                      <p:to>
+                                        <p:strVal val="visible"/>
+                                      </p:to>
+                                    </p:set>
+                                    <p:animEffect transition="in" filter="fade">
+                                      <p:cBhvr>
+                                        <p:cTn id="22" dur="350"/>
+                                        <p:tgtEl>
+                                          <p:spTgt spid="34"/>
+                                        </p:tgtEl>
+                                      </p:cBhvr>
+                                    </p:animEffect>
+                                  </p:childTnLst>
+                                </p:cTn>
+                              </p:par>
+                              <p:par>
+                                <p:cTn id="23" presetID="10" presetClass="entr" presetSubtype="0" fill="hold" grpId="0" nodeType="withEffect">
+                                  <p:stCondLst>
+                                    <p:cond delay="100"/>
+                                  </p:stCondLst>
+                                  <p:childTnLst>
+                                    <p:set>
+                                      <p:cBhvr>
+                                        <p:cTn id="24" dur="1" fill="hold">
+                                          <p:stCondLst>
+                                            <p:cond delay="0"/>
+                                          </p:stCondLst>
+                                        </p:cTn>
+                                        <p:tgtEl>
+                                          <p:spTgt spid="35"/>
+                                        </p:tgtEl>
+                                        <p:attrNameLst>
+                                          <p:attrName>style.visibility</p:attrName>
+                                        </p:attrNameLst>
+                                      </p:cBhvr>
+                                      <p:to>
+                                        <p:strVal val="visible"/>
+                                      </p:to>
+                                    </p:set>
+                                    <p:animEffect transition="in" filter="fade">
+                                      <p:cBhvr>
+                                        <p:cTn id="25" dur="350"/>
+                                        <p:tgtEl>
+                                          <p:spTgt spid="35"/>
+                                        </p:tgtEl>
+                                      </p:cBhvr>
+                                    </p:animEffect>
+                                  </p:childTnLst>
+                                </p:cTn>
+                              </p:par>
+                              <p:par>
+                                <p:cTn id="26" presetID="10" presetClass="entr" presetSubtype="0" fill="hold" grpId="0" nodeType="withEffect">
+                                  <p:stCondLst>
+                                    <p:cond delay="100"/>
+                                  </p:stCondLst>
+                                  <p:childTnLst>
+                                    <p:set>
+                                      <p:cBhvr>
+                                        <p:cTn id="27" dur="1" fill="hold">
+                                          <p:stCondLst>
+                                            <p:cond delay="0"/>
+                                          </p:stCondLst>
+                                        </p:cTn>
+                                        <p:tgtEl>
+                                          <p:spTgt spid="36"/>
+                                        </p:tgtEl>
+                                        <p:attrNameLst>
+                                          <p:attrName>style.visibility</p:attrName>
+                                        </p:attrNameLst>
+                                      </p:cBhvr>
+                                      <p:to>
+                                        <p:strVal val="visible"/>
+                                      </p:to>
+                                    </p:set>
+                                    <p:animEffect transition="in" filter="fade">
+                                      <p:cBhvr>
+                                        <p:cTn id="28" dur="350"/>
+                                        <p:tgtEl>
+                                          <p:spTgt spid="36"/>
+                                        </p:tgtEl>
+                                      </p:cBhvr>
+                                    </p:animEffect>
+                                  </p:childTnLst>
+                                </p:cTn>
+                              </p:par>
+                              <p:par>
+                                <p:cTn id="29" presetID="10" presetClass="entr" presetSubtype="0" fill="hold" grpId="0" nodeType="withEffect">
+                                  <p:stCondLst>
+                                    <p:cond delay="100"/>
+                                  </p:stCondLst>
+                                  <p:childTnLst>
+                                    <p:set>
+                                      <p:cBhvr>
+                                        <p:cTn id="30" dur="1" fill="hold">
+                                          <p:stCondLst>
+                                            <p:cond delay="0"/>
+                                          </p:stCondLst>
+                                        </p:cTn>
+                                        <p:tgtEl>
+                                          <p:spTgt spid="37"/>
+                                        </p:tgtEl>
+                                        <p:attrNameLst>
+                                          <p:attrName>style.visibility</p:attrName>
+                                        </p:attrNameLst>
+                                      </p:cBhvr>
+                                      <p:to>
+                                        <p:strVal val="visible"/>
+                                      </p:to>
+                                    </p:set>
+                                    <p:animEffect transition="in" filter="fade">
+                                      <p:cBhvr>
+                                        <p:cTn id="31" dur="350"/>
+                                        <p:tgtEl>
+                                          <p:spTgt spid="37"/>
+                                        </p:tgtEl>
+                                      </p:cBhvr>
+                                    </p:animEffect>
+                                  </p:childTnLst>
+                                </p:cTn>
+                              </p:par>
+                              <p:par>
+                                <p:cTn id="32" presetID="10" presetClass="entr" presetSubtype="0" fill="hold" grpId="0" nodeType="withEffect">
+                                  <p:stCondLst>
+                                    <p:cond delay="100"/>
+                                  </p:stCondLst>
+                                  <p:childTnLst>
+                                    <p:set>
+                                      <p:cBhvr>
+                                        <p:cTn id="33" dur="1" fill="hold">
+                                          <p:stCondLst>
+                                            <p:cond delay="0"/>
+                                          </p:stCondLst>
+                                        </p:cTn>
+                                        <p:tgtEl>
+                                          <p:spTgt spid="38"/>
+                                        </p:tgtEl>
+                                        <p:attrNameLst>
+                                          <p:attrName>style.visibility</p:attrName>
+                                        </p:attrNameLst>
+                                      </p:cBhvr>
+                                      <p:to>
+                                        <p:strVal val="visible"/>
+                                      </p:to>
+                                    </p:set>
+                                    <p:animEffect transition="in" filter="fade">
+                                      <p:cBhvr>
+                                        <p:cTn id="34" dur="350"/>
+                                        <p:tgtEl>
+                                          <p:spTgt spid="38"/>
+                                        </p:tgtEl>
+                                      </p:cBhvr>
+                                    </p:animEffect>
+                                  </p:childTnLst>
+                                </p:cTn>
+                              </p:par>
+                              <p:par>
+                                <p:cTn id="35" presetID="10" presetClass="entr" presetSubtype="0" fill="hold" grpId="0" nodeType="withEffect">
+                                  <p:stCondLst>
+                                    <p:cond delay="100"/>
+                                  </p:stCondLst>
+                                  <p:childTnLst>
+                                    <p:set>
+                                      <p:cBhvr>
+                                        <p:cTn id="36" dur="1" fill="hold">
+                                          <p:stCondLst>
+                                            <p:cond delay="0"/>
+                                          </p:stCondLst>
+                                        </p:cTn>
+                                        <p:tgtEl>
+                                          <p:spTgt spid="39"/>
+                                        </p:tgtEl>
+                                        <p:attrNameLst>
+                                          <p:attrName>style.visibility</p:attrName>
+                                        </p:attrNameLst>
+                                      </p:cBhvr>
+                                      <p:to>
+                                        <p:strVal val="visible"/>
+                                      </p:to>
+                                    </p:set>
+                                    <p:animEffect transition="in" filter="fade">
+                                      <p:cBhvr>
+                                        <p:cTn id="37" dur="350"/>
+                                        <p:tgtEl>
+                                          <p:spTgt spid="39"/>
+                                        </p:tgtEl>
+                                      </p:cBhvr>
+                                    </p:animEffect>
+                                  </p:childTnLst>
+                                </p:cTn>
+                              </p:par>
+                              <p:par>
+                                <p:cTn id="38" presetID="10" presetClass="entr" presetSubtype="0" fill="hold" grpId="0" nodeType="withEffect">
+                                  <p:stCondLst>
+                                    <p:cond delay="100"/>
+                                  </p:stCondLst>
+                                  <p:childTnLst>
+                                    <p:set>
+                                      <p:cBhvr>
+                                        <p:cTn id="39" dur="1" fill="hold">
+                                          <p:stCondLst>
+                                            <p:cond delay="0"/>
+                                          </p:stCondLst>
+                                        </p:cTn>
+                                        <p:tgtEl>
+                                          <p:spTgt spid="40"/>
+                                        </p:tgtEl>
+                                        <p:attrNameLst>
+                                          <p:attrName>style.visibility</p:attrName>
+                                        </p:attrNameLst>
+                                      </p:cBhvr>
+                                      <p:to>
+                                        <p:strVal val="visible"/>
+                                      </p:to>
+                                    </p:set>
+                                    <p:animEffect transition="in" filter="fade">
+                                      <p:cBhvr>
+                                        <p:cTn id="40" dur="350"/>
+                                        <p:tgtEl>
+                                          <p:spTgt spid="40"/>
+                                        </p:tgtEl>
+                                      </p:cBhvr>
+                                    </p:animEffect>
+                                  </p:childTnLst>
+                                </p:cTn>
+                              </p:par>
+                              <p:par>
+                                <p:cTn id="41" presetID="10" presetClass="entr" presetSubtype="0" fill="hold" grpId="0" nodeType="withEffect">
+                                  <p:stCondLst>
+                                    <p:cond delay="100"/>
+                                  </p:stCondLst>
+                                  <p:childTnLst>
+                                    <p:set>
+                                      <p:cBhvr>
+                                        <p:cTn id="42" dur="1" fill="hold">
+                                          <p:stCondLst>
+                                            <p:cond delay="0"/>
+                                          </p:stCondLst>
+                                        </p:cTn>
+                                        <p:tgtEl>
+                                          <p:spTgt spid="41"/>
+                                        </p:tgtEl>
+                                        <p:attrNameLst>
+                                          <p:attrName>style.visibility</p:attrName>
+                                        </p:attrNameLst>
+                                      </p:cBhvr>
+                                      <p:to>
+                                        <p:strVal val="visible"/>
+                                      </p:to>
+                                    </p:set>
+                                    <p:animEffect transition="in" filter="fade">
+                                      <p:cBhvr>
+                                        <p:cTn id="43" dur="350"/>
+                                        <p:tgtEl>
+                                          <p:spTgt spid="41"/>
+                                        </p:tgtEl>
+                                      </p:cBhvr>
+                                    </p:animEffect>
+                                  </p:childTnLst>
+                                </p:cTn>
+                              </p:par>
+                              <p:par>
+                                <p:cTn id="44" presetID="10" presetClass="entr" presetSubtype="0" fill="hold" grpId="0" nodeType="withEffect">
+                                  <p:stCondLst>
+                                    <p:cond delay="100"/>
+                                  </p:stCondLst>
+                                  <p:childTnLst>
+                                    <p:set>
+                                      <p:cBhvr>
+                                        <p:cTn id="45" dur="1" fill="hold">
+                                          <p:stCondLst>
+                                            <p:cond delay="0"/>
+                                          </p:stCondLst>
+                                        </p:cTn>
+                                        <p:tgtEl>
+                                          <p:spTgt spid="42"/>
+                                        </p:tgtEl>
+                                        <p:attrNameLst>
+                                          <p:attrName>style.visibility</p:attrName>
+                                        </p:attrNameLst>
+                                      </p:cBhvr>
+                                      <p:to>
+                                        <p:strVal val="visible"/>
+                                      </p:to>
+                                    </p:set>
+                                    <p:animEffect transition="in" filter="fade">
+                                      <p:cBhvr>
+                                        <p:cTn id="46" dur="350"/>
+                                        <p:tgtEl>
+                                          <p:spTgt spid="42"/>
+                                        </p:tgtEl>
+                                      </p:cBhvr>
+                                    </p:animEffect>
+                                  </p:childTnLst>
+                                </p:cTn>
+                              </p:par>
+                              <p:par>
+                                <p:cTn id="47" presetID="10" presetClass="entr" presetSubtype="0" fill="hold" grpId="0" nodeType="withEffect">
+                                  <p:stCondLst>
+                                    <p:cond delay="100"/>
+                                  </p:stCondLst>
+                                  <p:childTnLst>
+                                    <p:set>
+                                      <p:cBhvr>
+                                        <p:cTn id="48" dur="1" fill="hold">
+                                          <p:stCondLst>
+                                            <p:cond delay="0"/>
+                                          </p:stCondLst>
+                                        </p:cTn>
+                                        <p:tgtEl>
+                                          <p:spTgt spid="43"/>
+                                        </p:tgtEl>
+                                        <p:attrNameLst>
+                                          <p:attrName>style.visibility</p:attrName>
+                                        </p:attrNameLst>
+                                      </p:cBhvr>
+                                      <p:to>
+                                        <p:strVal val="visible"/>
+                                      </p:to>
+                                    </p:set>
+                                    <p:animEffect transition="in" filter="fade">
+                                      <p:cBhvr>
+                                        <p:cTn id="49" dur="350"/>
+                                        <p:tgtEl>
+                                          <p:spTgt spid="43"/>
+                                        </p:tgtEl>
+                                      </p:cBhvr>
+                                    </p:animEffect>
+                                  </p:childTnLst>
+                                </p:cTn>
+                              </p:par>
+                              <p:par>
+                                <p:cTn id="50" presetID="10" presetClass="entr" presetSubtype="0" fill="hold" grpId="0" nodeType="withEffect">
+                                  <p:stCondLst>
+                                    <p:cond delay="100"/>
+                                  </p:stCondLst>
+                                  <p:childTnLst>
+                                    <p:set>
+                                      <p:cBhvr>
+                                        <p:cTn id="51" dur="1" fill="hold">
+                                          <p:stCondLst>
+                                            <p:cond delay="0"/>
+                                          </p:stCondLst>
+                                        </p:cTn>
+                                        <p:tgtEl>
+                                          <p:spTgt spid="44"/>
+                                        </p:tgtEl>
+                                        <p:attrNameLst>
+                                          <p:attrName>style.visibility</p:attrName>
+                                        </p:attrNameLst>
+                                      </p:cBhvr>
+                                      <p:to>
+                                        <p:strVal val="visible"/>
+                                      </p:to>
+                                    </p:set>
+                                    <p:animEffect transition="in" filter="fade">
+                                      <p:cBhvr>
+                                        <p:cTn id="52" dur="350"/>
+                                        <p:tgtEl>
+                                          <p:spTgt spid="44"/>
+                                        </p:tgtEl>
+                                      </p:cBhvr>
+                                    </p:animEffect>
+                                  </p:childTnLst>
+                                </p:cTn>
+                              </p:par>
+                              <p:par>
+                                <p:cTn id="53" presetID="10" presetClass="entr" presetSubtype="0" fill="hold" grpId="0" nodeType="withEffect">
+                                  <p:stCondLst>
+                                    <p:cond delay="100"/>
+                                  </p:stCondLst>
+                                  <p:childTnLst>
+                                    <p:set>
+                                      <p:cBhvr>
+                                        <p:cTn id="54" dur="1" fill="hold">
+                                          <p:stCondLst>
+                                            <p:cond delay="0"/>
+                                          </p:stCondLst>
+                                        </p:cTn>
+                                        <p:tgtEl>
+                                          <p:spTgt spid="45"/>
+                                        </p:tgtEl>
+                                        <p:attrNameLst>
+                                          <p:attrName>style.visibility</p:attrName>
+                                        </p:attrNameLst>
+                                      </p:cBhvr>
+                                      <p:to>
+                                        <p:strVal val="visible"/>
+                                      </p:to>
+                                    </p:set>
+                                    <p:animEffect transition="in" filter="fade">
+                                      <p:cBhvr>
+                                        <p:cTn id="55" dur="350"/>
+                                        <p:tgtEl>
+                                          <p:spTgt spid="45"/>
+                                        </p:tgtEl>
+                                      </p:cBhvr>
+                                    </p:animEffect>
+                                  </p:childTnLst>
+                                </p:cTn>
+                              </p:par>
+                              <p:par>
+                                <p:cTn id="56" presetID="10" presetClass="entr" presetSubtype="0" fill="hold" grpId="0" nodeType="withEffect">
+                                  <p:stCondLst>
+                                    <p:cond delay="100"/>
+                                  </p:stCondLst>
+                                  <p:childTnLst>
+                                    <p:set>
+                                      <p:cBhvr>
+                                        <p:cTn id="57" dur="1" fill="hold">
+                                          <p:stCondLst>
+                                            <p:cond delay="0"/>
+                                          </p:stCondLst>
+                                        </p:cTn>
+                                        <p:tgtEl>
+                                          <p:spTgt spid="46"/>
+                                        </p:tgtEl>
+                                        <p:attrNameLst>
+                                          <p:attrName>style.visibility</p:attrName>
+                                        </p:attrNameLst>
+                                      </p:cBhvr>
+                                      <p:to>
+                                        <p:strVal val="visible"/>
+                                      </p:to>
+                                    </p:set>
+                                    <p:animEffect transition="in" filter="fade">
+                                      <p:cBhvr>
+                                        <p:cTn id="58" dur="350"/>
+                                        <p:tgtEl>
+                                          <p:spTgt spid="46"/>
+                                        </p:tgtEl>
+                                      </p:cBhvr>
+                                    </p:animEffect>
+                                  </p:childTnLst>
+                                </p:cTn>
+                              </p:par>
+                              <p:par>
+                                <p:cTn id="59" presetID="10" presetClass="entr" presetSubtype="0" fill="hold" grpId="0" nodeType="withEffect">
+                                  <p:stCondLst>
+                                    <p:cond delay="100"/>
+                                  </p:stCondLst>
+                                  <p:childTnLst>
+                                    <p:set>
+                                      <p:cBhvr>
+                                        <p:cTn id="60" dur="1" fill="hold">
+                                          <p:stCondLst>
+                                            <p:cond delay="0"/>
+                                          </p:stCondLst>
+                                        </p:cTn>
+                                        <p:tgtEl>
+                                          <p:spTgt spid="47"/>
+                                        </p:tgtEl>
+                                        <p:attrNameLst>
+                                          <p:attrName>style.visibility</p:attrName>
+                                        </p:attrNameLst>
+                                      </p:cBhvr>
+                                      <p:to>
+                                        <p:strVal val="visible"/>
+                                      </p:to>
+                                    </p:set>
+                                    <p:animEffect transition="in" filter="fade">
+                                      <p:cBhvr>
+                                        <p:cTn id="61" dur="350"/>
+                                        <p:tgtEl>
+                                          <p:spTgt spid="47"/>
+                                        </p:tgtEl>
+                                      </p:cBhvr>
+                                    </p:animEffect>
+                                  </p:childTnLst>
+                                </p:cTn>
+                              </p:par>
+                              <p:par>
+                                <p:cTn id="62" presetID="10" presetClass="entr" presetSubtype="0" fill="hold" grpId="0" nodeType="withEffect">
+                                  <p:stCondLst>
+                                    <p:cond delay="250"/>
+                                  </p:stCondLst>
+                                  <p:childTnLst>
+                                    <p:set>
+                                      <p:cBhvr>
+                                        <p:cTn id="63" dur="1" fill="hold">
+                                          <p:stCondLst>
+                                            <p:cond delay="0"/>
+                                          </p:stCondLst>
+                                        </p:cTn>
+                                        <p:tgtEl>
+                                          <p:spTgt spid="20"/>
+                                        </p:tgtEl>
+                                        <p:attrNameLst>
+                                          <p:attrName>style.visibility</p:attrName>
+                                        </p:attrNameLst>
+                                      </p:cBhvr>
+                                      <p:to>
+                                        <p:strVal val="visible"/>
+                                      </p:to>
+                                    </p:set>
+                                    <p:animEffect transition="in" filter="fade">
+                                      <p:cBhvr>
+                                        <p:cTn id="64" dur="350"/>
+                                        <p:tgtEl>
+                                          <p:spTgt spid="20"/>
+                                        </p:tgtEl>
+                                      </p:cBhvr>
+                                    </p:animEffect>
+                                  </p:childTnLst>
+                                </p:cTn>
+                              </p:par>
+                              <p:par>
+                                <p:cTn id="65" presetID="10" presetClass="entr" presetSubtype="0" fill="hold" grpId="0" nodeType="withEffect">
+                                  <p:stCondLst>
+                                    <p:cond delay="250"/>
+                                  </p:stCondLst>
+                                  <p:childTnLst>
+                                    <p:set>
+                                      <p:cBhvr>
+                                        <p:cTn id="66" dur="1" fill="hold">
+                                          <p:stCondLst>
+                                            <p:cond delay="0"/>
+                                          </p:stCondLst>
+                                        </p:cTn>
+                                        <p:tgtEl>
+                                          <p:spTgt spid="21"/>
+                                        </p:tgtEl>
+                                        <p:attrNameLst>
+                                          <p:attrName>style.visibility</p:attrName>
+                                        </p:attrNameLst>
+                                      </p:cBhvr>
+                                      <p:to>
+                                        <p:strVal val="visible"/>
+                                      </p:to>
+                                    </p:set>
+                                    <p:animEffect transition="in" filter="fade">
+                                      <p:cBhvr>
+                                        <p:cTn id="67" dur="350"/>
+                                        <p:tgtEl>
+                                          <p:spTgt spid="21"/>
+                                        </p:tgtEl>
+                                      </p:cBhvr>
+                                    </p:animEffect>
+                                  </p:childTnLst>
+                                </p:cTn>
+                              </p:par>
+                              <p:par>
+                                <p:cTn id="68" presetID="10" presetClass="entr" presetSubtype="0" fill="hold" grpId="0" nodeType="withEffect">
+                                  <p:stCondLst>
+                                    <p:cond delay="250"/>
+                                  </p:stCondLst>
+                                  <p:childTnLst>
+                                    <p:set>
+                                      <p:cBhvr>
+                                        <p:cTn id="69" dur="1" fill="hold">
+                                          <p:stCondLst>
+                                            <p:cond delay="0"/>
+                                          </p:stCondLst>
+                                        </p:cTn>
+                                        <p:tgtEl>
+                                          <p:spTgt spid="22"/>
+                                        </p:tgtEl>
+                                        <p:attrNameLst>
+                                          <p:attrName>style.visibility</p:attrName>
+                                        </p:attrNameLst>
+                                      </p:cBhvr>
+                                      <p:to>
+                                        <p:strVal val="visible"/>
+                                      </p:to>
+                                    </p:set>
+                                    <p:animEffect transition="in" filter="fade">
+                                      <p:cBhvr>
+                                        <p:cTn id="70" dur="350"/>
+                                        <p:tgtEl>
+                                          <p:spTgt spid="22"/>
+                                        </p:tgtEl>
+                                      </p:cBhvr>
+                                    </p:animEffect>
+                                  </p:childTnLst>
+                                </p:cTn>
+                              </p:par>
+                              <p:par>
+                                <p:cTn id="71" presetID="10" presetClass="entr" presetSubtype="0" fill="hold" grpId="0" nodeType="withEffect">
+                                  <p:stCondLst>
+                                    <p:cond delay="450"/>
+                                  </p:stCondLst>
+                                  <p:childTnLst>
+                                    <p:set>
+                                      <p:cBhvr>
+                                        <p:cTn id="72" dur="1" fill="hold">
+                                          <p:stCondLst>
+                                            <p:cond delay="0"/>
+                                          </p:stCondLst>
+                                        </p:cTn>
+                                        <p:tgtEl>
+                                          <p:spTgt spid="23"/>
+                                        </p:tgtEl>
+                                        <p:attrNameLst>
+                                          <p:attrName>style.visibility</p:attrName>
+                                        </p:attrNameLst>
+                                      </p:cBhvr>
+                                      <p:to>
+                                        <p:strVal val="visible"/>
+                                      </p:to>
+                                    </p:set>
+                                    <p:animEffect transition="in" filter="fade">
+                                      <p:cBhvr>
+                                        <p:cTn id="73" dur="350"/>
+                                        <p:tgtEl>
+                                          <p:spTgt spid="23"/>
+                                        </p:tgtEl>
+                                      </p:cBhvr>
+                                    </p:animEffect>
+                                  </p:childTnLst>
+                                </p:cTn>
+                              </p:par>
+                              <p:par>
+                                <p:cTn id="74" presetID="10" presetClass="entr" presetSubtype="0" fill="hold" grpId="0" nodeType="withEffect">
+                                  <p:stCondLst>
+                                    <p:cond delay="450"/>
+                                  </p:stCondLst>
+                                  <p:childTnLst>
+                                    <p:set>
+                                      <p:cBhvr>
+                                        <p:cTn id="75" dur="1" fill="hold">
+                                          <p:stCondLst>
+                                            <p:cond delay="0"/>
+                                          </p:stCondLst>
+                                        </p:cTn>
+                                        <p:tgtEl>
+                                          <p:spTgt spid="24"/>
+                                        </p:tgtEl>
+                                        <p:attrNameLst>
+                                          <p:attrName>style.visibility</p:attrName>
+                                        </p:attrNameLst>
+                                      </p:cBhvr>
+                                      <p:to>
+                                        <p:strVal val="visible"/>
+                                      </p:to>
+                                    </p:set>
+                                    <p:animEffect transition="in" filter="fade">
+                                      <p:cBhvr>
+                                        <p:cTn id="76" dur="350"/>
+                                        <p:tgtEl>
+                                          <p:spTgt spid="24"/>
+                                        </p:tgtEl>
+                                      </p:cBhvr>
+                                    </p:animEffect>
+                                  </p:childTnLst>
+                                </p:cTn>
+                              </p:par>
+                              <p:par>
+                                <p:cTn id="77" presetID="10" presetClass="entr" presetSubtype="0" fill="hold" grpId="0" nodeType="withEffect">
+                                  <p:stCondLst>
+                                    <p:cond delay="450"/>
+                                  </p:stCondLst>
+                                  <p:childTnLst>
+                                    <p:set>
+                                      <p:cBhvr>
+                                        <p:cTn id="78" dur="1" fill="hold">
+                                          <p:stCondLst>
+                                            <p:cond delay="0"/>
+                                          </p:stCondLst>
+                                        </p:cTn>
+                                        <p:tgtEl>
+                                          <p:spTgt spid="25"/>
+                                        </p:tgtEl>
+                                        <p:attrNameLst>
+                                          <p:attrName>style.visibility</p:attrName>
+                                        </p:attrNameLst>
+                                      </p:cBhvr>
+                                      <p:to>
+                                        <p:strVal val="visible"/>
+                                      </p:to>
+                                    </p:set>
+                                    <p:animEffect transition="in" filter="fade">
+                                      <p:cBhvr>
+                                        <p:cTn id="79" dur="350"/>
+                                        <p:tgtEl>
+                                          <p:spTgt spid="25"/>
+                                        </p:tgtEl>
+                                      </p:cBhvr>
+                                    </p:animEffect>
+                                  </p:childTnLst>
+                                </p:cTn>
+                              </p:par>
+                              <p:par>
+                                <p:cTn id="80" presetID="10" presetClass="entr" presetSubtype="0" fill="hold" grpId="0" nodeType="withEffect">
+                                  <p:stCondLst>
+                                    <p:cond delay="650"/>
+                                  </p:stCondLst>
+                                  <p:childTnLst>
+                                    <p:set>
+                                      <p:cBhvr>
+                                        <p:cTn id="81" dur="1" fill="hold">
+                                          <p:stCondLst>
+                                            <p:cond delay="0"/>
+                                          </p:stCondLst>
+                                        </p:cTn>
+                                        <p:tgtEl>
+                                          <p:spTgt spid="26"/>
+                                        </p:tgtEl>
+                                        <p:attrNameLst>
+                                          <p:attrName>style.visibility</p:attrName>
+                                        </p:attrNameLst>
+                                      </p:cBhvr>
+                                      <p:to>
+                                        <p:strVal val="visible"/>
+                                      </p:to>
+                                    </p:set>
+                                    <p:animEffect transition="in" filter="fade">
+                                      <p:cBhvr>
+                                        <p:cTn id="82" dur="350"/>
+                                        <p:tgtEl>
+                                          <p:spTgt spid="26"/>
+                                        </p:tgtEl>
+                                      </p:cBhvr>
+                                    </p:animEffect>
+                                  </p:childTnLst>
+                                </p:cTn>
+                              </p:par>
+                              <p:par>
+                                <p:cTn id="83" presetID="10" presetClass="entr" presetSubtype="0" fill="hold" grpId="0" nodeType="withEffect">
+                                  <p:stCondLst>
+                                    <p:cond delay="650"/>
+                                  </p:stCondLst>
+                                  <p:childTnLst>
+                                    <p:set>
+                                      <p:cBhvr>
+                                        <p:cTn id="84" dur="1" fill="hold">
+                                          <p:stCondLst>
+                                            <p:cond delay="0"/>
+                                          </p:stCondLst>
+                                        </p:cTn>
+                                        <p:tgtEl>
+                                          <p:spTgt spid="27"/>
+                                        </p:tgtEl>
+                                        <p:attrNameLst>
+                                          <p:attrName>style.visibility</p:attrName>
+                                        </p:attrNameLst>
+                                      </p:cBhvr>
+                                      <p:to>
+                                        <p:strVal val="visible"/>
+                                      </p:to>
+                                    </p:set>
+                                    <p:animEffect transition="in" filter="fade">
+                                      <p:cBhvr>
+                                        <p:cTn id="85" dur="350"/>
+                                        <p:tgtEl>
+                                          <p:spTgt spid="27"/>
+                                        </p:tgtEl>
+                                      </p:cBhvr>
+                                    </p:animEffect>
+                                  </p:childTnLst>
+                                </p:cTn>
+                              </p:par>
+                              <p:par>
+                                <p:cTn id="86" presetID="10" presetClass="entr" presetSubtype="0" fill="hold" grpId="0" nodeType="withEffect">
+                                  <p:stCondLst>
+                                    <p:cond delay="650"/>
+                                  </p:stCondLst>
+                                  <p:childTnLst>
+                                    <p:set>
+                                      <p:cBhvr>
+                                        <p:cTn id="87" dur="1" fill="hold">
+                                          <p:stCondLst>
+                                            <p:cond delay="0"/>
+                                          </p:stCondLst>
+                                        </p:cTn>
+                                        <p:tgtEl>
+                                          <p:spTgt spid="28"/>
+                                        </p:tgtEl>
+                                        <p:attrNameLst>
+                                          <p:attrName>style.visibility</p:attrName>
+                                        </p:attrNameLst>
+                                      </p:cBhvr>
+                                      <p:to>
+                                        <p:strVal val="visible"/>
+                                      </p:to>
+                                    </p:set>
+                                    <p:animEffect transition="in" filter="fade">
+                                      <p:cBhvr>
+                                        <p:cTn id="88" dur="350"/>
+                                        <p:tgtEl>
+                                          <p:spTgt spid="28"/>
+                                        </p:tgtEl>
+                                      </p:cBhvr>
+                                    </p:animEffect>
+                                  </p:childTnLst>
+                                </p:cTn>
+                              </p:par>
+                            </p:childTnLst>
+                          </p:cTn>
+                        </p:par>
+                      </p:childTnLst>
+                    </p:cTn>
+                  </p:par>
+                </p:childTnLst>
+              </p:cTn>
+              <p:prevCondLst>
+                <p:cond evt="onPrev" delay="0">
+                  <p:tgtEl>
+                    <p:sldTgt/>
+                  </p:tgtEl>
+                </p:cond>
+              </p:prevCondLst>
+              <p:nextCondLst>
+                <p:cond evt="onNext" delay="0">
+                  <p:tgtEl>
+                    <p:sldTgt/>
+                  </p:tgtEl>
+                </p:cond>
+              </p:nextCondLst>
+            </p:seq>
+          </p:childTnLst>
+        </p:cTn>
+      </p:par>
+    </p:tnLst>
+  </p:timing>
 </p:sld>
 </file>
 
@@ -28438,6 +32270,404 @@
       </p:transition>
     </mc:Fallback>
   </mc:AlternateContent>
+  <p:timing>
+    <p:tnLst>
+      <p:par>
+        <p:cTn id="1" dur="indefinite" restart="never" nodeType="tmRoot">
+          <p:childTnLst>
+            <p:seq concurrent="1" nextAc="seek">
+              <p:cTn id="2" dur="indefinite" nodeType="mainSeq">
+                <p:childTnLst>
+                  <p:par>
+                    <p:cTn id="3" fill="hold">
+                      <p:stCondLst>
+                        <p:cond delay="0"/>
+                      </p:stCondLst>
+                      <p:childTnLst>
+                        <p:par>
+                          <p:cTn id="4" fill="hold">
+                            <p:stCondLst>
+                              <p:cond delay="0"/>
+                            </p:stCondLst>
+                            <p:childTnLst>
+                              <p:par>
+                                <p:cTn id="5" presetID="10" presetClass="entr" presetSubtype="0" fill="hold" grpId="0" nodeType="withEffect">
+                                  <p:stCondLst>
+                                    <p:cond delay="0"/>
+                                  </p:stCondLst>
+                                  <p:childTnLst>
+                                    <p:set>
+                                      <p:cBhvr>
+                                        <p:cTn id="6" dur="1" fill="hold">
+                                          <p:stCondLst>
+                                            <p:cond delay="0"/>
+                                          </p:stCondLst>
+                                        </p:cTn>
+                                        <p:tgtEl>
+                                          <p:spTgt spid="4"/>
+                                        </p:tgtEl>
+                                        <p:attrNameLst>
+                                          <p:attrName>style.visibility</p:attrName>
+                                        </p:attrNameLst>
+                                      </p:cBhvr>
+                                      <p:to>
+                                        <p:strVal val="visible"/>
+                                      </p:to>
+                                    </p:set>
+                                    <p:animEffect transition="in" filter="fade">
+                                      <p:cBhvr>
+                                        <p:cTn id="7" dur="450"/>
+                                        <p:tgtEl>
+                                          <p:spTgt spid="4"/>
+                                        </p:tgtEl>
+                                      </p:cBhvr>
+                                    </p:animEffect>
+                                  </p:childTnLst>
+                                </p:cTn>
+                              </p:par>
+                              <p:par>
+                                <p:cTn id="8" presetID="10" presetClass="entr" presetSubtype="0" fill="hold" grpId="0" nodeType="withEffect">
+                                  <p:stCondLst>
+                                    <p:cond delay="0"/>
+                                  </p:stCondLst>
+                                  <p:childTnLst>
+                                    <p:set>
+                                      <p:cBhvr>
+                                        <p:cTn id="9" dur="1" fill="hold">
+                                          <p:stCondLst>
+                                            <p:cond delay="0"/>
+                                          </p:stCondLst>
+                                        </p:cTn>
+                                        <p:tgtEl>
+                                          <p:spTgt spid="5"/>
+                                        </p:tgtEl>
+                                        <p:attrNameLst>
+                                          <p:attrName>style.visibility</p:attrName>
+                                        </p:attrNameLst>
+                                      </p:cBhvr>
+                                      <p:to>
+                                        <p:strVal val="visible"/>
+                                      </p:to>
+                                    </p:set>
+                                    <p:animEffect transition="in" filter="fade">
+                                      <p:cBhvr>
+                                        <p:cTn id="10" dur="450"/>
+                                        <p:tgtEl>
+                                          <p:spTgt spid="5"/>
+                                        </p:tgtEl>
+                                      </p:cBhvr>
+                                    </p:animEffect>
+                                  </p:childTnLst>
+                                </p:cTn>
+                              </p:par>
+                              <p:par>
+                                <p:cTn id="11" presetID="10" presetClass="entr" presetSubtype="0" fill="hold" grpId="0" nodeType="withEffect">
+                                  <p:stCondLst>
+                                    <p:cond delay="0"/>
+                                  </p:stCondLst>
+                                  <p:childTnLst>
+                                    <p:set>
+                                      <p:cBhvr>
+                                        <p:cTn id="12" dur="1" fill="hold">
+                                          <p:stCondLst>
+                                            <p:cond delay="0"/>
+                                          </p:stCondLst>
+                                        </p:cTn>
+                                        <p:tgtEl>
+                                          <p:spTgt spid="6"/>
+                                        </p:tgtEl>
+                                        <p:attrNameLst>
+                                          <p:attrName>style.visibility</p:attrName>
+                                        </p:attrNameLst>
+                                      </p:cBhvr>
+                                      <p:to>
+                                        <p:strVal val="visible"/>
+                                      </p:to>
+                                    </p:set>
+                                    <p:animEffect transition="in" filter="fade">
+                                      <p:cBhvr>
+                                        <p:cTn id="13" dur="450"/>
+                                        <p:tgtEl>
+                                          <p:spTgt spid="6"/>
+                                        </p:tgtEl>
+                                      </p:cBhvr>
+                                    </p:animEffect>
+                                  </p:childTnLst>
+                                </p:cTn>
+                              </p:par>
+                              <p:par>
+                                <p:cTn id="14" presetID="10" presetClass="entr" presetSubtype="0" fill="hold" grpId="0" nodeType="withEffect">
+                                  <p:stCondLst>
+                                    <p:cond delay="180"/>
+                                  </p:stCondLst>
+                                  <p:childTnLst>
+                                    <p:set>
+                                      <p:cBhvr>
+                                        <p:cTn id="15" dur="1" fill="hold">
+                                          <p:stCondLst>
+                                            <p:cond delay="0"/>
+                                          </p:stCondLst>
+                                        </p:cTn>
+                                        <p:tgtEl>
+                                          <p:spTgt spid="7"/>
+                                        </p:tgtEl>
+                                        <p:attrNameLst>
+                                          <p:attrName>style.visibility</p:attrName>
+                                        </p:attrNameLst>
+                                      </p:cBhvr>
+                                      <p:to>
+                                        <p:strVal val="visible"/>
+                                      </p:to>
+                                    </p:set>
+                                    <p:animEffect transition="in" filter="fade">
+                                      <p:cBhvr>
+                                        <p:cTn id="16" dur="450"/>
+                                        <p:tgtEl>
+                                          <p:spTgt spid="7"/>
+                                        </p:tgtEl>
+                                      </p:cBhvr>
+                                    </p:animEffect>
+                                  </p:childTnLst>
+                                </p:cTn>
+                              </p:par>
+                              <p:par>
+                                <p:cTn id="17" presetID="10" presetClass="entr" presetSubtype="0" fill="hold" grpId="0" nodeType="withEffect">
+                                  <p:stCondLst>
+                                    <p:cond delay="180"/>
+                                  </p:stCondLst>
+                                  <p:childTnLst>
+                                    <p:set>
+                                      <p:cBhvr>
+                                        <p:cTn id="18" dur="1" fill="hold">
+                                          <p:stCondLst>
+                                            <p:cond delay="0"/>
+                                          </p:stCondLst>
+                                        </p:cTn>
+                                        <p:tgtEl>
+                                          <p:spTgt spid="8"/>
+                                        </p:tgtEl>
+                                        <p:attrNameLst>
+                                          <p:attrName>style.visibility</p:attrName>
+                                        </p:attrNameLst>
+                                      </p:cBhvr>
+                                      <p:to>
+                                        <p:strVal val="visible"/>
+                                      </p:to>
+                                    </p:set>
+                                    <p:animEffect transition="in" filter="fade">
+                                      <p:cBhvr>
+                                        <p:cTn id="19" dur="450"/>
+                                        <p:tgtEl>
+                                          <p:spTgt spid="8"/>
+                                        </p:tgtEl>
+                                      </p:cBhvr>
+                                    </p:animEffect>
+                                  </p:childTnLst>
+                                </p:cTn>
+                              </p:par>
+                              <p:par>
+                                <p:cTn id="20" presetID="10" presetClass="entr" presetSubtype="0" fill="hold" grpId="0" nodeType="withEffect">
+                                  <p:stCondLst>
+                                    <p:cond delay="180"/>
+                                  </p:stCondLst>
+                                  <p:childTnLst>
+                                    <p:set>
+                                      <p:cBhvr>
+                                        <p:cTn id="21" dur="1" fill="hold">
+                                          <p:stCondLst>
+                                            <p:cond delay="0"/>
+                                          </p:stCondLst>
+                                        </p:cTn>
+                                        <p:tgtEl>
+                                          <p:spTgt spid="9"/>
+                                        </p:tgtEl>
+                                        <p:attrNameLst>
+                                          <p:attrName>style.visibility</p:attrName>
+                                        </p:attrNameLst>
+                                      </p:cBhvr>
+                                      <p:to>
+                                        <p:strVal val="visible"/>
+                                      </p:to>
+                                    </p:set>
+                                    <p:animEffect transition="in" filter="fade">
+                                      <p:cBhvr>
+                                        <p:cTn id="22" dur="450"/>
+                                        <p:tgtEl>
+                                          <p:spTgt spid="9"/>
+                                        </p:tgtEl>
+                                      </p:cBhvr>
+                                    </p:animEffect>
+                                  </p:childTnLst>
+                                </p:cTn>
+                              </p:par>
+                              <p:par>
+                                <p:cTn id="23" presetID="10" presetClass="entr" presetSubtype="0" fill="hold" grpId="0" nodeType="withEffect">
+                                  <p:stCondLst>
+                                    <p:cond delay="360"/>
+                                  </p:stCondLst>
+                                  <p:childTnLst>
+                                    <p:set>
+                                      <p:cBhvr>
+                                        <p:cTn id="24" dur="1" fill="hold">
+                                          <p:stCondLst>
+                                            <p:cond delay="0"/>
+                                          </p:stCondLst>
+                                        </p:cTn>
+                                        <p:tgtEl>
+                                          <p:spTgt spid="10"/>
+                                        </p:tgtEl>
+                                        <p:attrNameLst>
+                                          <p:attrName>style.visibility</p:attrName>
+                                        </p:attrNameLst>
+                                      </p:cBhvr>
+                                      <p:to>
+                                        <p:strVal val="visible"/>
+                                      </p:to>
+                                    </p:set>
+                                    <p:animEffect transition="in" filter="fade">
+                                      <p:cBhvr>
+                                        <p:cTn id="25" dur="450"/>
+                                        <p:tgtEl>
+                                          <p:spTgt spid="10"/>
+                                        </p:tgtEl>
+                                      </p:cBhvr>
+                                    </p:animEffect>
+                                  </p:childTnLst>
+                                </p:cTn>
+                              </p:par>
+                              <p:par>
+                                <p:cTn id="26" presetID="10" presetClass="entr" presetSubtype="0" fill="hold" grpId="0" nodeType="withEffect">
+                                  <p:stCondLst>
+                                    <p:cond delay="360"/>
+                                  </p:stCondLst>
+                                  <p:childTnLst>
+                                    <p:set>
+                                      <p:cBhvr>
+                                        <p:cTn id="27" dur="1" fill="hold">
+                                          <p:stCondLst>
+                                            <p:cond delay="0"/>
+                                          </p:stCondLst>
+                                        </p:cTn>
+                                        <p:tgtEl>
+                                          <p:spTgt spid="11"/>
+                                        </p:tgtEl>
+                                        <p:attrNameLst>
+                                          <p:attrName>style.visibility</p:attrName>
+                                        </p:attrNameLst>
+                                      </p:cBhvr>
+                                      <p:to>
+                                        <p:strVal val="visible"/>
+                                      </p:to>
+                                    </p:set>
+                                    <p:animEffect transition="in" filter="fade">
+                                      <p:cBhvr>
+                                        <p:cTn id="28" dur="450"/>
+                                        <p:tgtEl>
+                                          <p:spTgt spid="11"/>
+                                        </p:tgtEl>
+                                      </p:cBhvr>
+                                    </p:animEffect>
+                                  </p:childTnLst>
+                                </p:cTn>
+                              </p:par>
+                              <p:par>
+                                <p:cTn id="29" presetID="10" presetClass="entr" presetSubtype="0" fill="hold" grpId="0" nodeType="withEffect">
+                                  <p:stCondLst>
+                                    <p:cond delay="360"/>
+                                  </p:stCondLst>
+                                  <p:childTnLst>
+                                    <p:set>
+                                      <p:cBhvr>
+                                        <p:cTn id="30" dur="1" fill="hold">
+                                          <p:stCondLst>
+                                            <p:cond delay="0"/>
+                                          </p:stCondLst>
+                                        </p:cTn>
+                                        <p:tgtEl>
+                                          <p:spTgt spid="12"/>
+                                        </p:tgtEl>
+                                        <p:attrNameLst>
+                                          <p:attrName>style.visibility</p:attrName>
+                                        </p:attrNameLst>
+                                      </p:cBhvr>
+                                      <p:to>
+                                        <p:strVal val="visible"/>
+                                      </p:to>
+                                    </p:set>
+                                    <p:animEffect transition="in" filter="fade">
+                                      <p:cBhvr>
+                                        <p:cTn id="31" dur="450"/>
+                                        <p:tgtEl>
+                                          <p:spTgt spid="12"/>
+                                        </p:tgtEl>
+                                      </p:cBhvr>
+                                    </p:animEffect>
+                                  </p:childTnLst>
+                                </p:cTn>
+                              </p:par>
+                              <p:par>
+                                <p:cTn id="32" presetID="10" presetClass="entr" presetSubtype="0" fill="hold" grpId="0" nodeType="withEffect">
+                                  <p:stCondLst>
+                                    <p:cond delay="750"/>
+                                  </p:stCondLst>
+                                  <p:childTnLst>
+                                    <p:set>
+                                      <p:cBhvr>
+                                        <p:cTn id="33" dur="1" fill="hold">
+                                          <p:stCondLst>
+                                            <p:cond delay="0"/>
+                                          </p:stCondLst>
+                                        </p:cTn>
+                                        <p:tgtEl>
+                                          <p:spTgt spid="13"/>
+                                        </p:tgtEl>
+                                        <p:attrNameLst>
+                                          <p:attrName>style.visibility</p:attrName>
+                                        </p:attrNameLst>
+                                      </p:cBhvr>
+                                      <p:to>
+                                        <p:strVal val="visible"/>
+                                      </p:to>
+                                    </p:set>
+                                    <p:animEffect transition="in" filter="fade">
+                                      <p:cBhvr>
+                                        <p:cTn id="34" dur="500"/>
+                                        <p:tgtEl>
+                                          <p:spTgt spid="13"/>
+                                        </p:tgtEl>
+                                      </p:cBhvr>
+                                    </p:animEffect>
+                                  </p:childTnLst>
+                                </p:cTn>
+                              </p:par>
+                            </p:childTnLst>
+                          </p:cTn>
+                        </p:par>
+                      </p:childTnLst>
+                    </p:cTn>
+                  </p:par>
+                </p:childTnLst>
+              </p:cTn>
+              <p:prevCondLst>
+                <p:cond evt="onPrev" delay="0">
+                  <p:tgtEl>
+                    <p:sldTgt/>
+                  </p:tgtEl>
+                </p:cond>
+              </p:prevCondLst>
+              <p:nextCondLst>
+                <p:cond evt="onNext" delay="0">
+                  <p:tgtEl>
+                    <p:sldTgt/>
+                  </p:tgtEl>
+                </p:cond>
+              </p:nextCondLst>
+            </p:seq>
+          </p:childTnLst>
+        </p:cTn>
+      </p:par>
+    </p:tnLst>
+  </p:timing>
 </p:sld>
 </file>
 

</xml_diff>